<commit_message>
design: add To-Be swimlane process-flow slide (board + deck)
Adds a 4th 16:9 slide — a swimlane business-process flow of the proposed (To-Be)
journey (lanes: Client, Clinician, Sona app&AI, External) with task boxes, a
triage decision, start/end terminators and connectors. Helps frame As-Is vs
To-Be and drives prototypes/screens. Page numbers updated to /4.

https://claude.ai/code/session_015v7JWiWTXQN2Qco9pisXZ1
</commit_message>
<xml_diff>
--- a/docs/design/Sona_Care_Journey_Deck.pptx
+++ b/docs/design/Sona_Care_Journey_Deck.pptx
@@ -8,6 +8,7 @@
     <p:sldId id="256" r:id="rId7"/>
     <p:sldId id="257" r:id="rId8"/>
     <p:sldId id="258" r:id="rId9"/>
+    <p:sldId id="259" r:id="rId10"/>
   </p:sldIdLst>
   <p:sldSz cx="12192000" cy="6858000" type="screen4x3"/>
   <p:notesSz cx="6858000" cy="9144000"/>
@@ -3505,7 +3506,7 @@
         <p:spPr>
           <a:xfrm>
             <a:off x="6388100" y="2286000"/>
-            <a:ext cx="5080000" cy="2794000"/>
+            <a:ext cx="5080000" cy="2921000"/>
           </a:xfrm>
           <a:prstGeom prst="rect">
             <a:avLst/>
@@ -3530,7 +3531,7 @@
                 </a:solidFill>
                 <a:latin typeface="Inter"/>
               </a:rPr>
-              <a:t>•  Two views follow — the Executive view (the journey and the value) and the Product view (the proposed solution, phase by phase).</a:t>
+              <a:t>•  Three views follow — the Executive view (the journey and the value), the Product view (the proposed solution), and the Process-flow view (the To-Be swimlane).</a:t>
             </a:r>
           </a:p>
           <a:p>
@@ -3887,7 +3888,7 @@
                 </a:solidFill>
                 <a:latin typeface="Inter"/>
               </a:rPr>
-              <a:t>1 / 3</a:t>
+              <a:t>1 / 4</a:t>
             </a:r>
           </a:p>
         </p:txBody>
@@ -5984,7 +5985,7 @@
                 </a:solidFill>
                 <a:latin typeface="Inter"/>
               </a:rPr>
-              <a:t>2 / 3</a:t>
+              <a:t>2 / 4</a:t>
             </a:r>
           </a:p>
         </p:txBody>
@@ -9581,7 +9582,2951 @@
                 </a:solidFill>
                 <a:latin typeface="Inter"/>
               </a:rPr>
-              <a:t>3 / 3</a:t>
+              <a:t>3 / 4</a:t>
+            </a:r>
+          </a:p>
+        </p:txBody>
+      </p:sp>
+    </p:spTree>
+  </p:cSld>
+  <p:clrMapOvr>
+    <a:masterClrMapping/>
+  </p:clrMapOvr>
+</p:sld>
+</file>
+
+<file path=ppt/slides/slide4.xml><?xml version="1.0" encoding="utf-8"?>
+<p:sld xmlns:a="http://schemas.openxmlformats.org/drawingml/2006/main" xmlns:p="http://schemas.openxmlformats.org/presentationml/2006/main" xmlns:r="http://schemas.openxmlformats.org/officeDocument/2006/relationships">
+  <p:cSld>
+    <p:spTree>
+      <p:nvGrpSpPr>
+        <p:cNvPr id="1" name=""/>
+        <p:cNvGrpSpPr/>
+        <p:nvPr/>
+      </p:nvGrpSpPr>
+      <p:grpSpPr/>
+      <p:sp>
+        <p:nvSpPr>
+          <p:cNvPr id="2" name="Rectangle 1"/>
+          <p:cNvSpPr/>
+          <p:nvPr/>
+        </p:nvSpPr>
+        <p:spPr>
+          <a:xfrm>
+            <a:off x="0" y="0"/>
+            <a:ext cx="12192000" cy="6858000"/>
+          </a:xfrm>
+          <a:prstGeom prst="rect">
+            <a:avLst/>
+          </a:prstGeom>
+          <a:solidFill>
+            <a:srgbClr val="FAFAF7"/>
+          </a:solidFill>
+          <a:ln>
+            <a:noFill/>
+          </a:ln>
+          <a:effectLst/>
+        </p:spPr>
+        <p:style>
+          <a:lnRef idx="1">
+            <a:schemeClr val="accent1"/>
+          </a:lnRef>
+          <a:fillRef idx="3">
+            <a:schemeClr val="accent1"/>
+          </a:fillRef>
+          <a:effectRef idx="2">
+            <a:schemeClr val="accent1"/>
+          </a:effectRef>
+          <a:fontRef idx="minor">
+            <a:schemeClr val="lt1"/>
+          </a:fontRef>
+        </p:style>
+        <p:txBody>
+          <a:bodyPr rtlCol="0" anchor="ctr"/>
+          <a:lstStyle/>
+          <a:p>
+            <a:pPr algn="ctr"/>
+          </a:p>
+        </p:txBody>
+      </p:sp>
+      <p:sp>
+        <p:nvSpPr>
+          <p:cNvPr id="3" name="TextBox 2"/>
+          <p:cNvSpPr txBox="1"/>
+          <p:nvPr/>
+        </p:nvSpPr>
+        <p:spPr>
+          <a:xfrm>
+            <a:off x="571500" y="406400"/>
+            <a:ext cx="5715000" cy="165100"/>
+          </a:xfrm>
+          <a:prstGeom prst="rect">
+            <a:avLst/>
+          </a:prstGeom>
+          <a:noFill/>
+        </p:spPr>
+        <p:txBody>
+          <a:bodyPr wrap="square" anchor="t" lIns="25400" rIns="25400" tIns="12700" bIns="12700">
+            <a:spAutoFit/>
+          </a:bodyPr>
+          <a:lstStyle/>
+          <a:p>
+            <a:pPr algn="l">
+              <a:spcAft>
+                <a:spcPts val="0"/>
+              </a:spcAft>
+            </a:pPr>
+            <a:r>
+              <a:rPr sz="750" b="1">
+                <a:solidFill>
+                  <a:srgbClr val="8597A4"/>
+                </a:solidFill>
+                <a:latin typeface="Inter"/>
+              </a:rPr>
+              <a:t>PROCESS FLOW · TO-BE</a:t>
+            </a:r>
+          </a:p>
+        </p:txBody>
+      </p:sp>
+      <p:sp>
+        <p:nvSpPr>
+          <p:cNvPr id="4" name="TextBox 3"/>
+          <p:cNvSpPr txBox="1"/>
+          <p:nvPr/>
+        </p:nvSpPr>
+        <p:spPr>
+          <a:xfrm>
+            <a:off x="571500" y="571500"/>
+            <a:ext cx="9525000" cy="381000"/>
+          </a:xfrm>
+          <a:prstGeom prst="rect">
+            <a:avLst/>
+          </a:prstGeom>
+          <a:noFill/>
+        </p:spPr>
+        <p:txBody>
+          <a:bodyPr wrap="square" anchor="t" lIns="25400" rIns="25400" tIns="12700" bIns="12700">
+            <a:spAutoFit/>
+          </a:bodyPr>
+          <a:lstStyle/>
+          <a:p>
+            <a:pPr algn="l">
+              <a:spcAft>
+                <a:spcPts val="0"/>
+              </a:spcAft>
+            </a:pPr>
+            <a:r>
+              <a:rPr sz="2000" b="1">
+                <a:solidFill>
+                  <a:srgbClr val="2D6A6E"/>
+                </a:solidFill>
+                <a:latin typeface="Inter"/>
+              </a:rPr>
+              <a:t>How the journey runs with Sona</a:t>
+            </a:r>
+          </a:p>
+        </p:txBody>
+      </p:sp>
+      <p:sp>
+        <p:nvSpPr>
+          <p:cNvPr id="5" name="TextBox 4"/>
+          <p:cNvSpPr txBox="1"/>
+          <p:nvPr/>
+        </p:nvSpPr>
+        <p:spPr>
+          <a:xfrm>
+            <a:off x="571500" y="1003300"/>
+            <a:ext cx="10922000" cy="317500"/>
+          </a:xfrm>
+          <a:prstGeom prst="rect">
+            <a:avLst/>
+          </a:prstGeom>
+          <a:noFill/>
+        </p:spPr>
+        <p:txBody>
+          <a:bodyPr wrap="square" anchor="t" lIns="25400" rIns="25400" tIns="12700" bIns="12700">
+            <a:spAutoFit/>
+          </a:bodyPr>
+          <a:lstStyle/>
+          <a:p>
+            <a:pPr algn="l">
+              <a:spcAft>
+                <a:spcPts val="0"/>
+              </a:spcAft>
+            </a:pPr>
+            <a:r>
+              <a:rPr sz="900" b="0">
+                <a:solidFill>
+                  <a:srgbClr val="4A5B6B"/>
+                </a:solidFill>
+                <a:latin typeface="Inter"/>
+              </a:rPr>
+              <a:t>A swimlane map of the proposed (To-Be) process — read against today's As-Is to spot what to optimise, and use it to design the prototypes and screens.</a:t>
+            </a:r>
+          </a:p>
+        </p:txBody>
+      </p:sp>
+      <p:sp>
+        <p:nvSpPr>
+          <p:cNvPr id="6" name="Rectangle 5"/>
+          <p:cNvSpPr/>
+          <p:nvPr/>
+        </p:nvSpPr>
+        <p:spPr>
+          <a:xfrm>
+            <a:off x="1371600" y="1473200"/>
+            <a:ext cx="10439400" cy="1244600"/>
+          </a:xfrm>
+          <a:prstGeom prst="rect">
+            <a:avLst/>
+          </a:prstGeom>
+          <a:solidFill>
+            <a:srgbClr val="FFFFFF"/>
+          </a:solidFill>
+          <a:ln w="12700">
+            <a:solidFill>
+              <a:srgbClr val="E5E7EB"/>
+            </a:solidFill>
+          </a:ln>
+          <a:effectLst/>
+        </p:spPr>
+        <p:style>
+          <a:lnRef idx="1">
+            <a:schemeClr val="accent1"/>
+          </a:lnRef>
+          <a:fillRef idx="3">
+            <a:schemeClr val="accent1"/>
+          </a:fillRef>
+          <a:effectRef idx="2">
+            <a:schemeClr val="accent1"/>
+          </a:effectRef>
+          <a:fontRef idx="minor">
+            <a:schemeClr val="lt1"/>
+          </a:fontRef>
+        </p:style>
+        <p:txBody>
+          <a:bodyPr rtlCol="0" anchor="ctr"/>
+          <a:lstStyle/>
+          <a:p>
+            <a:pPr algn="ctr"/>
+          </a:p>
+        </p:txBody>
+      </p:sp>
+      <p:sp>
+        <p:nvSpPr>
+          <p:cNvPr id="7" name="Rectangle 6"/>
+          <p:cNvSpPr/>
+          <p:nvPr/>
+        </p:nvSpPr>
+        <p:spPr>
+          <a:xfrm>
+            <a:off x="381000" y="1473200"/>
+            <a:ext cx="990599" cy="1244600"/>
+          </a:xfrm>
+          <a:prstGeom prst="rect">
+            <a:avLst/>
+          </a:prstGeom>
+          <a:solidFill>
+            <a:srgbClr val="C98A5E"/>
+          </a:solidFill>
+          <a:ln>
+            <a:noFill/>
+          </a:ln>
+          <a:effectLst/>
+        </p:spPr>
+        <p:style>
+          <a:lnRef idx="1">
+            <a:schemeClr val="accent1"/>
+          </a:lnRef>
+          <a:fillRef idx="3">
+            <a:schemeClr val="accent1"/>
+          </a:fillRef>
+          <a:effectRef idx="2">
+            <a:schemeClr val="accent1"/>
+          </a:effectRef>
+          <a:fontRef idx="minor">
+            <a:schemeClr val="lt1"/>
+          </a:fontRef>
+        </p:style>
+        <p:txBody>
+          <a:bodyPr rtlCol="0" anchor="ctr"/>
+          <a:lstStyle/>
+          <a:p>
+            <a:pPr algn="ctr"/>
+          </a:p>
+        </p:txBody>
+      </p:sp>
+      <p:sp>
+        <p:nvSpPr>
+          <p:cNvPr id="8" name="TextBox 7"/>
+          <p:cNvSpPr txBox="1"/>
+          <p:nvPr/>
+        </p:nvSpPr>
+        <p:spPr>
+          <a:xfrm rot="16200000">
+            <a:off x="381000" y="1473200"/>
+            <a:ext cx="990599" cy="1244600"/>
+          </a:xfrm>
+          <a:prstGeom prst="rect">
+            <a:avLst/>
+          </a:prstGeom>
+          <a:noFill/>
+        </p:spPr>
+        <p:txBody>
+          <a:bodyPr wrap="square" anchor="ctr">
+            <a:spAutoFit/>
+          </a:bodyPr>
+          <a:lstStyle/>
+          <a:p>
+            <a:pPr algn="ctr"/>
+            <a:r>
+              <a:rPr sz="700" b="1">
+                <a:solidFill>
+                  <a:srgbClr val="FFFFFF"/>
+                </a:solidFill>
+                <a:latin typeface="Inter"/>
+              </a:rPr>
+              <a:t>Client / Parent / Carer</a:t>
+            </a:r>
+          </a:p>
+        </p:txBody>
+      </p:sp>
+      <p:sp>
+        <p:nvSpPr>
+          <p:cNvPr id="9" name="Rectangle 8"/>
+          <p:cNvSpPr/>
+          <p:nvPr/>
+        </p:nvSpPr>
+        <p:spPr>
+          <a:xfrm>
+            <a:off x="1371600" y="2717800"/>
+            <a:ext cx="10439400" cy="1244600"/>
+          </a:xfrm>
+          <a:prstGeom prst="rect">
+            <a:avLst/>
+          </a:prstGeom>
+          <a:solidFill>
+            <a:srgbClr val="F3F6F6"/>
+          </a:solidFill>
+          <a:ln w="12700">
+            <a:solidFill>
+              <a:srgbClr val="E5E7EB"/>
+            </a:solidFill>
+          </a:ln>
+          <a:effectLst/>
+        </p:spPr>
+        <p:style>
+          <a:lnRef idx="1">
+            <a:schemeClr val="accent1"/>
+          </a:lnRef>
+          <a:fillRef idx="3">
+            <a:schemeClr val="accent1"/>
+          </a:fillRef>
+          <a:effectRef idx="2">
+            <a:schemeClr val="accent1"/>
+          </a:effectRef>
+          <a:fontRef idx="minor">
+            <a:schemeClr val="lt1"/>
+          </a:fontRef>
+        </p:style>
+        <p:txBody>
+          <a:bodyPr rtlCol="0" anchor="ctr"/>
+          <a:lstStyle/>
+          <a:p>
+            <a:pPr algn="ctr"/>
+          </a:p>
+        </p:txBody>
+      </p:sp>
+      <p:sp>
+        <p:nvSpPr>
+          <p:cNvPr id="10" name="Rectangle 9"/>
+          <p:cNvSpPr/>
+          <p:nvPr/>
+        </p:nvSpPr>
+        <p:spPr>
+          <a:xfrm>
+            <a:off x="381000" y="2717800"/>
+            <a:ext cx="990599" cy="1244600"/>
+          </a:xfrm>
+          <a:prstGeom prst="rect">
+            <a:avLst/>
+          </a:prstGeom>
+          <a:solidFill>
+            <a:srgbClr val="2D6A6E"/>
+          </a:solidFill>
+          <a:ln>
+            <a:noFill/>
+          </a:ln>
+          <a:effectLst/>
+        </p:spPr>
+        <p:style>
+          <a:lnRef idx="1">
+            <a:schemeClr val="accent1"/>
+          </a:lnRef>
+          <a:fillRef idx="3">
+            <a:schemeClr val="accent1"/>
+          </a:fillRef>
+          <a:effectRef idx="2">
+            <a:schemeClr val="accent1"/>
+          </a:effectRef>
+          <a:fontRef idx="minor">
+            <a:schemeClr val="lt1"/>
+          </a:fontRef>
+        </p:style>
+        <p:txBody>
+          <a:bodyPr rtlCol="0" anchor="ctr"/>
+          <a:lstStyle/>
+          <a:p>
+            <a:pPr algn="ctr"/>
+          </a:p>
+        </p:txBody>
+      </p:sp>
+      <p:sp>
+        <p:nvSpPr>
+          <p:cNvPr id="11" name="TextBox 10"/>
+          <p:cNvSpPr txBox="1"/>
+          <p:nvPr/>
+        </p:nvSpPr>
+        <p:spPr>
+          <a:xfrm rot="16200000">
+            <a:off x="381000" y="2717800"/>
+            <a:ext cx="990599" cy="1244600"/>
+          </a:xfrm>
+          <a:prstGeom prst="rect">
+            <a:avLst/>
+          </a:prstGeom>
+          <a:noFill/>
+        </p:spPr>
+        <p:txBody>
+          <a:bodyPr wrap="square" anchor="ctr">
+            <a:spAutoFit/>
+          </a:bodyPr>
+          <a:lstStyle/>
+          <a:p>
+            <a:pPr algn="ctr"/>
+            <a:r>
+              <a:rPr sz="700" b="1">
+                <a:solidFill>
+                  <a:srgbClr val="FFFFFF"/>
+                </a:solidFill>
+                <a:latin typeface="Inter"/>
+              </a:rPr>
+              <a:t>Clinician / SLT</a:t>
+            </a:r>
+          </a:p>
+        </p:txBody>
+      </p:sp>
+      <p:sp>
+        <p:nvSpPr>
+          <p:cNvPr id="12" name="Rectangle 11"/>
+          <p:cNvSpPr/>
+          <p:nvPr/>
+        </p:nvSpPr>
+        <p:spPr>
+          <a:xfrm>
+            <a:off x="1371600" y="3962399"/>
+            <a:ext cx="10439400" cy="1244600"/>
+          </a:xfrm>
+          <a:prstGeom prst="rect">
+            <a:avLst/>
+          </a:prstGeom>
+          <a:solidFill>
+            <a:srgbClr val="FFFFFF"/>
+          </a:solidFill>
+          <a:ln w="12700">
+            <a:solidFill>
+              <a:srgbClr val="E5E7EB"/>
+            </a:solidFill>
+          </a:ln>
+          <a:effectLst/>
+        </p:spPr>
+        <p:style>
+          <a:lnRef idx="1">
+            <a:schemeClr val="accent1"/>
+          </a:lnRef>
+          <a:fillRef idx="3">
+            <a:schemeClr val="accent1"/>
+          </a:fillRef>
+          <a:effectRef idx="2">
+            <a:schemeClr val="accent1"/>
+          </a:effectRef>
+          <a:fontRef idx="minor">
+            <a:schemeClr val="lt1"/>
+          </a:fontRef>
+        </p:style>
+        <p:txBody>
+          <a:bodyPr rtlCol="0" anchor="ctr"/>
+          <a:lstStyle/>
+          <a:p>
+            <a:pPr algn="ctr"/>
+          </a:p>
+        </p:txBody>
+      </p:sp>
+      <p:sp>
+        <p:nvSpPr>
+          <p:cNvPr id="13" name="Rectangle 12"/>
+          <p:cNvSpPr/>
+          <p:nvPr/>
+        </p:nvSpPr>
+        <p:spPr>
+          <a:xfrm>
+            <a:off x="381000" y="3962399"/>
+            <a:ext cx="990599" cy="1244600"/>
+          </a:xfrm>
+          <a:prstGeom prst="rect">
+            <a:avLst/>
+          </a:prstGeom>
+          <a:solidFill>
+            <a:srgbClr val="356985"/>
+          </a:solidFill>
+          <a:ln>
+            <a:noFill/>
+          </a:ln>
+          <a:effectLst/>
+        </p:spPr>
+        <p:style>
+          <a:lnRef idx="1">
+            <a:schemeClr val="accent1"/>
+          </a:lnRef>
+          <a:fillRef idx="3">
+            <a:schemeClr val="accent1"/>
+          </a:fillRef>
+          <a:effectRef idx="2">
+            <a:schemeClr val="accent1"/>
+          </a:effectRef>
+          <a:fontRef idx="minor">
+            <a:schemeClr val="lt1"/>
+          </a:fontRef>
+        </p:style>
+        <p:txBody>
+          <a:bodyPr rtlCol="0" anchor="ctr"/>
+          <a:lstStyle/>
+          <a:p>
+            <a:pPr algn="ctr"/>
+          </a:p>
+        </p:txBody>
+      </p:sp>
+      <p:sp>
+        <p:nvSpPr>
+          <p:cNvPr id="14" name="TextBox 13"/>
+          <p:cNvSpPr txBox="1"/>
+          <p:nvPr/>
+        </p:nvSpPr>
+        <p:spPr>
+          <a:xfrm rot="16200000">
+            <a:off x="381000" y="3962399"/>
+            <a:ext cx="990599" cy="1244600"/>
+          </a:xfrm>
+          <a:prstGeom prst="rect">
+            <a:avLst/>
+          </a:prstGeom>
+          <a:noFill/>
+        </p:spPr>
+        <p:txBody>
+          <a:bodyPr wrap="square" anchor="ctr">
+            <a:spAutoFit/>
+          </a:bodyPr>
+          <a:lstStyle/>
+          <a:p>
+            <a:pPr algn="ctr"/>
+            <a:r>
+              <a:rPr sz="700" b="1">
+                <a:solidFill>
+                  <a:srgbClr val="FFFFFF"/>
+                </a:solidFill>
+                <a:latin typeface="Inter"/>
+              </a:rPr>
+              <a:t>Sona  (app &amp; AI)</a:t>
+            </a:r>
+          </a:p>
+        </p:txBody>
+      </p:sp>
+      <p:sp>
+        <p:nvSpPr>
+          <p:cNvPr id="15" name="Rectangle 14"/>
+          <p:cNvSpPr/>
+          <p:nvPr/>
+        </p:nvSpPr>
+        <p:spPr>
+          <a:xfrm>
+            <a:off x="1371600" y="5207000"/>
+            <a:ext cx="10439400" cy="1244600"/>
+          </a:xfrm>
+          <a:prstGeom prst="rect">
+            <a:avLst/>
+          </a:prstGeom>
+          <a:solidFill>
+            <a:srgbClr val="F3F6F6"/>
+          </a:solidFill>
+          <a:ln w="12700">
+            <a:solidFill>
+              <a:srgbClr val="E5E7EB"/>
+            </a:solidFill>
+          </a:ln>
+          <a:effectLst/>
+        </p:spPr>
+        <p:style>
+          <a:lnRef idx="1">
+            <a:schemeClr val="accent1"/>
+          </a:lnRef>
+          <a:fillRef idx="3">
+            <a:schemeClr val="accent1"/>
+          </a:fillRef>
+          <a:effectRef idx="2">
+            <a:schemeClr val="accent1"/>
+          </a:effectRef>
+          <a:fontRef idx="minor">
+            <a:schemeClr val="lt1"/>
+          </a:fontRef>
+        </p:style>
+        <p:txBody>
+          <a:bodyPr rtlCol="0" anchor="ctr"/>
+          <a:lstStyle/>
+          <a:p>
+            <a:pPr algn="ctr"/>
+          </a:p>
+        </p:txBody>
+      </p:sp>
+      <p:sp>
+        <p:nvSpPr>
+          <p:cNvPr id="16" name="Rectangle 15"/>
+          <p:cNvSpPr/>
+          <p:nvPr/>
+        </p:nvSpPr>
+        <p:spPr>
+          <a:xfrm>
+            <a:off x="381000" y="5207000"/>
+            <a:ext cx="990599" cy="1244600"/>
+          </a:xfrm>
+          <a:prstGeom prst="rect">
+            <a:avLst/>
+          </a:prstGeom>
+          <a:solidFill>
+            <a:srgbClr val="4C8060"/>
+          </a:solidFill>
+          <a:ln>
+            <a:noFill/>
+          </a:ln>
+          <a:effectLst/>
+        </p:spPr>
+        <p:style>
+          <a:lnRef idx="1">
+            <a:schemeClr val="accent1"/>
+          </a:lnRef>
+          <a:fillRef idx="3">
+            <a:schemeClr val="accent1"/>
+          </a:fillRef>
+          <a:effectRef idx="2">
+            <a:schemeClr val="accent1"/>
+          </a:effectRef>
+          <a:fontRef idx="minor">
+            <a:schemeClr val="lt1"/>
+          </a:fontRef>
+        </p:style>
+        <p:txBody>
+          <a:bodyPr rtlCol="0" anchor="ctr"/>
+          <a:lstStyle/>
+          <a:p>
+            <a:pPr algn="ctr"/>
+          </a:p>
+        </p:txBody>
+      </p:sp>
+      <p:sp>
+        <p:nvSpPr>
+          <p:cNvPr id="17" name="TextBox 16"/>
+          <p:cNvSpPr txBox="1"/>
+          <p:nvPr/>
+        </p:nvSpPr>
+        <p:spPr>
+          <a:xfrm rot="16200000">
+            <a:off x="381000" y="5207000"/>
+            <a:ext cx="990599" cy="1244600"/>
+          </a:xfrm>
+          <a:prstGeom prst="rect">
+            <a:avLst/>
+          </a:prstGeom>
+          <a:noFill/>
+        </p:spPr>
+        <p:txBody>
+          <a:bodyPr wrap="square" anchor="ctr">
+            <a:spAutoFit/>
+          </a:bodyPr>
+          <a:lstStyle/>
+          <a:p>
+            <a:pPr algn="ctr"/>
+            <a:r>
+              <a:rPr sz="700" b="1">
+                <a:solidFill>
+                  <a:srgbClr val="FFFFFF"/>
+                </a:solidFill>
+                <a:latin typeface="Inter"/>
+              </a:rPr>
+              <a:t>External  (calendar · PMS)</a:t>
+            </a:r>
+          </a:p>
+        </p:txBody>
+      </p:sp>
+      <p:sp>
+        <p:nvSpPr>
+          <p:cNvPr id="18" name="Rounded Rectangle 17"/>
+          <p:cNvSpPr/>
+          <p:nvPr/>
+        </p:nvSpPr>
+        <p:spPr>
+          <a:xfrm>
+            <a:off x="1397000" y="1866899"/>
+            <a:ext cx="1016000" cy="457200"/>
+          </a:xfrm>
+          <a:prstGeom prst="roundRect">
+            <a:avLst>
+              <a:gd name="adj" fmla="val 50000"/>
+            </a:avLst>
+          </a:prstGeom>
+          <a:solidFill>
+            <a:srgbClr val="FBF7F1"/>
+          </a:solidFill>
+          <a:ln w="12700">
+            <a:solidFill>
+              <a:srgbClr val="C98A5E"/>
+            </a:solidFill>
+          </a:ln>
+          <a:effectLst/>
+        </p:spPr>
+        <p:style>
+          <a:lnRef idx="1">
+            <a:schemeClr val="accent1"/>
+          </a:lnRef>
+          <a:fillRef idx="3">
+            <a:schemeClr val="accent1"/>
+          </a:fillRef>
+          <a:effectRef idx="2">
+            <a:schemeClr val="accent1"/>
+          </a:effectRef>
+          <a:fontRef idx="minor">
+            <a:schemeClr val="lt1"/>
+          </a:fontRef>
+        </p:style>
+        <p:txBody>
+          <a:bodyPr rtlCol="0" anchor="ctr"/>
+          <a:lstStyle/>
+          <a:p>
+            <a:pPr algn="ctr"/>
+          </a:p>
+        </p:txBody>
+      </p:sp>
+      <p:sp>
+        <p:nvSpPr>
+          <p:cNvPr id="19" name="TextBox 18"/>
+          <p:cNvSpPr txBox="1"/>
+          <p:nvPr/>
+        </p:nvSpPr>
+        <p:spPr>
+          <a:xfrm>
+            <a:off x="1460500" y="1866899"/>
+            <a:ext cx="889000" cy="457200"/>
+          </a:xfrm>
+          <a:prstGeom prst="rect">
+            <a:avLst/>
+          </a:prstGeom>
+          <a:noFill/>
+        </p:spPr>
+        <p:txBody>
+          <a:bodyPr wrap="square" anchor="ctr" lIns="25400" rIns="25400" tIns="12700" bIns="12700">
+            <a:normAutofit/>
+          </a:bodyPr>
+          <a:lstStyle/>
+          <a:p>
+            <a:pPr algn="ctr">
+              <a:spcAft>
+                <a:spcPts val="0"/>
+              </a:spcAft>
+            </a:pPr>
+            <a:r>
+              <a:rPr sz="625" b="1">
+                <a:solidFill>
+                  <a:srgbClr val="142433"/>
+                </a:solidFill>
+                <a:latin typeface="Inter"/>
+              </a:rPr>
+              <a:t>Enquiry arrives</a:t>
+            </a:r>
+          </a:p>
+        </p:txBody>
+      </p:sp>
+      <p:sp>
+        <p:nvSpPr>
+          <p:cNvPr id="20" name="Rounded Rectangle 19"/>
+          <p:cNvSpPr/>
+          <p:nvPr/>
+        </p:nvSpPr>
+        <p:spPr>
+          <a:xfrm>
+            <a:off x="1397000" y="4362450"/>
+            <a:ext cx="1016000" cy="444500"/>
+          </a:xfrm>
+          <a:prstGeom prst="roundRect">
+            <a:avLst>
+              <a:gd name="adj" fmla="val 17142"/>
+            </a:avLst>
+          </a:prstGeom>
+          <a:solidFill>
+            <a:srgbClr val="E6F0F0"/>
+          </a:solidFill>
+          <a:ln w="12700">
+            <a:solidFill>
+              <a:srgbClr val="2D6A6E"/>
+            </a:solidFill>
+          </a:ln>
+          <a:effectLst/>
+        </p:spPr>
+        <p:style>
+          <a:lnRef idx="1">
+            <a:schemeClr val="accent1"/>
+          </a:lnRef>
+          <a:fillRef idx="3">
+            <a:schemeClr val="accent1"/>
+          </a:fillRef>
+          <a:effectRef idx="2">
+            <a:schemeClr val="accent1"/>
+          </a:effectRef>
+          <a:fontRef idx="minor">
+            <a:schemeClr val="lt1"/>
+          </a:fontRef>
+        </p:style>
+        <p:txBody>
+          <a:bodyPr rtlCol="0" anchor="ctr"/>
+          <a:lstStyle/>
+          <a:p>
+            <a:pPr algn="ctr"/>
+          </a:p>
+        </p:txBody>
+      </p:sp>
+      <p:sp>
+        <p:nvSpPr>
+          <p:cNvPr id="21" name="TextBox 20"/>
+          <p:cNvSpPr txBox="1"/>
+          <p:nvPr/>
+        </p:nvSpPr>
+        <p:spPr>
+          <a:xfrm>
+            <a:off x="1460500" y="4362450"/>
+            <a:ext cx="889000" cy="444500"/>
+          </a:xfrm>
+          <a:prstGeom prst="rect">
+            <a:avLst/>
+          </a:prstGeom>
+          <a:noFill/>
+        </p:spPr>
+        <p:txBody>
+          <a:bodyPr wrap="square" anchor="ctr" lIns="25400" rIns="25400" tIns="12700" bIns="12700">
+            <a:normAutofit/>
+          </a:bodyPr>
+          <a:lstStyle/>
+          <a:p>
+            <a:pPr algn="ctr">
+              <a:spcAft>
+                <a:spcPts val="0"/>
+              </a:spcAft>
+            </a:pPr>
+            <a:r>
+              <a:rPr sz="625" b="0">
+                <a:solidFill>
+                  <a:srgbClr val="142433"/>
+                </a:solidFill>
+                <a:latin typeface="Inter"/>
+              </a:rPr>
+              <a:t>Capture enquiry + smart intake</a:t>
+            </a:r>
+          </a:p>
+        </p:txBody>
+      </p:sp>
+      <p:sp>
+        <p:nvSpPr>
+          <p:cNvPr id="22" name="Rounded Rectangle 21"/>
+          <p:cNvSpPr/>
+          <p:nvPr/>
+        </p:nvSpPr>
+        <p:spPr>
+          <a:xfrm>
+            <a:off x="2362200" y="1873250"/>
+            <a:ext cx="1016000" cy="444500"/>
+          </a:xfrm>
+          <a:prstGeom prst="roundRect">
+            <a:avLst>
+              <a:gd name="adj" fmla="val 17142"/>
+            </a:avLst>
+          </a:prstGeom>
+          <a:solidFill>
+            <a:srgbClr val="E6F0F0"/>
+          </a:solidFill>
+          <a:ln w="12700">
+            <a:solidFill>
+              <a:srgbClr val="2D6A6E"/>
+            </a:solidFill>
+          </a:ln>
+          <a:effectLst/>
+        </p:spPr>
+        <p:style>
+          <a:lnRef idx="1">
+            <a:schemeClr val="accent1"/>
+          </a:lnRef>
+          <a:fillRef idx="3">
+            <a:schemeClr val="accent1"/>
+          </a:fillRef>
+          <a:effectRef idx="2">
+            <a:schemeClr val="accent1"/>
+          </a:effectRef>
+          <a:fontRef idx="minor">
+            <a:schemeClr val="lt1"/>
+          </a:fontRef>
+        </p:style>
+        <p:txBody>
+          <a:bodyPr rtlCol="0" anchor="ctr"/>
+          <a:lstStyle/>
+          <a:p>
+            <a:pPr algn="ctr"/>
+          </a:p>
+        </p:txBody>
+      </p:sp>
+      <p:sp>
+        <p:nvSpPr>
+          <p:cNvPr id="23" name="TextBox 22"/>
+          <p:cNvSpPr txBox="1"/>
+          <p:nvPr/>
+        </p:nvSpPr>
+        <p:spPr>
+          <a:xfrm>
+            <a:off x="2425700" y="1873250"/>
+            <a:ext cx="889000" cy="444500"/>
+          </a:xfrm>
+          <a:prstGeom prst="rect">
+            <a:avLst/>
+          </a:prstGeom>
+          <a:noFill/>
+        </p:spPr>
+        <p:txBody>
+          <a:bodyPr wrap="square" anchor="ctr" lIns="25400" rIns="25400" tIns="12700" bIns="12700">
+            <a:normAutofit/>
+          </a:bodyPr>
+          <a:lstStyle/>
+          <a:p>
+            <a:pPr algn="ctr">
+              <a:spcAft>
+                <a:spcPts val="0"/>
+              </a:spcAft>
+            </a:pPr>
+            <a:r>
+              <a:rPr sz="625" b="0">
+                <a:solidFill>
+                  <a:srgbClr val="142433"/>
+                </a:solidFill>
+                <a:latin typeface="Inter"/>
+              </a:rPr>
+              <a:t>Complete intake &amp; consent</a:t>
+            </a:r>
+          </a:p>
+        </p:txBody>
+      </p:sp>
+      <p:sp>
+        <p:nvSpPr>
+          <p:cNvPr id="24" name="Rounded Rectangle 23"/>
+          <p:cNvSpPr/>
+          <p:nvPr/>
+        </p:nvSpPr>
+        <p:spPr>
+          <a:xfrm>
+            <a:off x="3327400" y="4362450"/>
+            <a:ext cx="1016000" cy="444500"/>
+          </a:xfrm>
+          <a:prstGeom prst="roundRect">
+            <a:avLst>
+              <a:gd name="adj" fmla="val 17142"/>
+            </a:avLst>
+          </a:prstGeom>
+          <a:solidFill>
+            <a:srgbClr val="E6F0F0"/>
+          </a:solidFill>
+          <a:ln w="12700">
+            <a:solidFill>
+              <a:srgbClr val="2D6A6E"/>
+            </a:solidFill>
+          </a:ln>
+          <a:effectLst/>
+        </p:spPr>
+        <p:style>
+          <a:lnRef idx="1">
+            <a:schemeClr val="accent1"/>
+          </a:lnRef>
+          <a:fillRef idx="3">
+            <a:schemeClr val="accent1"/>
+          </a:fillRef>
+          <a:effectRef idx="2">
+            <a:schemeClr val="accent1"/>
+          </a:effectRef>
+          <a:fontRef idx="minor">
+            <a:schemeClr val="lt1"/>
+          </a:fontRef>
+        </p:style>
+        <p:txBody>
+          <a:bodyPr rtlCol="0" anchor="ctr"/>
+          <a:lstStyle/>
+          <a:p>
+            <a:pPr algn="ctr"/>
+          </a:p>
+        </p:txBody>
+      </p:sp>
+      <p:sp>
+        <p:nvSpPr>
+          <p:cNvPr id="25" name="TextBox 24"/>
+          <p:cNvSpPr txBox="1"/>
+          <p:nvPr/>
+        </p:nvSpPr>
+        <p:spPr>
+          <a:xfrm>
+            <a:off x="3390900" y="4362450"/>
+            <a:ext cx="889000" cy="444500"/>
+          </a:xfrm>
+          <a:prstGeom prst="rect">
+            <a:avLst/>
+          </a:prstGeom>
+          <a:noFill/>
+        </p:spPr>
+        <p:txBody>
+          <a:bodyPr wrap="square" anchor="ctr" lIns="25400" rIns="25400" tIns="12700" bIns="12700">
+            <a:normAutofit/>
+          </a:bodyPr>
+          <a:lstStyle/>
+          <a:p>
+            <a:pPr algn="ctr">
+              <a:spcAft>
+                <a:spcPts val="0"/>
+              </a:spcAft>
+            </a:pPr>
+            <a:r>
+              <a:rPr sz="625" b="0">
+                <a:solidFill>
+                  <a:srgbClr val="142433"/>
+                </a:solidFill>
+                <a:latin typeface="Inter"/>
+              </a:rPr>
+              <a:t>AI prep brief (DRAFT)</a:t>
+            </a:r>
+          </a:p>
+        </p:txBody>
+      </p:sp>
+      <p:sp>
+        <p:nvSpPr>
+          <p:cNvPr id="26" name="Rounded Rectangle 25"/>
+          <p:cNvSpPr/>
+          <p:nvPr/>
+        </p:nvSpPr>
+        <p:spPr>
+          <a:xfrm>
+            <a:off x="4292600" y="3117850"/>
+            <a:ext cx="1016000" cy="444500"/>
+          </a:xfrm>
+          <a:prstGeom prst="roundRect">
+            <a:avLst>
+              <a:gd name="adj" fmla="val 17142"/>
+            </a:avLst>
+          </a:prstGeom>
+          <a:solidFill>
+            <a:srgbClr val="E6F0F0"/>
+          </a:solidFill>
+          <a:ln w="12700">
+            <a:solidFill>
+              <a:srgbClr val="2D6A6E"/>
+            </a:solidFill>
+          </a:ln>
+          <a:effectLst/>
+        </p:spPr>
+        <p:style>
+          <a:lnRef idx="1">
+            <a:schemeClr val="accent1"/>
+          </a:lnRef>
+          <a:fillRef idx="3">
+            <a:schemeClr val="accent1"/>
+          </a:fillRef>
+          <a:effectRef idx="2">
+            <a:schemeClr val="accent1"/>
+          </a:effectRef>
+          <a:fontRef idx="minor">
+            <a:schemeClr val="lt1"/>
+          </a:fontRef>
+        </p:style>
+        <p:txBody>
+          <a:bodyPr rtlCol="0" anchor="ctr"/>
+          <a:lstStyle/>
+          <a:p>
+            <a:pPr algn="ctr"/>
+          </a:p>
+        </p:txBody>
+      </p:sp>
+      <p:sp>
+        <p:nvSpPr>
+          <p:cNvPr id="27" name="TextBox 26"/>
+          <p:cNvSpPr txBox="1"/>
+          <p:nvPr/>
+        </p:nvSpPr>
+        <p:spPr>
+          <a:xfrm>
+            <a:off x="4356100" y="3117850"/>
+            <a:ext cx="889000" cy="444500"/>
+          </a:xfrm>
+          <a:prstGeom prst="rect">
+            <a:avLst/>
+          </a:prstGeom>
+          <a:noFill/>
+        </p:spPr>
+        <p:txBody>
+          <a:bodyPr wrap="square" anchor="ctr" lIns="25400" rIns="25400" tIns="12700" bIns="12700">
+            <a:normAutofit/>
+          </a:bodyPr>
+          <a:lstStyle/>
+          <a:p>
+            <a:pPr algn="ctr">
+              <a:spcAft>
+                <a:spcPts val="0"/>
+              </a:spcAft>
+            </a:pPr>
+            <a:r>
+              <a:rPr sz="625" b="0">
+                <a:solidFill>
+                  <a:srgbClr val="142433"/>
+                </a:solidFill>
+                <a:latin typeface="Inter"/>
+              </a:rPr>
+              <a:t>Review overview + prep</a:t>
+            </a:r>
+          </a:p>
+        </p:txBody>
+      </p:sp>
+      <p:sp>
+        <p:nvSpPr>
+          <p:cNvPr id="28" name="Rounded Rectangle 27"/>
+          <p:cNvSpPr/>
+          <p:nvPr/>
+        </p:nvSpPr>
+        <p:spPr>
+          <a:xfrm>
+            <a:off x="4292600" y="5607050"/>
+            <a:ext cx="1016000" cy="444500"/>
+          </a:xfrm>
+          <a:prstGeom prst="roundRect">
+            <a:avLst>
+              <a:gd name="adj" fmla="val 17142"/>
+            </a:avLst>
+          </a:prstGeom>
+          <a:solidFill>
+            <a:srgbClr val="E6F0F0"/>
+          </a:solidFill>
+          <a:ln w="12700">
+            <a:solidFill>
+              <a:srgbClr val="2D6A6E"/>
+            </a:solidFill>
+          </a:ln>
+          <a:effectLst/>
+        </p:spPr>
+        <p:style>
+          <a:lnRef idx="1">
+            <a:schemeClr val="accent1"/>
+          </a:lnRef>
+          <a:fillRef idx="3">
+            <a:schemeClr val="accent1"/>
+          </a:fillRef>
+          <a:effectRef idx="2">
+            <a:schemeClr val="accent1"/>
+          </a:effectRef>
+          <a:fontRef idx="minor">
+            <a:schemeClr val="lt1"/>
+          </a:fontRef>
+        </p:style>
+        <p:txBody>
+          <a:bodyPr rtlCol="0" anchor="ctr"/>
+          <a:lstStyle/>
+          <a:p>
+            <a:pPr algn="ctr"/>
+          </a:p>
+        </p:txBody>
+      </p:sp>
+      <p:sp>
+        <p:nvSpPr>
+          <p:cNvPr id="29" name="TextBox 28"/>
+          <p:cNvSpPr txBox="1"/>
+          <p:nvPr/>
+        </p:nvSpPr>
+        <p:spPr>
+          <a:xfrm>
+            <a:off x="4356100" y="5607050"/>
+            <a:ext cx="889000" cy="444500"/>
+          </a:xfrm>
+          <a:prstGeom prst="rect">
+            <a:avLst/>
+          </a:prstGeom>
+          <a:noFill/>
+        </p:spPr>
+        <p:txBody>
+          <a:bodyPr wrap="square" anchor="ctr" lIns="25400" rIns="25400" tIns="12700" bIns="12700">
+            <a:normAutofit/>
+          </a:bodyPr>
+          <a:lstStyle/>
+          <a:p>
+            <a:pPr algn="ctr">
+              <a:spcAft>
+                <a:spcPts val="0"/>
+              </a:spcAft>
+            </a:pPr>
+            <a:r>
+              <a:rPr sz="625" b="0">
+                <a:solidFill>
+                  <a:srgbClr val="142433"/>
+                </a:solidFill>
+                <a:latin typeface="Inter"/>
+              </a:rPr>
+              <a:t>Calendar / video link</a:t>
+            </a:r>
+          </a:p>
+        </p:txBody>
+      </p:sp>
+      <p:sp>
+        <p:nvSpPr>
+          <p:cNvPr id="30" name="Rounded Rectangle 29"/>
+          <p:cNvSpPr/>
+          <p:nvPr/>
+        </p:nvSpPr>
+        <p:spPr>
+          <a:xfrm>
+            <a:off x="5257800" y="3117850"/>
+            <a:ext cx="1016000" cy="444500"/>
+          </a:xfrm>
+          <a:prstGeom prst="roundRect">
+            <a:avLst>
+              <a:gd name="adj" fmla="val 17142"/>
+            </a:avLst>
+          </a:prstGeom>
+          <a:solidFill>
+            <a:srgbClr val="E6F0F0"/>
+          </a:solidFill>
+          <a:ln w="12700">
+            <a:solidFill>
+              <a:srgbClr val="2D6A6E"/>
+            </a:solidFill>
+          </a:ln>
+          <a:effectLst/>
+        </p:spPr>
+        <p:style>
+          <a:lnRef idx="1">
+            <a:schemeClr val="accent1"/>
+          </a:lnRef>
+          <a:fillRef idx="3">
+            <a:schemeClr val="accent1"/>
+          </a:fillRef>
+          <a:effectRef idx="2">
+            <a:schemeClr val="accent1"/>
+          </a:effectRef>
+          <a:fontRef idx="minor">
+            <a:schemeClr val="lt1"/>
+          </a:fontRef>
+        </p:style>
+        <p:txBody>
+          <a:bodyPr rtlCol="0" anchor="ctr"/>
+          <a:lstStyle/>
+          <a:p>
+            <a:pPr algn="ctr"/>
+          </a:p>
+        </p:txBody>
+      </p:sp>
+      <p:sp>
+        <p:nvSpPr>
+          <p:cNvPr id="31" name="TextBox 30"/>
+          <p:cNvSpPr txBox="1"/>
+          <p:nvPr/>
+        </p:nvSpPr>
+        <p:spPr>
+          <a:xfrm>
+            <a:off x="5321300" y="3117850"/>
+            <a:ext cx="889000" cy="444500"/>
+          </a:xfrm>
+          <a:prstGeom prst="rect">
+            <a:avLst/>
+          </a:prstGeom>
+          <a:noFill/>
+        </p:spPr>
+        <p:txBody>
+          <a:bodyPr wrap="square" anchor="ctr" lIns="25400" rIns="25400" tIns="12700" bIns="12700">
+            <a:normAutofit/>
+          </a:bodyPr>
+          <a:lstStyle/>
+          <a:p>
+            <a:pPr algn="ctr">
+              <a:spcAft>
+                <a:spcPts val="0"/>
+              </a:spcAft>
+            </a:pPr>
+            <a:r>
+              <a:rPr sz="625" b="0">
+                <a:solidFill>
+                  <a:srgbClr val="142433"/>
+                </a:solidFill>
+                <a:latin typeface="Inter"/>
+              </a:rPr>
+              <a:t>Consultation (~20 min)</a:t>
+            </a:r>
+          </a:p>
+        </p:txBody>
+      </p:sp>
+      <p:sp>
+        <p:nvSpPr>
+          <p:cNvPr id="32" name="Diamond 31"/>
+          <p:cNvSpPr/>
+          <p:nvPr/>
+        </p:nvSpPr>
+        <p:spPr>
+          <a:xfrm>
+            <a:off x="6184900" y="3009900"/>
+            <a:ext cx="1092200" cy="660400"/>
+          </a:xfrm>
+          <a:prstGeom prst="diamond">
+            <a:avLst/>
+          </a:prstGeom>
+          <a:solidFill>
+            <a:srgbClr val="FFF0E6"/>
+          </a:solidFill>
+          <a:ln w="19050">
+            <a:solidFill>
+              <a:srgbClr val="C45A1A"/>
+            </a:solidFill>
+          </a:ln>
+          <a:effectLst/>
+        </p:spPr>
+        <p:style>
+          <a:lnRef idx="1">
+            <a:schemeClr val="accent1"/>
+          </a:lnRef>
+          <a:fillRef idx="3">
+            <a:schemeClr val="accent1"/>
+          </a:fillRef>
+          <a:effectRef idx="2">
+            <a:schemeClr val="accent1"/>
+          </a:effectRef>
+          <a:fontRef idx="minor">
+            <a:schemeClr val="lt1"/>
+          </a:fontRef>
+        </p:style>
+        <p:txBody>
+          <a:bodyPr rtlCol="0" anchor="ctr" wrap="square" lIns="38100" rIns="38100" tIns="12700" bIns="12700">
+            <a:normAutofit/>
+          </a:bodyPr>
+          <a:lstStyle/>
+          <a:p>
+            <a:pPr algn="ctr"/>
+            <a:r>
+              <a:rPr sz="625" b="1">
+                <a:solidFill>
+                  <a:srgbClr val="142433"/>
+                </a:solidFill>
+                <a:latin typeface="Inter"/>
+              </a:rPr>
+              <a:t>Ongoing therapy?</a:t>
+            </a:r>
+          </a:p>
+        </p:txBody>
+      </p:sp>
+      <p:sp>
+        <p:nvSpPr>
+          <p:cNvPr id="33" name="Rounded Rectangle 32"/>
+          <p:cNvSpPr/>
+          <p:nvPr/>
+        </p:nvSpPr>
+        <p:spPr>
+          <a:xfrm>
+            <a:off x="7188200" y="4362450"/>
+            <a:ext cx="1016000" cy="444500"/>
+          </a:xfrm>
+          <a:prstGeom prst="roundRect">
+            <a:avLst>
+              <a:gd name="adj" fmla="val 17142"/>
+            </a:avLst>
+          </a:prstGeom>
+          <a:solidFill>
+            <a:srgbClr val="E6F0F0"/>
+          </a:solidFill>
+          <a:ln w="12700">
+            <a:solidFill>
+              <a:srgbClr val="2D6A6E"/>
+            </a:solidFill>
+          </a:ln>
+          <a:effectLst/>
+        </p:spPr>
+        <p:style>
+          <a:lnRef idx="1">
+            <a:schemeClr val="accent1"/>
+          </a:lnRef>
+          <a:fillRef idx="3">
+            <a:schemeClr val="accent1"/>
+          </a:fillRef>
+          <a:effectRef idx="2">
+            <a:schemeClr val="accent1"/>
+          </a:effectRef>
+          <a:fontRef idx="minor">
+            <a:schemeClr val="lt1"/>
+          </a:fontRef>
+        </p:style>
+        <p:txBody>
+          <a:bodyPr rtlCol="0" anchor="ctr"/>
+          <a:lstStyle/>
+          <a:p>
+            <a:pPr algn="ctr"/>
+          </a:p>
+        </p:txBody>
+      </p:sp>
+      <p:sp>
+        <p:nvSpPr>
+          <p:cNvPr id="34" name="TextBox 33"/>
+          <p:cNvSpPr txBox="1"/>
+          <p:nvPr/>
+        </p:nvSpPr>
+        <p:spPr>
+          <a:xfrm>
+            <a:off x="7251700" y="4362450"/>
+            <a:ext cx="889000" cy="444500"/>
+          </a:xfrm>
+          <a:prstGeom prst="rect">
+            <a:avLst/>
+          </a:prstGeom>
+          <a:noFill/>
+        </p:spPr>
+        <p:txBody>
+          <a:bodyPr wrap="square" anchor="ctr" lIns="25400" rIns="25400" tIns="12700" bIns="12700">
+            <a:normAutofit/>
+          </a:bodyPr>
+          <a:lstStyle/>
+          <a:p>
+            <a:pPr algn="ctr">
+              <a:spcAft>
+                <a:spcPts val="0"/>
+              </a:spcAft>
+            </a:pPr>
+            <a:r>
+              <a:rPr sz="625" b="0">
+                <a:solidFill>
+                  <a:srgbClr val="142433"/>
+                </a:solidFill>
+                <a:latin typeface="Inter"/>
+              </a:rPr>
+              <a:t>AI session plan (DRAFT)</a:t>
+            </a:r>
+          </a:p>
+        </p:txBody>
+      </p:sp>
+      <p:sp>
+        <p:nvSpPr>
+          <p:cNvPr id="35" name="Rounded Rectangle 34"/>
+          <p:cNvSpPr/>
+          <p:nvPr/>
+        </p:nvSpPr>
+        <p:spPr>
+          <a:xfrm>
+            <a:off x="7188200" y="3117850"/>
+            <a:ext cx="1016000" cy="444500"/>
+          </a:xfrm>
+          <a:prstGeom prst="roundRect">
+            <a:avLst>
+              <a:gd name="adj" fmla="val 17142"/>
+            </a:avLst>
+          </a:prstGeom>
+          <a:solidFill>
+            <a:srgbClr val="E6F0F0"/>
+          </a:solidFill>
+          <a:ln w="12700">
+            <a:solidFill>
+              <a:srgbClr val="2D6A6E"/>
+            </a:solidFill>
+          </a:ln>
+          <a:effectLst/>
+        </p:spPr>
+        <p:style>
+          <a:lnRef idx="1">
+            <a:schemeClr val="accent1"/>
+          </a:lnRef>
+          <a:fillRef idx="3">
+            <a:schemeClr val="accent1"/>
+          </a:fillRef>
+          <a:effectRef idx="2">
+            <a:schemeClr val="accent1"/>
+          </a:effectRef>
+          <a:fontRef idx="minor">
+            <a:schemeClr val="lt1"/>
+          </a:fontRef>
+        </p:style>
+        <p:txBody>
+          <a:bodyPr rtlCol="0" anchor="ctr"/>
+          <a:lstStyle/>
+          <a:p>
+            <a:pPr algn="ctr"/>
+          </a:p>
+        </p:txBody>
+      </p:sp>
+      <p:sp>
+        <p:nvSpPr>
+          <p:cNvPr id="36" name="TextBox 35"/>
+          <p:cNvSpPr txBox="1"/>
+          <p:nvPr/>
+        </p:nvSpPr>
+        <p:spPr>
+          <a:xfrm>
+            <a:off x="7251700" y="3117850"/>
+            <a:ext cx="889000" cy="444500"/>
+          </a:xfrm>
+          <a:prstGeom prst="rect">
+            <a:avLst/>
+          </a:prstGeom>
+          <a:noFill/>
+        </p:spPr>
+        <p:txBody>
+          <a:bodyPr wrap="square" anchor="ctr" lIns="25400" rIns="25400" tIns="12700" bIns="12700">
+            <a:normAutofit/>
+          </a:bodyPr>
+          <a:lstStyle/>
+          <a:p>
+            <a:pPr algn="ctr">
+              <a:spcAft>
+                <a:spcPts val="0"/>
+              </a:spcAft>
+            </a:pPr>
+            <a:r>
+              <a:rPr sz="625" b="0">
+                <a:solidFill>
+                  <a:srgbClr val="142433"/>
+                </a:solidFill>
+                <a:latin typeface="Inter"/>
+              </a:rPr>
+              <a:t>Strategy advice &amp; home tips</a:t>
+            </a:r>
+          </a:p>
+        </p:txBody>
+      </p:sp>
+      <p:sp>
+        <p:nvSpPr>
+          <p:cNvPr id="37" name="Rounded Rectangle 36"/>
+          <p:cNvSpPr/>
+          <p:nvPr/>
+        </p:nvSpPr>
+        <p:spPr>
+          <a:xfrm>
+            <a:off x="8153399" y="3117850"/>
+            <a:ext cx="1016000" cy="444500"/>
+          </a:xfrm>
+          <a:prstGeom prst="roundRect">
+            <a:avLst>
+              <a:gd name="adj" fmla="val 17142"/>
+            </a:avLst>
+          </a:prstGeom>
+          <a:solidFill>
+            <a:srgbClr val="E6F0F0"/>
+          </a:solidFill>
+          <a:ln w="12700">
+            <a:solidFill>
+              <a:srgbClr val="2D6A6E"/>
+            </a:solidFill>
+          </a:ln>
+          <a:effectLst/>
+        </p:spPr>
+        <p:style>
+          <a:lnRef idx="1">
+            <a:schemeClr val="accent1"/>
+          </a:lnRef>
+          <a:fillRef idx="3">
+            <a:schemeClr val="accent1"/>
+          </a:fillRef>
+          <a:effectRef idx="2">
+            <a:schemeClr val="accent1"/>
+          </a:effectRef>
+          <a:fontRef idx="minor">
+            <a:schemeClr val="lt1"/>
+          </a:fontRef>
+        </p:style>
+        <p:txBody>
+          <a:bodyPr rtlCol="0" anchor="ctr"/>
+          <a:lstStyle/>
+          <a:p>
+            <a:pPr algn="ctr"/>
+          </a:p>
+        </p:txBody>
+      </p:sp>
+      <p:sp>
+        <p:nvSpPr>
+          <p:cNvPr id="38" name="TextBox 37"/>
+          <p:cNvSpPr txBox="1"/>
+          <p:nvPr/>
+        </p:nvSpPr>
+        <p:spPr>
+          <a:xfrm>
+            <a:off x="8216900" y="3117850"/>
+            <a:ext cx="889000" cy="444500"/>
+          </a:xfrm>
+          <a:prstGeom prst="rect">
+            <a:avLst/>
+          </a:prstGeom>
+          <a:noFill/>
+        </p:spPr>
+        <p:txBody>
+          <a:bodyPr wrap="square" anchor="ctr" lIns="25400" rIns="25400" tIns="12700" bIns="12700">
+            <a:normAutofit/>
+          </a:bodyPr>
+          <a:lstStyle/>
+          <a:p>
+            <a:pPr algn="ctr">
+              <a:spcAft>
+                <a:spcPts val="0"/>
+              </a:spcAft>
+            </a:pPr>
+            <a:r>
+              <a:rPr sz="625" b="0">
+                <a:solidFill>
+                  <a:srgbClr val="142433"/>
+                </a:solidFill>
+                <a:latin typeface="Inter"/>
+              </a:rPr>
+              <a:t>Edit &amp; sign plan</a:t>
+            </a:r>
+          </a:p>
+        </p:txBody>
+      </p:sp>
+      <p:sp>
+        <p:nvSpPr>
+          <p:cNvPr id="39" name="Rounded Rectangle 38"/>
+          <p:cNvSpPr/>
+          <p:nvPr/>
+        </p:nvSpPr>
+        <p:spPr>
+          <a:xfrm>
+            <a:off x="9118600" y="4362450"/>
+            <a:ext cx="1016000" cy="444500"/>
+          </a:xfrm>
+          <a:prstGeom prst="roundRect">
+            <a:avLst>
+              <a:gd name="adj" fmla="val 17142"/>
+            </a:avLst>
+          </a:prstGeom>
+          <a:solidFill>
+            <a:srgbClr val="E6F0F0"/>
+          </a:solidFill>
+          <a:ln w="12700">
+            <a:solidFill>
+              <a:srgbClr val="2D6A6E"/>
+            </a:solidFill>
+          </a:ln>
+          <a:effectLst/>
+        </p:spPr>
+        <p:style>
+          <a:lnRef idx="1">
+            <a:schemeClr val="accent1"/>
+          </a:lnRef>
+          <a:fillRef idx="3">
+            <a:schemeClr val="accent1"/>
+          </a:fillRef>
+          <a:effectRef idx="2">
+            <a:schemeClr val="accent1"/>
+          </a:effectRef>
+          <a:fontRef idx="minor">
+            <a:schemeClr val="lt1"/>
+          </a:fontRef>
+        </p:style>
+        <p:txBody>
+          <a:bodyPr rtlCol="0" anchor="ctr"/>
+          <a:lstStyle/>
+          <a:p>
+            <a:pPr algn="ctr"/>
+          </a:p>
+        </p:txBody>
+      </p:sp>
+      <p:sp>
+        <p:nvSpPr>
+          <p:cNvPr id="40" name="TextBox 39"/>
+          <p:cNvSpPr txBox="1"/>
+          <p:nvPr/>
+        </p:nvSpPr>
+        <p:spPr>
+          <a:xfrm>
+            <a:off x="9182100" y="4362450"/>
+            <a:ext cx="889000" cy="444500"/>
+          </a:xfrm>
+          <a:prstGeom prst="rect">
+            <a:avLst/>
+          </a:prstGeom>
+          <a:noFill/>
+        </p:spPr>
+        <p:txBody>
+          <a:bodyPr wrap="square" anchor="ctr" lIns="25400" rIns="25400" tIns="12700" bIns="12700">
+            <a:normAutofit/>
+          </a:bodyPr>
+          <a:lstStyle/>
+          <a:p>
+            <a:pPr algn="ctr">
+              <a:spcAft>
+                <a:spcPts val="0"/>
+              </a:spcAft>
+            </a:pPr>
+            <a:r>
+              <a:rPr sz="625" b="0">
+                <a:solidFill>
+                  <a:srgbClr val="142433"/>
+                </a:solidFill>
+                <a:latin typeface="Inter"/>
+              </a:rPr>
+              <a:t>AI family summary (DRAFT)</a:t>
+            </a:r>
+          </a:p>
+        </p:txBody>
+      </p:sp>
+      <p:sp>
+        <p:nvSpPr>
+          <p:cNvPr id="41" name="Rounded Rectangle 40"/>
+          <p:cNvSpPr/>
+          <p:nvPr/>
+        </p:nvSpPr>
+        <p:spPr>
+          <a:xfrm>
+            <a:off x="10083800" y="3117850"/>
+            <a:ext cx="1016000" cy="444500"/>
+          </a:xfrm>
+          <a:prstGeom prst="roundRect">
+            <a:avLst>
+              <a:gd name="adj" fmla="val 17142"/>
+            </a:avLst>
+          </a:prstGeom>
+          <a:solidFill>
+            <a:srgbClr val="E6F0F0"/>
+          </a:solidFill>
+          <a:ln w="12700">
+            <a:solidFill>
+              <a:srgbClr val="2D6A6E"/>
+            </a:solidFill>
+          </a:ln>
+          <a:effectLst/>
+        </p:spPr>
+        <p:style>
+          <a:lnRef idx="1">
+            <a:schemeClr val="accent1"/>
+          </a:lnRef>
+          <a:fillRef idx="3">
+            <a:schemeClr val="accent1"/>
+          </a:fillRef>
+          <a:effectRef idx="2">
+            <a:schemeClr val="accent1"/>
+          </a:effectRef>
+          <a:fontRef idx="minor">
+            <a:schemeClr val="lt1"/>
+          </a:fontRef>
+        </p:style>
+        <p:txBody>
+          <a:bodyPr rtlCol="0" anchor="ctr"/>
+          <a:lstStyle/>
+          <a:p>
+            <a:pPr algn="ctr"/>
+          </a:p>
+        </p:txBody>
+      </p:sp>
+      <p:sp>
+        <p:nvSpPr>
+          <p:cNvPr id="42" name="TextBox 41"/>
+          <p:cNvSpPr txBox="1"/>
+          <p:nvPr/>
+        </p:nvSpPr>
+        <p:spPr>
+          <a:xfrm>
+            <a:off x="10147300" y="3117850"/>
+            <a:ext cx="889000" cy="444500"/>
+          </a:xfrm>
+          <a:prstGeom prst="rect">
+            <a:avLst/>
+          </a:prstGeom>
+          <a:noFill/>
+        </p:spPr>
+        <p:txBody>
+          <a:bodyPr wrap="square" anchor="ctr" lIns="25400" rIns="25400" tIns="12700" bIns="12700">
+            <a:normAutofit/>
+          </a:bodyPr>
+          <a:lstStyle/>
+          <a:p>
+            <a:pPr algn="ctr">
+              <a:spcAft>
+                <a:spcPts val="0"/>
+              </a:spcAft>
+            </a:pPr>
+            <a:r>
+              <a:rPr sz="625" b="0">
+                <a:solidFill>
+                  <a:srgbClr val="142433"/>
+                </a:solidFill>
+                <a:latin typeface="Inter"/>
+              </a:rPr>
+              <a:t>Review &amp; send summary</a:t>
+            </a:r>
+          </a:p>
+        </p:txBody>
+      </p:sp>
+      <p:sp>
+        <p:nvSpPr>
+          <p:cNvPr id="43" name="Rounded Rectangle 42"/>
+          <p:cNvSpPr/>
+          <p:nvPr/>
+        </p:nvSpPr>
+        <p:spPr>
+          <a:xfrm>
+            <a:off x="9626600" y="1873250"/>
+            <a:ext cx="1016000" cy="444500"/>
+          </a:xfrm>
+          <a:prstGeom prst="roundRect">
+            <a:avLst>
+              <a:gd name="adj" fmla="val 17142"/>
+            </a:avLst>
+          </a:prstGeom>
+          <a:solidFill>
+            <a:srgbClr val="E6F0F0"/>
+          </a:solidFill>
+          <a:ln w="12700">
+            <a:solidFill>
+              <a:srgbClr val="2D6A6E"/>
+            </a:solidFill>
+          </a:ln>
+          <a:effectLst/>
+        </p:spPr>
+        <p:style>
+          <a:lnRef idx="1">
+            <a:schemeClr val="accent1"/>
+          </a:lnRef>
+          <a:fillRef idx="3">
+            <a:schemeClr val="accent1"/>
+          </a:fillRef>
+          <a:effectRef idx="2">
+            <a:schemeClr val="accent1"/>
+          </a:effectRef>
+          <a:fontRef idx="minor">
+            <a:schemeClr val="lt1"/>
+          </a:fontRef>
+        </p:style>
+        <p:txBody>
+          <a:bodyPr rtlCol="0" anchor="ctr"/>
+          <a:lstStyle/>
+          <a:p>
+            <a:pPr algn="ctr"/>
+          </a:p>
+        </p:txBody>
+      </p:sp>
+      <p:sp>
+        <p:nvSpPr>
+          <p:cNvPr id="44" name="TextBox 43"/>
+          <p:cNvSpPr txBox="1"/>
+          <p:nvPr/>
+        </p:nvSpPr>
+        <p:spPr>
+          <a:xfrm>
+            <a:off x="9690100" y="1873250"/>
+            <a:ext cx="889000" cy="444500"/>
+          </a:xfrm>
+          <a:prstGeom prst="rect">
+            <a:avLst/>
+          </a:prstGeom>
+          <a:noFill/>
+        </p:spPr>
+        <p:txBody>
+          <a:bodyPr wrap="square" anchor="ctr" lIns="25400" rIns="25400" tIns="12700" bIns="12700">
+            <a:normAutofit/>
+          </a:bodyPr>
+          <a:lstStyle/>
+          <a:p>
+            <a:pPr algn="ctr">
+              <a:spcAft>
+                <a:spcPts val="0"/>
+              </a:spcAft>
+            </a:pPr>
+            <a:r>
+              <a:rPr sz="625" b="0">
+                <a:solidFill>
+                  <a:srgbClr val="142433"/>
+                </a:solidFill>
+                <a:latin typeface="Inter"/>
+              </a:rPr>
+              <a:t>Receive summary (app)</a:t>
+            </a:r>
+          </a:p>
+        </p:txBody>
+      </p:sp>
+      <p:sp>
+        <p:nvSpPr>
+          <p:cNvPr id="45" name="Rounded Rectangle 44"/>
+          <p:cNvSpPr/>
+          <p:nvPr/>
+        </p:nvSpPr>
+        <p:spPr>
+          <a:xfrm>
+            <a:off x="10083800" y="4362450"/>
+            <a:ext cx="1016000" cy="444500"/>
+          </a:xfrm>
+          <a:prstGeom prst="roundRect">
+            <a:avLst>
+              <a:gd name="adj" fmla="val 17142"/>
+            </a:avLst>
+          </a:prstGeom>
+          <a:solidFill>
+            <a:srgbClr val="E6F0F0"/>
+          </a:solidFill>
+          <a:ln w="12700">
+            <a:solidFill>
+              <a:srgbClr val="2D6A6E"/>
+            </a:solidFill>
+          </a:ln>
+          <a:effectLst/>
+        </p:spPr>
+        <p:style>
+          <a:lnRef idx="1">
+            <a:schemeClr val="accent1"/>
+          </a:lnRef>
+          <a:fillRef idx="3">
+            <a:schemeClr val="accent1"/>
+          </a:fillRef>
+          <a:effectRef idx="2">
+            <a:schemeClr val="accent1"/>
+          </a:effectRef>
+          <a:fontRef idx="minor">
+            <a:schemeClr val="lt1"/>
+          </a:fontRef>
+        </p:style>
+        <p:txBody>
+          <a:bodyPr rtlCol="0" anchor="ctr"/>
+          <a:lstStyle/>
+          <a:p>
+            <a:pPr algn="ctr"/>
+          </a:p>
+        </p:txBody>
+      </p:sp>
+      <p:sp>
+        <p:nvSpPr>
+          <p:cNvPr id="46" name="TextBox 45"/>
+          <p:cNvSpPr txBox="1"/>
+          <p:nvPr/>
+        </p:nvSpPr>
+        <p:spPr>
+          <a:xfrm>
+            <a:off x="10147300" y="4362450"/>
+            <a:ext cx="889000" cy="444500"/>
+          </a:xfrm>
+          <a:prstGeom prst="rect">
+            <a:avLst/>
+          </a:prstGeom>
+          <a:noFill/>
+        </p:spPr>
+        <p:txBody>
+          <a:bodyPr wrap="square" anchor="ctr" lIns="25400" rIns="25400" tIns="12700" bIns="12700">
+            <a:normAutofit/>
+          </a:bodyPr>
+          <a:lstStyle/>
+          <a:p>
+            <a:pPr algn="ctr">
+              <a:spcAft>
+                <a:spcPts val="0"/>
+              </a:spcAft>
+            </a:pPr>
+            <a:r>
+              <a:rPr sz="625" b="0">
+                <a:solidFill>
+                  <a:srgbClr val="142433"/>
+                </a:solidFill>
+                <a:latin typeface="Inter"/>
+              </a:rPr>
+              <a:t>Carryover + progress portal</a:t>
+            </a:r>
+          </a:p>
+        </p:txBody>
+      </p:sp>
+      <p:sp>
+        <p:nvSpPr>
+          <p:cNvPr id="47" name="Rounded Rectangle 46"/>
+          <p:cNvSpPr/>
+          <p:nvPr/>
+        </p:nvSpPr>
+        <p:spPr>
+          <a:xfrm>
+            <a:off x="10083800" y="5607050"/>
+            <a:ext cx="1016000" cy="444500"/>
+          </a:xfrm>
+          <a:prstGeom prst="roundRect">
+            <a:avLst>
+              <a:gd name="adj" fmla="val 17142"/>
+            </a:avLst>
+          </a:prstGeom>
+          <a:solidFill>
+            <a:srgbClr val="E6F0F0"/>
+          </a:solidFill>
+          <a:ln w="12700">
+            <a:solidFill>
+              <a:srgbClr val="2D6A6E"/>
+            </a:solidFill>
+          </a:ln>
+          <a:effectLst/>
+        </p:spPr>
+        <p:style>
+          <a:lnRef idx="1">
+            <a:schemeClr val="accent1"/>
+          </a:lnRef>
+          <a:fillRef idx="3">
+            <a:schemeClr val="accent1"/>
+          </a:fillRef>
+          <a:effectRef idx="2">
+            <a:schemeClr val="accent1"/>
+          </a:effectRef>
+          <a:fontRef idx="minor">
+            <a:schemeClr val="lt1"/>
+          </a:fontRef>
+        </p:style>
+        <p:txBody>
+          <a:bodyPr rtlCol="0" anchor="ctr"/>
+          <a:lstStyle/>
+          <a:p>
+            <a:pPr algn="ctr"/>
+          </a:p>
+        </p:txBody>
+      </p:sp>
+      <p:sp>
+        <p:nvSpPr>
+          <p:cNvPr id="48" name="TextBox 47"/>
+          <p:cNvSpPr txBox="1"/>
+          <p:nvPr/>
+        </p:nvSpPr>
+        <p:spPr>
+          <a:xfrm>
+            <a:off x="10147300" y="5607050"/>
+            <a:ext cx="889000" cy="444500"/>
+          </a:xfrm>
+          <a:prstGeom prst="rect">
+            <a:avLst/>
+          </a:prstGeom>
+          <a:noFill/>
+        </p:spPr>
+        <p:txBody>
+          <a:bodyPr wrap="square" anchor="ctr" lIns="25400" rIns="25400" tIns="12700" bIns="12700">
+            <a:normAutofit/>
+          </a:bodyPr>
+          <a:lstStyle/>
+          <a:p>
+            <a:pPr algn="ctr">
+              <a:spcAft>
+                <a:spcPts val="0"/>
+              </a:spcAft>
+            </a:pPr>
+            <a:r>
+              <a:rPr sz="625" b="0">
+                <a:solidFill>
+                  <a:srgbClr val="142433"/>
+                </a:solidFill>
+                <a:latin typeface="Inter"/>
+              </a:rPr>
+              <a:t>PMS sync (vision)</a:t>
+            </a:r>
+          </a:p>
+        </p:txBody>
+      </p:sp>
+      <p:sp>
+        <p:nvSpPr>
+          <p:cNvPr id="49" name="Rounded Rectangle 48"/>
+          <p:cNvSpPr/>
+          <p:nvPr/>
+        </p:nvSpPr>
+        <p:spPr>
+          <a:xfrm>
+            <a:off x="10775950" y="1866899"/>
+            <a:ext cx="952500" cy="457200"/>
+          </a:xfrm>
+          <a:prstGeom prst="roundRect">
+            <a:avLst>
+              <a:gd name="adj" fmla="val 50000"/>
+            </a:avLst>
+          </a:prstGeom>
+          <a:solidFill>
+            <a:srgbClr val="FBF7F1"/>
+          </a:solidFill>
+          <a:ln w="12700">
+            <a:solidFill>
+              <a:srgbClr val="C98A5E"/>
+            </a:solidFill>
+          </a:ln>
+          <a:effectLst/>
+        </p:spPr>
+        <p:style>
+          <a:lnRef idx="1">
+            <a:schemeClr val="accent1"/>
+          </a:lnRef>
+          <a:fillRef idx="3">
+            <a:schemeClr val="accent1"/>
+          </a:fillRef>
+          <a:effectRef idx="2">
+            <a:schemeClr val="accent1"/>
+          </a:effectRef>
+          <a:fontRef idx="minor">
+            <a:schemeClr val="lt1"/>
+          </a:fontRef>
+        </p:style>
+        <p:txBody>
+          <a:bodyPr rtlCol="0" anchor="ctr"/>
+          <a:lstStyle/>
+          <a:p>
+            <a:pPr algn="ctr"/>
+          </a:p>
+        </p:txBody>
+      </p:sp>
+      <p:sp>
+        <p:nvSpPr>
+          <p:cNvPr id="50" name="TextBox 49"/>
+          <p:cNvSpPr txBox="1"/>
+          <p:nvPr/>
+        </p:nvSpPr>
+        <p:spPr>
+          <a:xfrm>
+            <a:off x="10839450" y="1866899"/>
+            <a:ext cx="825500" cy="457200"/>
+          </a:xfrm>
+          <a:prstGeom prst="rect">
+            <a:avLst/>
+          </a:prstGeom>
+          <a:noFill/>
+        </p:spPr>
+        <p:txBody>
+          <a:bodyPr wrap="square" anchor="ctr" lIns="25400" rIns="25400" tIns="12700" bIns="12700">
+            <a:normAutofit/>
+          </a:bodyPr>
+          <a:lstStyle/>
+          <a:p>
+            <a:pPr algn="ctr">
+              <a:spcAft>
+                <a:spcPts val="0"/>
+              </a:spcAft>
+            </a:pPr>
+            <a:r>
+              <a:rPr sz="625" b="1">
+                <a:solidFill>
+                  <a:srgbClr val="142433"/>
+                </a:solidFill>
+                <a:latin typeface="Inter"/>
+              </a:rPr>
+              <a:t>Ongoing care</a:t>
+            </a:r>
+          </a:p>
+        </p:txBody>
+      </p:sp>
+      <p:cxnSp>
+        <p:nvCxnSpPr>
+          <p:cNvPr id="51" name="Connector 50"/>
+          <p:cNvCxnSpPr/>
+          <p:nvPr/>
+        </p:nvCxnSpPr>
+        <p:spPr>
+          <a:xfrm>
+            <a:off x="1905000" y="2324100"/>
+            <a:ext cx="0" cy="2038350"/>
+          </a:xfrm>
+          <a:prstGeom prst="bentConnector3">
+            <a:avLst/>
+          </a:prstGeom>
+          <a:ln w="15875">
+            <a:solidFill>
+              <a:srgbClr val="9AA7AD"/>
+            </a:solidFill>
+            <a:tailEnd type="triangle" w="med" len="med"/>
+          </a:ln>
+          <a:effectLst/>
+        </p:spPr>
+        <p:style>
+          <a:lnRef idx="2">
+            <a:schemeClr val="accent1"/>
+          </a:lnRef>
+          <a:fillRef idx="0">
+            <a:schemeClr val="accent1"/>
+          </a:fillRef>
+          <a:effectRef idx="1">
+            <a:schemeClr val="accent1"/>
+          </a:effectRef>
+          <a:fontRef idx="minor">
+            <a:schemeClr val="tx1"/>
+          </a:fontRef>
+        </p:style>
+      </p:cxnSp>
+      <p:cxnSp>
+        <p:nvCxnSpPr>
+          <p:cNvPr id="52" name="Connector 51"/>
+          <p:cNvCxnSpPr/>
+          <p:nvPr/>
+        </p:nvCxnSpPr>
+        <p:spPr>
+          <a:xfrm flipV="1">
+            <a:off x="1905000" y="2317750"/>
+            <a:ext cx="965200" cy="2044700"/>
+          </a:xfrm>
+          <a:prstGeom prst="bentConnector3">
+            <a:avLst/>
+          </a:prstGeom>
+          <a:ln w="15875">
+            <a:solidFill>
+              <a:srgbClr val="9AA7AD"/>
+            </a:solidFill>
+            <a:tailEnd type="triangle" w="med" len="med"/>
+          </a:ln>
+          <a:effectLst/>
+        </p:spPr>
+        <p:style>
+          <a:lnRef idx="2">
+            <a:schemeClr val="accent1"/>
+          </a:lnRef>
+          <a:fillRef idx="0">
+            <a:schemeClr val="accent1"/>
+          </a:fillRef>
+          <a:effectRef idx="1">
+            <a:schemeClr val="accent1"/>
+          </a:effectRef>
+          <a:fontRef idx="minor">
+            <a:schemeClr val="tx1"/>
+          </a:fontRef>
+        </p:style>
+      </p:cxnSp>
+      <p:cxnSp>
+        <p:nvCxnSpPr>
+          <p:cNvPr id="53" name="Connector 52"/>
+          <p:cNvCxnSpPr/>
+          <p:nvPr/>
+        </p:nvCxnSpPr>
+        <p:spPr>
+          <a:xfrm>
+            <a:off x="2870200" y="2317750"/>
+            <a:ext cx="965200" cy="2044700"/>
+          </a:xfrm>
+          <a:prstGeom prst="bentConnector3">
+            <a:avLst/>
+          </a:prstGeom>
+          <a:ln w="15875">
+            <a:solidFill>
+              <a:srgbClr val="9AA7AD"/>
+            </a:solidFill>
+            <a:tailEnd type="triangle" w="med" len="med"/>
+          </a:ln>
+          <a:effectLst/>
+        </p:spPr>
+        <p:style>
+          <a:lnRef idx="2">
+            <a:schemeClr val="accent1"/>
+          </a:lnRef>
+          <a:fillRef idx="0">
+            <a:schemeClr val="accent1"/>
+          </a:fillRef>
+          <a:effectRef idx="1">
+            <a:schemeClr val="accent1"/>
+          </a:effectRef>
+          <a:fontRef idx="minor">
+            <a:schemeClr val="tx1"/>
+          </a:fontRef>
+        </p:style>
+      </p:cxnSp>
+      <p:cxnSp>
+        <p:nvCxnSpPr>
+          <p:cNvPr id="54" name="Connector 53"/>
+          <p:cNvCxnSpPr/>
+          <p:nvPr/>
+        </p:nvCxnSpPr>
+        <p:spPr>
+          <a:xfrm flipV="1">
+            <a:off x="3835400" y="3562350"/>
+            <a:ext cx="965200" cy="800100"/>
+          </a:xfrm>
+          <a:prstGeom prst="bentConnector3">
+            <a:avLst/>
+          </a:prstGeom>
+          <a:ln w="15875">
+            <a:solidFill>
+              <a:srgbClr val="9AA7AD"/>
+            </a:solidFill>
+            <a:tailEnd type="triangle" w="med" len="med"/>
+          </a:ln>
+          <a:effectLst/>
+        </p:spPr>
+        <p:style>
+          <a:lnRef idx="2">
+            <a:schemeClr val="accent1"/>
+          </a:lnRef>
+          <a:fillRef idx="0">
+            <a:schemeClr val="accent1"/>
+          </a:fillRef>
+          <a:effectRef idx="1">
+            <a:schemeClr val="accent1"/>
+          </a:effectRef>
+          <a:fontRef idx="minor">
+            <a:schemeClr val="tx1"/>
+          </a:fontRef>
+        </p:style>
+      </p:cxnSp>
+      <p:cxnSp>
+        <p:nvCxnSpPr>
+          <p:cNvPr id="55" name="Connector 54"/>
+          <p:cNvCxnSpPr/>
+          <p:nvPr/>
+        </p:nvCxnSpPr>
+        <p:spPr>
+          <a:xfrm flipV="1">
+            <a:off x="4800600" y="3562350"/>
+            <a:ext cx="965200" cy="2044700"/>
+          </a:xfrm>
+          <a:prstGeom prst="bentConnector3">
+            <a:avLst/>
+          </a:prstGeom>
+          <a:ln w="15875">
+            <a:solidFill>
+              <a:srgbClr val="9AA7AD"/>
+            </a:solidFill>
+            <a:tailEnd type="triangle" w="med" len="med"/>
+          </a:ln>
+          <a:effectLst/>
+        </p:spPr>
+        <p:style>
+          <a:lnRef idx="2">
+            <a:schemeClr val="accent1"/>
+          </a:lnRef>
+          <a:fillRef idx="0">
+            <a:schemeClr val="accent1"/>
+          </a:fillRef>
+          <a:effectRef idx="1">
+            <a:schemeClr val="accent1"/>
+          </a:effectRef>
+          <a:fontRef idx="minor">
+            <a:schemeClr val="tx1"/>
+          </a:fontRef>
+        </p:style>
+      </p:cxnSp>
+      <p:cxnSp>
+        <p:nvCxnSpPr>
+          <p:cNvPr id="56" name="Connector 55"/>
+          <p:cNvCxnSpPr/>
+          <p:nvPr/>
+        </p:nvCxnSpPr>
+        <p:spPr>
+          <a:xfrm flipH="1">
+            <a:off x="5257800" y="3340100"/>
+            <a:ext cx="50800" cy="0"/>
+          </a:xfrm>
+          <a:prstGeom prst="bentConnector3">
+            <a:avLst/>
+          </a:prstGeom>
+          <a:ln w="15875">
+            <a:solidFill>
+              <a:srgbClr val="9AA7AD"/>
+            </a:solidFill>
+            <a:tailEnd type="triangle" w="med" len="med"/>
+          </a:ln>
+          <a:effectLst/>
+        </p:spPr>
+        <p:style>
+          <a:lnRef idx="2">
+            <a:schemeClr val="accent1"/>
+          </a:lnRef>
+          <a:fillRef idx="0">
+            <a:schemeClr val="accent1"/>
+          </a:fillRef>
+          <a:effectRef idx="1">
+            <a:schemeClr val="accent1"/>
+          </a:effectRef>
+          <a:fontRef idx="minor">
+            <a:schemeClr val="tx1"/>
+          </a:fontRef>
+        </p:style>
+      </p:cxnSp>
+      <p:cxnSp>
+        <p:nvCxnSpPr>
+          <p:cNvPr id="57" name="Connector 56"/>
+          <p:cNvCxnSpPr/>
+          <p:nvPr/>
+        </p:nvCxnSpPr>
+        <p:spPr>
+          <a:xfrm flipH="1">
+            <a:off x="6184900" y="3340100"/>
+            <a:ext cx="88900" cy="0"/>
+          </a:xfrm>
+          <a:prstGeom prst="bentConnector3">
+            <a:avLst/>
+          </a:prstGeom>
+          <a:ln w="15875">
+            <a:solidFill>
+              <a:srgbClr val="9AA7AD"/>
+            </a:solidFill>
+            <a:tailEnd type="triangle" w="med" len="med"/>
+          </a:ln>
+          <a:effectLst/>
+        </p:spPr>
+        <p:style>
+          <a:lnRef idx="2">
+            <a:schemeClr val="accent1"/>
+          </a:lnRef>
+          <a:fillRef idx="0">
+            <a:schemeClr val="accent1"/>
+          </a:fillRef>
+          <a:effectRef idx="1">
+            <a:schemeClr val="accent1"/>
+          </a:effectRef>
+          <a:fontRef idx="minor">
+            <a:schemeClr val="tx1"/>
+          </a:fontRef>
+        </p:style>
+      </p:cxnSp>
+      <p:cxnSp>
+        <p:nvCxnSpPr>
+          <p:cNvPr id="58" name="Connector 57"/>
+          <p:cNvCxnSpPr/>
+          <p:nvPr/>
+        </p:nvCxnSpPr>
+        <p:spPr>
+          <a:xfrm>
+            <a:off x="6731000" y="3670300"/>
+            <a:ext cx="965199" cy="692150"/>
+          </a:xfrm>
+          <a:prstGeom prst="bentConnector3">
+            <a:avLst/>
+          </a:prstGeom>
+          <a:ln w="15875">
+            <a:solidFill>
+              <a:srgbClr val="9AA7AD"/>
+            </a:solidFill>
+            <a:tailEnd type="triangle" w="med" len="med"/>
+          </a:ln>
+          <a:effectLst/>
+        </p:spPr>
+        <p:style>
+          <a:lnRef idx="2">
+            <a:schemeClr val="accent1"/>
+          </a:lnRef>
+          <a:fillRef idx="0">
+            <a:schemeClr val="accent1"/>
+          </a:fillRef>
+          <a:effectRef idx="1">
+            <a:schemeClr val="accent1"/>
+          </a:effectRef>
+          <a:fontRef idx="minor">
+            <a:schemeClr val="tx1"/>
+          </a:fontRef>
+        </p:style>
+      </p:cxnSp>
+      <p:sp>
+        <p:nvSpPr>
+          <p:cNvPr id="59" name="TextBox 58"/>
+          <p:cNvSpPr txBox="1"/>
+          <p:nvPr/>
+        </p:nvSpPr>
+        <p:spPr>
+          <a:xfrm>
+            <a:off x="7023100" y="3876674"/>
+            <a:ext cx="381000" cy="139700"/>
+          </a:xfrm>
+          <a:prstGeom prst="rect">
+            <a:avLst/>
+          </a:prstGeom>
+          <a:noFill/>
+        </p:spPr>
+        <p:txBody>
+          <a:bodyPr wrap="none">
+            <a:spAutoFit/>
+          </a:bodyPr>
+          <a:lstStyle/>
+          <a:p>
+            <a:pPr algn="ctr"/>
+            <a:r>
+              <a:rPr sz="600" b="1">
+                <a:solidFill>
+                  <a:srgbClr val="4A5B6B"/>
+                </a:solidFill>
+                <a:latin typeface="Inter"/>
+              </a:rPr>
+              <a:t>Yes</a:t>
+            </a:r>
+          </a:p>
+        </p:txBody>
+      </p:sp>
+      <p:cxnSp>
+        <p:nvCxnSpPr>
+          <p:cNvPr id="60" name="Connector 59"/>
+          <p:cNvCxnSpPr/>
+          <p:nvPr/>
+        </p:nvCxnSpPr>
+        <p:spPr>
+          <a:xfrm flipH="1">
+            <a:off x="7188200" y="3340100"/>
+            <a:ext cx="88900" cy="0"/>
+          </a:xfrm>
+          <a:prstGeom prst="bentConnector3">
+            <a:avLst/>
+          </a:prstGeom>
+          <a:ln w="15875">
+            <a:solidFill>
+              <a:srgbClr val="9AA7AD"/>
+            </a:solidFill>
+            <a:tailEnd type="triangle" w="med" len="med"/>
+          </a:ln>
+          <a:effectLst/>
+        </p:spPr>
+        <p:style>
+          <a:lnRef idx="2">
+            <a:schemeClr val="accent1"/>
+          </a:lnRef>
+          <a:fillRef idx="0">
+            <a:schemeClr val="accent1"/>
+          </a:fillRef>
+          <a:effectRef idx="1">
+            <a:schemeClr val="accent1"/>
+          </a:effectRef>
+          <a:fontRef idx="minor">
+            <a:schemeClr val="tx1"/>
+          </a:fontRef>
+        </p:style>
+      </p:cxnSp>
+      <p:sp>
+        <p:nvSpPr>
+          <p:cNvPr id="61" name="TextBox 60"/>
+          <p:cNvSpPr txBox="1"/>
+          <p:nvPr/>
+        </p:nvSpPr>
+        <p:spPr>
+          <a:xfrm>
+            <a:off x="7042150" y="3200400"/>
+            <a:ext cx="381000" cy="139700"/>
+          </a:xfrm>
+          <a:prstGeom prst="rect">
+            <a:avLst/>
+          </a:prstGeom>
+          <a:noFill/>
+        </p:spPr>
+        <p:txBody>
+          <a:bodyPr wrap="none">
+            <a:spAutoFit/>
+          </a:bodyPr>
+          <a:lstStyle/>
+          <a:p>
+            <a:pPr algn="ctr"/>
+            <a:r>
+              <a:rPr sz="600" b="1">
+                <a:solidFill>
+                  <a:srgbClr val="4A5B6B"/>
+                </a:solidFill>
+                <a:latin typeface="Inter"/>
+              </a:rPr>
+              <a:t>No</a:t>
+            </a:r>
+          </a:p>
+        </p:txBody>
+      </p:sp>
+      <p:cxnSp>
+        <p:nvCxnSpPr>
+          <p:cNvPr id="62" name="Connector 61"/>
+          <p:cNvCxnSpPr/>
+          <p:nvPr/>
+        </p:nvCxnSpPr>
+        <p:spPr>
+          <a:xfrm flipV="1">
+            <a:off x="7696199" y="3562350"/>
+            <a:ext cx="965201" cy="800100"/>
+          </a:xfrm>
+          <a:prstGeom prst="bentConnector3">
+            <a:avLst/>
+          </a:prstGeom>
+          <a:ln w="15875">
+            <a:solidFill>
+              <a:srgbClr val="9AA7AD"/>
+            </a:solidFill>
+            <a:tailEnd type="triangle" w="med" len="med"/>
+          </a:ln>
+          <a:effectLst/>
+        </p:spPr>
+        <p:style>
+          <a:lnRef idx="2">
+            <a:schemeClr val="accent1"/>
+          </a:lnRef>
+          <a:fillRef idx="0">
+            <a:schemeClr val="accent1"/>
+          </a:fillRef>
+          <a:effectRef idx="1">
+            <a:schemeClr val="accent1"/>
+          </a:effectRef>
+          <a:fontRef idx="minor">
+            <a:schemeClr val="tx1"/>
+          </a:fontRef>
+        </p:style>
+      </p:cxnSp>
+      <p:cxnSp>
+        <p:nvCxnSpPr>
+          <p:cNvPr id="63" name="Connector 62"/>
+          <p:cNvCxnSpPr/>
+          <p:nvPr/>
+        </p:nvCxnSpPr>
+        <p:spPr>
+          <a:xfrm>
+            <a:off x="8661400" y="3562350"/>
+            <a:ext cx="965200" cy="800100"/>
+          </a:xfrm>
+          <a:prstGeom prst="bentConnector3">
+            <a:avLst/>
+          </a:prstGeom>
+          <a:ln w="15875">
+            <a:solidFill>
+              <a:srgbClr val="9AA7AD"/>
+            </a:solidFill>
+            <a:tailEnd type="triangle" w="med" len="med"/>
+          </a:ln>
+          <a:effectLst/>
+        </p:spPr>
+        <p:style>
+          <a:lnRef idx="2">
+            <a:schemeClr val="accent1"/>
+          </a:lnRef>
+          <a:fillRef idx="0">
+            <a:schemeClr val="accent1"/>
+          </a:fillRef>
+          <a:effectRef idx="1">
+            <a:schemeClr val="accent1"/>
+          </a:effectRef>
+          <a:fontRef idx="minor">
+            <a:schemeClr val="tx1"/>
+          </a:fontRef>
+        </p:style>
+      </p:cxnSp>
+      <p:cxnSp>
+        <p:nvCxnSpPr>
+          <p:cNvPr id="64" name="Connector 63"/>
+          <p:cNvCxnSpPr/>
+          <p:nvPr/>
+        </p:nvCxnSpPr>
+        <p:spPr>
+          <a:xfrm>
+            <a:off x="8204199" y="3340100"/>
+            <a:ext cx="914401" cy="1244600"/>
+          </a:xfrm>
+          <a:prstGeom prst="bentConnector3">
+            <a:avLst/>
+          </a:prstGeom>
+          <a:ln w="15875">
+            <a:solidFill>
+              <a:srgbClr val="9AA7AD"/>
+            </a:solidFill>
+            <a:tailEnd type="triangle" w="med" len="med"/>
+          </a:ln>
+          <a:effectLst/>
+        </p:spPr>
+        <p:style>
+          <a:lnRef idx="2">
+            <a:schemeClr val="accent1"/>
+          </a:lnRef>
+          <a:fillRef idx="0">
+            <a:schemeClr val="accent1"/>
+          </a:fillRef>
+          <a:effectRef idx="1">
+            <a:schemeClr val="accent1"/>
+          </a:effectRef>
+          <a:fontRef idx="minor">
+            <a:schemeClr val="tx1"/>
+          </a:fontRef>
+        </p:style>
+      </p:cxnSp>
+      <p:cxnSp>
+        <p:nvCxnSpPr>
+          <p:cNvPr id="65" name="Connector 64"/>
+          <p:cNvCxnSpPr/>
+          <p:nvPr/>
+        </p:nvCxnSpPr>
+        <p:spPr>
+          <a:xfrm flipV="1">
+            <a:off x="9626600" y="3562350"/>
+            <a:ext cx="965200" cy="800100"/>
+          </a:xfrm>
+          <a:prstGeom prst="bentConnector3">
+            <a:avLst/>
+          </a:prstGeom>
+          <a:ln w="15875">
+            <a:solidFill>
+              <a:srgbClr val="9AA7AD"/>
+            </a:solidFill>
+            <a:tailEnd type="triangle" w="med" len="med"/>
+          </a:ln>
+          <a:effectLst/>
+        </p:spPr>
+        <p:style>
+          <a:lnRef idx="2">
+            <a:schemeClr val="accent1"/>
+          </a:lnRef>
+          <a:fillRef idx="0">
+            <a:schemeClr val="accent1"/>
+          </a:fillRef>
+          <a:effectRef idx="1">
+            <a:schemeClr val="accent1"/>
+          </a:effectRef>
+          <a:fontRef idx="minor">
+            <a:schemeClr val="tx1"/>
+          </a:fontRef>
+        </p:style>
+      </p:cxnSp>
+      <p:cxnSp>
+        <p:nvCxnSpPr>
+          <p:cNvPr id="66" name="Connector 65"/>
+          <p:cNvCxnSpPr/>
+          <p:nvPr/>
+        </p:nvCxnSpPr>
+        <p:spPr>
+          <a:xfrm flipH="1" flipV="1">
+            <a:off x="10134600" y="2317750"/>
+            <a:ext cx="457200" cy="800100"/>
+          </a:xfrm>
+          <a:prstGeom prst="bentConnector3">
+            <a:avLst/>
+          </a:prstGeom>
+          <a:ln w="15875">
+            <a:solidFill>
+              <a:srgbClr val="9AA7AD"/>
+            </a:solidFill>
+            <a:tailEnd type="triangle" w="med" len="med"/>
+          </a:ln>
+          <a:effectLst/>
+        </p:spPr>
+        <p:style>
+          <a:lnRef idx="2">
+            <a:schemeClr val="accent1"/>
+          </a:lnRef>
+          <a:fillRef idx="0">
+            <a:schemeClr val="accent1"/>
+          </a:fillRef>
+          <a:effectRef idx="1">
+            <a:schemeClr val="accent1"/>
+          </a:effectRef>
+          <a:fontRef idx="minor">
+            <a:schemeClr val="tx1"/>
+          </a:fontRef>
+        </p:style>
+      </p:cxnSp>
+      <p:cxnSp>
+        <p:nvCxnSpPr>
+          <p:cNvPr id="67" name="Connector 66"/>
+          <p:cNvCxnSpPr/>
+          <p:nvPr/>
+        </p:nvCxnSpPr>
+        <p:spPr>
+          <a:xfrm>
+            <a:off x="10591800" y="3562350"/>
+            <a:ext cx="0" cy="800100"/>
+          </a:xfrm>
+          <a:prstGeom prst="bentConnector3">
+            <a:avLst/>
+          </a:prstGeom>
+          <a:ln w="15875">
+            <a:solidFill>
+              <a:srgbClr val="9AA7AD"/>
+            </a:solidFill>
+            <a:tailEnd type="triangle" w="med" len="med"/>
+          </a:ln>
+          <a:effectLst/>
+        </p:spPr>
+        <p:style>
+          <a:lnRef idx="2">
+            <a:schemeClr val="accent1"/>
+          </a:lnRef>
+          <a:fillRef idx="0">
+            <a:schemeClr val="accent1"/>
+          </a:fillRef>
+          <a:effectRef idx="1">
+            <a:schemeClr val="accent1"/>
+          </a:effectRef>
+          <a:fontRef idx="minor">
+            <a:schemeClr val="tx1"/>
+          </a:fontRef>
+        </p:style>
+      </p:cxnSp>
+      <p:cxnSp>
+        <p:nvCxnSpPr>
+          <p:cNvPr id="68" name="Connector 67"/>
+          <p:cNvCxnSpPr/>
+          <p:nvPr/>
+        </p:nvCxnSpPr>
+        <p:spPr>
+          <a:xfrm>
+            <a:off x="10642600" y="2095499"/>
+            <a:ext cx="133350" cy="0"/>
+          </a:xfrm>
+          <a:prstGeom prst="bentConnector3">
+            <a:avLst/>
+          </a:prstGeom>
+          <a:ln w="15875">
+            <a:solidFill>
+              <a:srgbClr val="9AA7AD"/>
+            </a:solidFill>
+            <a:tailEnd type="triangle" w="med" len="med"/>
+          </a:ln>
+          <a:effectLst/>
+        </p:spPr>
+        <p:style>
+          <a:lnRef idx="2">
+            <a:schemeClr val="accent1"/>
+          </a:lnRef>
+          <a:fillRef idx="0">
+            <a:schemeClr val="accent1"/>
+          </a:fillRef>
+          <a:effectRef idx="1">
+            <a:schemeClr val="accent1"/>
+          </a:effectRef>
+          <a:fontRef idx="minor">
+            <a:schemeClr val="tx1"/>
+          </a:fontRef>
+        </p:style>
+      </p:cxnSp>
+      <p:cxnSp>
+        <p:nvCxnSpPr>
+          <p:cNvPr id="69" name="Connector 68"/>
+          <p:cNvCxnSpPr/>
+          <p:nvPr/>
+        </p:nvCxnSpPr>
+        <p:spPr>
+          <a:xfrm>
+            <a:off x="10591800" y="4806950"/>
+            <a:ext cx="0" cy="800100"/>
+          </a:xfrm>
+          <a:prstGeom prst="bentConnector3">
+            <a:avLst/>
+          </a:prstGeom>
+          <a:ln w="15875">
+            <a:solidFill>
+              <a:srgbClr val="9AA7AD"/>
+            </a:solidFill>
+            <a:tailEnd type="triangle" w="med" len="med"/>
+          </a:ln>
+          <a:effectLst/>
+        </p:spPr>
+        <p:style>
+          <a:lnRef idx="2">
+            <a:schemeClr val="accent1"/>
+          </a:lnRef>
+          <a:fillRef idx="0">
+            <a:schemeClr val="accent1"/>
+          </a:fillRef>
+          <a:effectRef idx="1">
+            <a:schemeClr val="accent1"/>
+          </a:effectRef>
+          <a:fontRef idx="minor">
+            <a:schemeClr val="tx1"/>
+          </a:fontRef>
+        </p:style>
+      </p:cxnSp>
+      <p:sp>
+        <p:nvSpPr>
+          <p:cNvPr id="70" name="TextBox 69"/>
+          <p:cNvSpPr txBox="1"/>
+          <p:nvPr/>
+        </p:nvSpPr>
+        <p:spPr>
+          <a:xfrm>
+            <a:off x="1371600" y="6464300"/>
+            <a:ext cx="11049000" cy="139700"/>
+          </a:xfrm>
+          <a:prstGeom prst="rect">
+            <a:avLst/>
+          </a:prstGeom>
+          <a:noFill/>
+        </p:spPr>
+        <p:txBody>
+          <a:bodyPr wrap="square" anchor="t" lIns="25400" rIns="25400" tIns="12700" bIns="12700">
+            <a:spAutoFit/>
+          </a:bodyPr>
+          <a:lstStyle/>
+          <a:p>
+            <a:pPr algn="l">
+              <a:spcAft>
+                <a:spcPts val="0"/>
+              </a:spcAft>
+            </a:pPr>
+            <a:r>
+              <a:rPr sz="625" b="0">
+                <a:solidFill>
+                  <a:srgbClr val="8597A4"/>
+                </a:solidFill>
+                <a:latin typeface="Inter"/>
+              </a:rPr>
+              <a:t>Shapes:  rounded = task   ·   diamond = decision   ·   pill = start / end.    DRAFT = AI artifact the clinician reviews &amp; signs.</a:t>
+            </a:r>
+          </a:p>
+        </p:txBody>
+      </p:sp>
+      <p:sp>
+        <p:nvSpPr>
+          <p:cNvPr id="71" name="TextBox 70"/>
+          <p:cNvSpPr txBox="1"/>
+          <p:nvPr/>
+        </p:nvSpPr>
+        <p:spPr>
+          <a:xfrm>
+            <a:off x="571500" y="6654800"/>
+            <a:ext cx="5715000" cy="139700"/>
+          </a:xfrm>
+          <a:prstGeom prst="rect">
+            <a:avLst/>
+          </a:prstGeom>
+          <a:noFill/>
+        </p:spPr>
+        <p:txBody>
+          <a:bodyPr wrap="square" anchor="t" lIns="25400" rIns="25400" tIns="12700" bIns="12700">
+            <a:spAutoFit/>
+          </a:bodyPr>
+          <a:lstStyle/>
+          <a:p>
+            <a:pPr algn="l">
+              <a:spcAft>
+                <a:spcPts val="0"/>
+              </a:spcAft>
+            </a:pPr>
+            <a:r>
+              <a:rPr sz="600" b="0">
+                <a:solidFill>
+                  <a:srgbClr val="8597A4"/>
+                </a:solidFill>
+                <a:latin typeface="Inter"/>
+              </a:rPr>
+              <a:t>Sona — Care Journey &amp; Product Overview</a:t>
+            </a:r>
+          </a:p>
+        </p:txBody>
+      </p:sp>
+      <p:sp>
+        <p:nvSpPr>
+          <p:cNvPr id="72" name="TextBox 71"/>
+          <p:cNvSpPr txBox="1"/>
+          <p:nvPr/>
+        </p:nvSpPr>
+        <p:spPr>
+          <a:xfrm>
+            <a:off x="10414000" y="6654800"/>
+            <a:ext cx="1206500" cy="139700"/>
+          </a:xfrm>
+          <a:prstGeom prst="rect">
+            <a:avLst/>
+          </a:prstGeom>
+          <a:noFill/>
+        </p:spPr>
+        <p:txBody>
+          <a:bodyPr wrap="square" anchor="t" lIns="25400" rIns="25400" tIns="12700" bIns="12700">
+            <a:spAutoFit/>
+          </a:bodyPr>
+          <a:lstStyle/>
+          <a:p>
+            <a:pPr algn="r">
+              <a:spcAft>
+                <a:spcPts val="0"/>
+              </a:spcAft>
+            </a:pPr>
+            <a:r>
+              <a:rPr sz="600" b="0">
+                <a:solidFill>
+                  <a:srgbClr val="8597A4"/>
+                </a:solidFill>
+                <a:latin typeface="Inter"/>
+              </a:rPr>
+              <a:t>4 / 4</a:t>
             </a:r>
           </a:p>
         </p:txBody>

</xml_diff>

<commit_message>
design: refine slides per review (overview, sentiment, pains)
Slide 1: format-agnostic 'How to read this', three views split into scannable
bold-lead lines, lighter anchor-principles strip. Slide 2: sentiment redesigned
as a filled-area curve with emotion descriptors; calmer neutral pain cards (no
alarm-red); 'The Prize' -> 'Target outcomes'. Deck regenerated to match the
board incl. the adjusted Slide 4 layout.

https://claude.ai/code/session_015v7JWiWTXQN2Qco9pisXZ1
</commit_message>
<xml_diff>
--- a/docs/design/Sona_Care_Journey_Deck.pptx
+++ b/docs/design/Sona_Care_Journey_Deck.pptx
@@ -3152,7 +3152,7 @@
           <a:noFill/>
         </p:spPr>
         <p:txBody>
-          <a:bodyPr wrap="square" anchor="t" lIns="25400" rIns="25400" tIns="12700" bIns="12700">
+          <a:bodyPr wrap="square" anchor="t" lIns="25400" rIns="25400" tIns="25400" bIns="25400">
             <a:spAutoFit/>
           </a:bodyPr>
           <a:lstStyle/>
@@ -3191,7 +3191,7 @@
           <a:noFill/>
         </p:spPr>
         <p:txBody>
-          <a:bodyPr wrap="square" anchor="t" lIns="25400" rIns="25400" tIns="12700" bIns="12700">
+          <a:bodyPr wrap="square" anchor="t" lIns="25400" rIns="25400" tIns="25400" bIns="25400">
             <a:spAutoFit/>
           </a:bodyPr>
           <a:lstStyle/>
@@ -3230,7 +3230,7 @@
           <a:noFill/>
         </p:spPr>
         <p:txBody>
-          <a:bodyPr wrap="square" anchor="t" lIns="25400" rIns="25400" tIns="12700" bIns="12700">
+          <a:bodyPr wrap="square" anchor="t" lIns="25400" rIns="25400" tIns="25400" bIns="25400">
             <a:spAutoFit/>
           </a:bodyPr>
           <a:lstStyle/>
@@ -3315,7 +3315,7 @@
           <a:noFill/>
         </p:spPr>
         <p:txBody>
-          <a:bodyPr wrap="square" anchor="t" lIns="25400" rIns="25400" tIns="12700" bIns="12700">
+          <a:bodyPr wrap="square" anchor="t" lIns="25400" rIns="25400" tIns="25400" bIns="25400">
             <a:spAutoFit/>
           </a:bodyPr>
           <a:lstStyle/>
@@ -3354,7 +3354,7 @@
           <a:noFill/>
         </p:spPr>
         <p:txBody>
-          <a:bodyPr wrap="square" anchor="t" lIns="25400" rIns="25400" tIns="12700" bIns="12700">
+          <a:bodyPr wrap="square" anchor="t" lIns="25400" rIns="25400" tIns="25400" bIns="25400">
             <a:spAutoFit/>
           </a:bodyPr>
           <a:lstStyle/>
@@ -3475,7 +3475,7 @@
           <a:noFill/>
         </p:spPr>
         <p:txBody>
-          <a:bodyPr wrap="square" anchor="t" lIns="25400" rIns="25400" tIns="12700" bIns="12700">
+          <a:bodyPr wrap="square" anchor="t" lIns="25400" rIns="25400" tIns="25400" bIns="25400">
             <a:spAutoFit/>
           </a:bodyPr>
           <a:lstStyle/>
@@ -3492,7 +3492,7 @@
                 </a:solidFill>
                 <a:latin typeface="Inter"/>
               </a:rPr>
-              <a:t>HOW TO READ THIS BOARD</a:t>
+              <a:t>HOW TO READ THIS</a:t>
             </a:r>
           </a:p>
         </p:txBody>
@@ -3505,8 +3505,8 @@
         </p:nvSpPr>
         <p:spPr>
           <a:xfrm>
-            <a:off x="6388100" y="2286000"/>
-            <a:ext cx="5080000" cy="2921000"/>
+            <a:off x="6388100" y="2298700"/>
+            <a:ext cx="5080000" cy="177800"/>
           </a:xfrm>
           <a:prstGeom prst="rect">
             <a:avLst/>
@@ -3514,7 +3514,7 @@
           <a:noFill/>
         </p:spPr>
         <p:txBody>
-          <a:bodyPr wrap="square" anchor="t" lIns="25400" rIns="25400" tIns="12700" bIns="12700">
+          <a:bodyPr wrap="square" anchor="t" lIns="25400" rIns="25400" tIns="25400" bIns="25400">
             <a:spAutoFit/>
           </a:bodyPr>
           <a:lstStyle/>
@@ -3527,71 +3527,244 @@
             <a:r>
               <a:rPr sz="900" b="0">
                 <a:solidFill>
-                  <a:srgbClr val="142433"/>
+                  <a:srgbClr val="4A5B6B"/>
                 </a:solidFill>
                 <a:latin typeface="Inter"/>
               </a:rPr>
-              <a:t>•  Three views follow — the Executive view (the journey and the value), the Product view (the proposed solution), and the Process-flow view (the To-Be swimlane).</a:t>
-            </a:r>
-          </a:p>
+              <a:t>Three views, read left → right:</a:t>
+            </a:r>
+          </a:p>
+        </p:txBody>
+      </p:sp>
+      <p:sp>
+        <p:nvSpPr>
+          <p:cNvPr id="12" name="TextBox 11"/>
+          <p:cNvSpPr txBox="1"/>
+          <p:nvPr/>
+        </p:nvSpPr>
+        <p:spPr>
+          <a:xfrm>
+            <a:off x="6388100" y="2578100"/>
+            <a:ext cx="5207000" cy="177800"/>
+          </a:xfrm>
+          <a:prstGeom prst="rect">
+            <a:avLst/>
+          </a:prstGeom>
+          <a:noFill/>
+        </p:spPr>
+        <p:txBody>
+          <a:bodyPr wrap="square">
+            <a:spAutoFit/>
+          </a:bodyPr>
+          <a:lstStyle/>
+          <a:p>
+            <a:pPr algn="l"/>
+            <a:r>
+              <a:rPr sz="900" b="1">
+                <a:solidFill>
+                  <a:srgbClr val="2D6A6E"/>
+                </a:solidFill>
+                <a:latin typeface="Inter"/>
+              </a:rPr>
+              <a:t>Executive</a:t>
+            </a:r>
+            <a:r>
+              <a:rPr sz="900" b="0">
+                <a:solidFill>
+                  <a:srgbClr val="142433"/>
+                </a:solidFill>
+                <a:latin typeface="Inter"/>
+              </a:rPr>
+              <a:t>  —  the journey &amp; the value</a:t>
+            </a:r>
+          </a:p>
+        </p:txBody>
+      </p:sp>
+      <p:sp>
+        <p:nvSpPr>
+          <p:cNvPr id="13" name="TextBox 12"/>
+          <p:cNvSpPr txBox="1"/>
+          <p:nvPr/>
+        </p:nvSpPr>
+        <p:spPr>
+          <a:xfrm>
+            <a:off x="6388100" y="2832100"/>
+            <a:ext cx="5207000" cy="177800"/>
+          </a:xfrm>
+          <a:prstGeom prst="rect">
+            <a:avLst/>
+          </a:prstGeom>
+          <a:noFill/>
+        </p:spPr>
+        <p:txBody>
+          <a:bodyPr wrap="square">
+            <a:spAutoFit/>
+          </a:bodyPr>
+          <a:lstStyle/>
+          <a:p>
+            <a:pPr algn="l"/>
+            <a:r>
+              <a:rPr sz="900" b="1">
+                <a:solidFill>
+                  <a:srgbClr val="2D6A6E"/>
+                </a:solidFill>
+                <a:latin typeface="Inter"/>
+              </a:rPr>
+              <a:t>Product</a:t>
+            </a:r>
+            <a:r>
+              <a:rPr sz="900" b="0">
+                <a:solidFill>
+                  <a:srgbClr val="142433"/>
+                </a:solidFill>
+                <a:latin typeface="Inter"/>
+              </a:rPr>
+              <a:t>  —  the proposed solution</a:t>
+            </a:r>
+          </a:p>
+        </p:txBody>
+      </p:sp>
+      <p:sp>
+        <p:nvSpPr>
+          <p:cNvPr id="14" name="TextBox 13"/>
+          <p:cNvSpPr txBox="1"/>
+          <p:nvPr/>
+        </p:nvSpPr>
+        <p:spPr>
+          <a:xfrm>
+            <a:off x="6388100" y="3086100"/>
+            <a:ext cx="5207000" cy="177800"/>
+          </a:xfrm>
+          <a:prstGeom prst="rect">
+            <a:avLst/>
+          </a:prstGeom>
+          <a:noFill/>
+        </p:spPr>
+        <p:txBody>
+          <a:bodyPr wrap="square">
+            <a:spAutoFit/>
+          </a:bodyPr>
+          <a:lstStyle/>
+          <a:p>
+            <a:pPr algn="l"/>
+            <a:r>
+              <a:rPr sz="900" b="1">
+                <a:solidFill>
+                  <a:srgbClr val="2D6A6E"/>
+                </a:solidFill>
+                <a:latin typeface="Inter"/>
+              </a:rPr>
+              <a:t>Process flow</a:t>
+            </a:r>
+            <a:r>
+              <a:rPr sz="900" b="0">
+                <a:solidFill>
+                  <a:srgbClr val="142433"/>
+                </a:solidFill>
+                <a:latin typeface="Inter"/>
+              </a:rPr>
+              <a:t>  —  the To-Be swimlane</a:t>
+            </a:r>
+          </a:p>
+        </p:txBody>
+      </p:sp>
+      <p:sp>
+        <p:nvSpPr>
+          <p:cNvPr id="15" name="TextBox 14"/>
+          <p:cNvSpPr txBox="1"/>
+          <p:nvPr/>
+        </p:nvSpPr>
+        <p:spPr>
+          <a:xfrm>
+            <a:off x="6388100" y="3530600"/>
+            <a:ext cx="5080000" cy="165100"/>
+          </a:xfrm>
+          <a:prstGeom prst="rect">
+            <a:avLst/>
+          </a:prstGeom>
+          <a:noFill/>
+        </p:spPr>
+        <p:txBody>
+          <a:bodyPr wrap="square" anchor="t" lIns="25400" rIns="25400" tIns="25400" bIns="25400">
+            <a:spAutoFit/>
+          </a:bodyPr>
+          <a:lstStyle/>
           <a:p>
             <a:pPr algn="l">
-              <a:spcBef>
-                <a:spcPts val="500"/>
-              </a:spcBef>
               <a:spcAft>
                 <a:spcPts val="0"/>
               </a:spcAft>
             </a:pPr>
             <a:r>
-              <a:rPr sz="900" b="0">
-                <a:solidFill>
-                  <a:srgbClr val="142433"/>
+              <a:rPr sz="750" b="1">
+                <a:solidFill>
+                  <a:srgbClr val="2D6A6E"/>
                 </a:solidFill>
                 <a:latin typeface="Inter"/>
               </a:rPr>
-              <a:t>•  Read each view left → right: the client's journey across the first ~30 days of a new case.</a:t>
-            </a:r>
-          </a:p>
+              <a:t>WHO'S WHO</a:t>
+            </a:r>
+          </a:p>
+        </p:txBody>
+      </p:sp>
+      <p:sp>
+        <p:nvSpPr>
+          <p:cNvPr id="16" name="TextBox 15"/>
+          <p:cNvSpPr txBox="1"/>
+          <p:nvPr/>
+        </p:nvSpPr>
+        <p:spPr>
+          <a:xfrm>
+            <a:off x="6388100" y="3733799"/>
+            <a:ext cx="5143500" cy="381000"/>
+          </a:xfrm>
+          <a:prstGeom prst="rect">
+            <a:avLst/>
+          </a:prstGeom>
+          <a:noFill/>
+        </p:spPr>
+        <p:txBody>
+          <a:bodyPr wrap="square" anchor="t" lIns="25400" rIns="25400" tIns="25400" bIns="25400">
+            <a:spAutoFit/>
+          </a:bodyPr>
+          <a:lstStyle/>
           <a:p>
             <a:pPr algn="l">
-              <a:spcBef>
-                <a:spcPts val="500"/>
-              </a:spcBef>
               <a:spcAft>
                 <a:spcPts val="0"/>
               </a:spcAft>
             </a:pPr>
             <a:r>
-              <a:rPr sz="900" b="0">
-                <a:solidFill>
-                  <a:srgbClr val="142433"/>
+              <a:rPr sz="800" b="0">
+                <a:solidFill>
+                  <a:srgbClr val="4A5B6B"/>
                 </a:solidFill>
                 <a:latin typeface="Inter"/>
               </a:rPr>
-              <a:t>•  Who's who —  client / parent / carer: the family or adult client;  clinician / SLT: the therapist;  practice: the private clinic.</a:t>
-            </a:r>
-          </a:p>
-        </p:txBody>
-      </p:sp>
-      <p:sp>
-        <p:nvSpPr>
-          <p:cNvPr id="12" name="Rounded Rectangle 11"/>
+              <a:t>client / parent / carer — the family or adult client
+clinician / SLT — the therapist    ·    practice — the private clinic</a:t>
+            </a:r>
+          </a:p>
+        </p:txBody>
+      </p:sp>
+      <p:sp>
+        <p:nvSpPr>
+          <p:cNvPr id="17" name="Rounded Rectangle 16"/>
           <p:cNvSpPr/>
           <p:nvPr/>
         </p:nvSpPr>
         <p:spPr>
           <a:xfrm>
             <a:off x="571500" y="5664200"/>
-            <a:ext cx="11049000" cy="812800"/>
+            <a:ext cx="11049000" cy="762000"/>
           </a:xfrm>
           <a:prstGeom prst="roundRect">
             <a:avLst>
-              <a:gd name="adj" fmla="val 12500"/>
+              <a:gd name="adj" fmla="val 13333"/>
             </a:avLst>
           </a:prstGeom>
           <a:solidFill>
-            <a:srgbClr val="1E4A4D"/>
+            <a:srgbClr val="EAF1F0"/>
           </a:solidFill>
           <a:ln>
             <a:noFill/>
@@ -3622,13 +3795,13 @@
       </p:sp>
       <p:sp>
         <p:nvSpPr>
-          <p:cNvPr id="13" name="TextBox 12"/>
+          <p:cNvPr id="18" name="TextBox 17"/>
           <p:cNvSpPr txBox="1"/>
           <p:nvPr/>
         </p:nvSpPr>
         <p:spPr>
           <a:xfrm>
-            <a:off x="774700" y="5816600"/>
+            <a:off x="774700" y="5803900"/>
             <a:ext cx="3810000" cy="152400"/>
           </a:xfrm>
           <a:prstGeom prst="rect">
@@ -3637,7 +3810,7 @@
           <a:noFill/>
         </p:spPr>
         <p:txBody>
-          <a:bodyPr wrap="square" anchor="t" lIns="25400" rIns="25400" tIns="12700" bIns="12700">
+          <a:bodyPr wrap="square" anchor="t" lIns="25400" rIns="25400" tIns="25400" bIns="25400">
             <a:spAutoFit/>
           </a:bodyPr>
           <a:lstStyle/>
@@ -3650,7 +3823,7 @@
             <a:r>
               <a:rPr sz="700" b="1">
                 <a:solidFill>
-                  <a:srgbClr val="A9C7C7"/>
+                  <a:srgbClr val="2D6A6E"/>
                 </a:solidFill>
                 <a:latin typeface="Inter"/>
               </a:rPr>
@@ -3661,13 +3834,13 @@
       </p:sp>
       <p:sp>
         <p:nvSpPr>
-          <p:cNvPr id="14" name="TextBox 13"/>
+          <p:cNvPr id="19" name="TextBox 18"/>
           <p:cNvSpPr txBox="1"/>
           <p:nvPr/>
         </p:nvSpPr>
         <p:spPr>
           <a:xfrm>
-            <a:off x="774700" y="6083300"/>
+            <a:off x="774700" y="6032500"/>
             <a:ext cx="2667000" cy="177800"/>
           </a:xfrm>
           <a:prstGeom prst="rect">
@@ -3676,7 +3849,7 @@
           <a:noFill/>
         </p:spPr>
         <p:txBody>
-          <a:bodyPr wrap="square" anchor="t" lIns="25400" rIns="25400" tIns="12700" bIns="12700">
+          <a:bodyPr wrap="square" anchor="t" lIns="25400" rIns="25400" tIns="25400" bIns="25400">
             <a:spAutoFit/>
           </a:bodyPr>
           <a:lstStyle/>
@@ -3689,24 +3862,24 @@
             <a:r>
               <a:rPr sz="750" b="0">
                 <a:solidFill>
-                  <a:srgbClr val="FFFFFF"/>
+                  <a:srgbClr val="1E4A4D"/>
                 </a:solidFill>
                 <a:latin typeface="Inter"/>
               </a:rPr>
-              <a:t>(1)   AI drafts, clinician decides</a:t>
-            </a:r>
-          </a:p>
-        </p:txBody>
-      </p:sp>
-      <p:sp>
-        <p:nvSpPr>
-          <p:cNvPr id="15" name="TextBox 14"/>
+              <a:t>AI drafts, clinician decides</a:t>
+            </a:r>
+          </a:p>
+        </p:txBody>
+      </p:sp>
+      <p:sp>
+        <p:nvSpPr>
+          <p:cNvPr id="20" name="TextBox 19"/>
           <p:cNvSpPr txBox="1"/>
           <p:nvPr/>
         </p:nvSpPr>
         <p:spPr>
           <a:xfrm>
-            <a:off x="3530600" y="6083300"/>
+            <a:off x="3530600" y="6032500"/>
             <a:ext cx="2667000" cy="177800"/>
           </a:xfrm>
           <a:prstGeom prst="rect">
@@ -3715,7 +3888,7 @@
           <a:noFill/>
         </p:spPr>
         <p:txBody>
-          <a:bodyPr wrap="square" anchor="t" lIns="25400" rIns="25400" tIns="12700" bIns="12700">
+          <a:bodyPr wrap="square" anchor="t" lIns="25400" rIns="25400" tIns="25400" bIns="25400">
             <a:spAutoFit/>
           </a:bodyPr>
           <a:lstStyle/>
@@ -3728,24 +3901,24 @@
             <a:r>
               <a:rPr sz="750" b="0">
                 <a:solidFill>
-                  <a:srgbClr val="FFFFFF"/>
+                  <a:srgbClr val="1E4A4D"/>
                 </a:solidFill>
                 <a:latin typeface="Inter"/>
               </a:rPr>
-              <a:t>(2)   No screen time for children</a:t>
-            </a:r>
-          </a:p>
-        </p:txBody>
-      </p:sp>
-      <p:sp>
-        <p:nvSpPr>
-          <p:cNvPr id="16" name="TextBox 15"/>
+              <a:t>No screen time for children</a:t>
+            </a:r>
+          </a:p>
+        </p:txBody>
+      </p:sp>
+      <p:sp>
+        <p:nvSpPr>
+          <p:cNvPr id="21" name="TextBox 20"/>
           <p:cNvSpPr txBox="1"/>
           <p:nvPr/>
         </p:nvSpPr>
         <p:spPr>
           <a:xfrm>
-            <a:off x="6286500" y="6083300"/>
+            <a:off x="6286500" y="6032500"/>
             <a:ext cx="2667000" cy="177800"/>
           </a:xfrm>
           <a:prstGeom prst="rect">
@@ -3754,7 +3927,7 @@
           <a:noFill/>
         </p:spPr>
         <p:txBody>
-          <a:bodyPr wrap="square" anchor="t" lIns="25400" rIns="25400" tIns="12700" bIns="12700">
+          <a:bodyPr wrap="square" anchor="t" lIns="25400" rIns="25400" tIns="25400" bIns="25400">
             <a:spAutoFit/>
           </a:bodyPr>
           <a:lstStyle/>
@@ -3767,24 +3940,24 @@
             <a:r>
               <a:rPr sz="750" b="0">
                 <a:solidFill>
-                  <a:srgbClr val="FFFFFF"/>
+                  <a:srgbClr val="1E4A4D"/>
                 </a:solidFill>
                 <a:latin typeface="Inter"/>
               </a:rPr>
-              <a:t>(3)   UK data residency + audit by construction</a:t>
-            </a:r>
-          </a:p>
-        </p:txBody>
-      </p:sp>
-      <p:sp>
-        <p:nvSpPr>
-          <p:cNvPr id="17" name="TextBox 16"/>
+              <a:t>UK data residency + audit by construction</a:t>
+            </a:r>
+          </a:p>
+        </p:txBody>
+      </p:sp>
+      <p:sp>
+        <p:nvSpPr>
+          <p:cNvPr id="22" name="TextBox 21"/>
           <p:cNvSpPr txBox="1"/>
           <p:nvPr/>
         </p:nvSpPr>
         <p:spPr>
           <a:xfrm>
-            <a:off x="8953500" y="6083300"/>
+            <a:off x="8953500" y="6032500"/>
             <a:ext cx="2667000" cy="177800"/>
           </a:xfrm>
           <a:prstGeom prst="rect">
@@ -3793,7 +3966,7 @@
           <a:noFill/>
         </p:spPr>
         <p:txBody>
-          <a:bodyPr wrap="square" anchor="t" lIns="25400" rIns="25400" tIns="12700" bIns="12700">
+          <a:bodyPr wrap="square" anchor="t" lIns="25400" rIns="25400" tIns="25400" bIns="25400">
             <a:spAutoFit/>
           </a:bodyPr>
           <a:lstStyle/>
@@ -3806,18 +3979,150 @@
             <a:r>
               <a:rPr sz="750" b="0">
                 <a:solidFill>
-                  <a:srgbClr val="FFFFFF"/>
+                  <a:srgbClr val="1E4A4D"/>
                 </a:solidFill>
                 <a:latin typeface="Inter"/>
               </a:rPr>
-              <a:t>(4)   Augment people, never replace them</a:t>
-            </a:r>
-          </a:p>
-        </p:txBody>
-      </p:sp>
-      <p:sp>
-        <p:nvSpPr>
-          <p:cNvPr id="18" name="TextBox 17"/>
+              <a:t>Augment people, never replace them</a:t>
+            </a:r>
+          </a:p>
+        </p:txBody>
+      </p:sp>
+      <p:sp>
+        <p:nvSpPr>
+          <p:cNvPr id="23" name="Rectangle 22"/>
+          <p:cNvSpPr/>
+          <p:nvPr/>
+        </p:nvSpPr>
+        <p:spPr>
+          <a:xfrm>
+            <a:off x="3429000" y="6007100"/>
+            <a:ext cx="6350" cy="279400"/>
+          </a:xfrm>
+          <a:prstGeom prst="rect">
+            <a:avLst/>
+          </a:prstGeom>
+          <a:solidFill>
+            <a:srgbClr val="E5E7EB"/>
+          </a:solidFill>
+          <a:ln>
+            <a:noFill/>
+          </a:ln>
+          <a:effectLst/>
+        </p:spPr>
+        <p:style>
+          <a:lnRef idx="1">
+            <a:schemeClr val="accent1"/>
+          </a:lnRef>
+          <a:fillRef idx="3">
+            <a:schemeClr val="accent1"/>
+          </a:fillRef>
+          <a:effectRef idx="2">
+            <a:schemeClr val="accent1"/>
+          </a:effectRef>
+          <a:fontRef idx="minor">
+            <a:schemeClr val="lt1"/>
+          </a:fontRef>
+        </p:style>
+        <p:txBody>
+          <a:bodyPr rtlCol="0" anchor="ctr"/>
+          <a:lstStyle/>
+          <a:p>
+            <a:pPr algn="ctr"/>
+          </a:p>
+        </p:txBody>
+      </p:sp>
+      <p:sp>
+        <p:nvSpPr>
+          <p:cNvPr id="24" name="Rectangle 23"/>
+          <p:cNvSpPr/>
+          <p:nvPr/>
+        </p:nvSpPr>
+        <p:spPr>
+          <a:xfrm>
+            <a:off x="6184900" y="6007100"/>
+            <a:ext cx="6350" cy="279400"/>
+          </a:xfrm>
+          <a:prstGeom prst="rect">
+            <a:avLst/>
+          </a:prstGeom>
+          <a:solidFill>
+            <a:srgbClr val="E5E7EB"/>
+          </a:solidFill>
+          <a:ln>
+            <a:noFill/>
+          </a:ln>
+          <a:effectLst/>
+        </p:spPr>
+        <p:style>
+          <a:lnRef idx="1">
+            <a:schemeClr val="accent1"/>
+          </a:lnRef>
+          <a:fillRef idx="3">
+            <a:schemeClr val="accent1"/>
+          </a:fillRef>
+          <a:effectRef idx="2">
+            <a:schemeClr val="accent1"/>
+          </a:effectRef>
+          <a:fontRef idx="minor">
+            <a:schemeClr val="lt1"/>
+          </a:fontRef>
+        </p:style>
+        <p:txBody>
+          <a:bodyPr rtlCol="0" anchor="ctr"/>
+          <a:lstStyle/>
+          <a:p>
+            <a:pPr algn="ctr"/>
+          </a:p>
+        </p:txBody>
+      </p:sp>
+      <p:sp>
+        <p:nvSpPr>
+          <p:cNvPr id="25" name="Rectangle 24"/>
+          <p:cNvSpPr/>
+          <p:nvPr/>
+        </p:nvSpPr>
+        <p:spPr>
+          <a:xfrm>
+            <a:off x="8851900" y="6007100"/>
+            <a:ext cx="6350" cy="279400"/>
+          </a:xfrm>
+          <a:prstGeom prst="rect">
+            <a:avLst/>
+          </a:prstGeom>
+          <a:solidFill>
+            <a:srgbClr val="E5E7EB"/>
+          </a:solidFill>
+          <a:ln>
+            <a:noFill/>
+          </a:ln>
+          <a:effectLst/>
+        </p:spPr>
+        <p:style>
+          <a:lnRef idx="1">
+            <a:schemeClr val="accent1"/>
+          </a:lnRef>
+          <a:fillRef idx="3">
+            <a:schemeClr val="accent1"/>
+          </a:fillRef>
+          <a:effectRef idx="2">
+            <a:schemeClr val="accent1"/>
+          </a:effectRef>
+          <a:fontRef idx="minor">
+            <a:schemeClr val="lt1"/>
+          </a:fontRef>
+        </p:style>
+        <p:txBody>
+          <a:bodyPr rtlCol="0" anchor="ctr"/>
+          <a:lstStyle/>
+          <a:p>
+            <a:pPr algn="ctr"/>
+          </a:p>
+        </p:txBody>
+      </p:sp>
+      <p:sp>
+        <p:nvSpPr>
+          <p:cNvPr id="26" name="TextBox 25"/>
           <p:cNvSpPr txBox="1"/>
           <p:nvPr/>
         </p:nvSpPr>
@@ -3832,7 +4137,7 @@
           <a:noFill/>
         </p:spPr>
         <p:txBody>
-          <a:bodyPr wrap="square" anchor="t" lIns="25400" rIns="25400" tIns="12700" bIns="12700">
+          <a:bodyPr wrap="square" anchor="t" lIns="25400" rIns="25400" tIns="25400" bIns="25400">
             <a:spAutoFit/>
           </a:bodyPr>
           <a:lstStyle/>
@@ -3856,7 +4161,7 @@
       </p:sp>
       <p:sp>
         <p:nvSpPr>
-          <p:cNvPr id="19" name="TextBox 18"/>
+          <p:cNvPr id="27" name="TextBox 26"/>
           <p:cNvSpPr txBox="1"/>
           <p:nvPr/>
         </p:nvSpPr>
@@ -3871,7 +4176,7 @@
           <a:noFill/>
         </p:spPr>
         <p:txBody>
-          <a:bodyPr wrap="square" anchor="t" lIns="25400" rIns="25400" tIns="12700" bIns="12700">
+          <a:bodyPr wrap="square" anchor="t" lIns="25400" rIns="25400" tIns="25400" bIns="25400">
             <a:spAutoFit/>
           </a:bodyPr>
           <a:lstStyle/>
@@ -3972,7 +4277,7 @@
           <a:noFill/>
         </p:spPr>
         <p:txBody>
-          <a:bodyPr wrap="square" anchor="t" lIns="25400" rIns="25400" tIns="12700" bIns="12700">
+          <a:bodyPr wrap="square" anchor="t" lIns="25400" rIns="25400" tIns="25400" bIns="25400">
             <a:spAutoFit/>
           </a:bodyPr>
           <a:lstStyle/>
@@ -4011,7 +4316,7 @@
           <a:noFill/>
         </p:spPr>
         <p:txBody>
-          <a:bodyPr wrap="square" anchor="t" lIns="25400" rIns="25400" tIns="12700" bIns="12700">
+          <a:bodyPr wrap="square" anchor="t" lIns="25400" rIns="25400" tIns="25400" bIns="25400">
             <a:spAutoFit/>
           </a:bodyPr>
           <a:lstStyle/>
@@ -4050,7 +4355,7 @@
           <a:noFill/>
         </p:spPr>
         <p:txBody>
-          <a:bodyPr wrap="square" anchor="t" lIns="25400" rIns="25400" tIns="12700" bIns="12700">
+          <a:bodyPr wrap="square" anchor="t" lIns="25400" rIns="25400" tIns="25400" bIns="25400">
             <a:spAutoFit/>
           </a:bodyPr>
           <a:lstStyle/>
@@ -4181,7 +4486,7 @@
           <a:noFill/>
         </p:spPr>
         <p:txBody>
-          <a:bodyPr wrap="square" anchor="ctr" lIns="25400" rIns="25400" tIns="12700" bIns="12700">
+          <a:bodyPr wrap="square" anchor="ctr" lIns="25400" rIns="25400" tIns="25400" bIns="25400">
             <a:normAutofit/>
           </a:bodyPr>
           <a:lstStyle/>
@@ -4266,7 +4571,7 @@
           <a:noFill/>
         </p:spPr>
         <p:txBody>
-          <a:bodyPr wrap="square" anchor="ctr" lIns="25400" rIns="25400" tIns="12700" bIns="12700">
+          <a:bodyPr wrap="square" anchor="ctr" lIns="25400" rIns="25400" tIns="25400" bIns="25400">
             <a:normAutofit/>
           </a:bodyPr>
           <a:lstStyle/>
@@ -4351,7 +4656,7 @@
           <a:noFill/>
         </p:spPr>
         <p:txBody>
-          <a:bodyPr wrap="square" anchor="ctr" lIns="25400" rIns="25400" tIns="12700" bIns="12700">
+          <a:bodyPr wrap="square" anchor="ctr" lIns="25400" rIns="25400" tIns="25400" bIns="25400">
             <a:normAutofit/>
           </a:bodyPr>
           <a:lstStyle/>
@@ -4436,7 +4741,7 @@
           <a:noFill/>
         </p:spPr>
         <p:txBody>
-          <a:bodyPr wrap="square" anchor="ctr" lIns="25400" rIns="25400" tIns="12700" bIns="12700">
+          <a:bodyPr wrap="square" anchor="ctr" lIns="25400" rIns="25400" tIns="25400" bIns="25400">
             <a:normAutofit/>
           </a:bodyPr>
           <a:lstStyle/>
@@ -4521,7 +4826,7 @@
           <a:noFill/>
         </p:spPr>
         <p:txBody>
-          <a:bodyPr wrap="square" anchor="ctr" lIns="25400" rIns="25400" tIns="12700" bIns="12700">
+          <a:bodyPr wrap="square" anchor="ctr" lIns="25400" rIns="25400" tIns="25400" bIns="25400">
             <a:normAutofit/>
           </a:bodyPr>
           <a:lstStyle/>
@@ -4560,7 +4865,7 @@
           <a:noFill/>
         </p:spPr>
         <p:txBody>
-          <a:bodyPr wrap="square" anchor="t" lIns="25400" rIns="25400" tIns="12700" bIns="12700">
+          <a:bodyPr wrap="square" anchor="t" lIns="25400" rIns="25400" tIns="25400" bIns="25400">
             <a:spAutoFit/>
           </a:bodyPr>
           <a:lstStyle/>
@@ -4582,42 +4887,80 @@
           </a:p>
         </p:txBody>
       </p:sp>
-      <p:cxnSp>
-        <p:nvCxnSpPr>
-          <p:cNvPr id="18" name="Connector 17"/>
-          <p:cNvCxnSpPr/>
-          <p:nvPr/>
-        </p:nvCxnSpPr>
-        <p:spPr>
-          <a:xfrm>
-            <a:off x="1620520" y="3202940"/>
-            <a:ext cx="2237739" cy="91439"/>
-          </a:xfrm>
-          <a:prstGeom prst="line">
-            <a:avLst/>
-          </a:prstGeom>
-          <a:ln w="19050">
-            <a:solidFill>
-              <a:srgbClr val="2D6A6E"/>
-            </a:solidFill>
+      <p:sp>
+        <p:nvSpPr>
+          <p:cNvPr id="18" name="Freeform 17"/>
+          <p:cNvSpPr/>
+          <p:nvPr/>
+        </p:nvSpPr>
+        <p:spPr>
+          <a:xfrm>
+            <a:off x="1620520" y="2631440"/>
+            <a:ext cx="8950959" cy="797560"/>
+          </a:xfrm>
+          <a:custGeom>
+            <a:avLst/>
+            <a:gdLst/>
+            <a:ahLst/>
+            <a:cxnLst/>
+            <a:rect l="l" t="t" r="r" b="b"/>
+            <a:pathLst>
+              <a:path w="8950959" h="797560">
+                <a:moveTo>
+                  <a:pt x="0" y="797560"/>
+                </a:moveTo>
+                <a:lnTo>
+                  <a:pt x="0" y="544830"/>
+                </a:lnTo>
+                <a:lnTo>
+                  <a:pt x="2237739" y="628650"/>
+                </a:lnTo>
+                <a:lnTo>
+                  <a:pt x="4475480" y="321310"/>
+                </a:lnTo>
+                <a:lnTo>
+                  <a:pt x="6713219" y="125729"/>
+                </a:lnTo>
+                <a:lnTo>
+                  <a:pt x="8950959" y="0"/>
+                </a:lnTo>
+                <a:lnTo>
+                  <a:pt x="8950959" y="797560"/>
+                </a:lnTo>
+                <a:close/>
+              </a:path>
+            </a:pathLst>
+          </a:custGeom>
+          <a:solidFill>
+            <a:srgbClr val="D9E7E6"/>
+          </a:solidFill>
+          <a:ln>
+            <a:noFill/>
           </a:ln>
           <a:effectLst/>
         </p:spPr>
         <p:style>
-          <a:lnRef idx="2">
+          <a:lnRef idx="1">
             <a:schemeClr val="accent1"/>
           </a:lnRef>
-          <a:fillRef idx="0">
+          <a:fillRef idx="3">
             <a:schemeClr val="accent1"/>
           </a:fillRef>
-          <a:effectRef idx="1">
+          <a:effectRef idx="2">
             <a:schemeClr val="accent1"/>
           </a:effectRef>
           <a:fontRef idx="minor">
-            <a:schemeClr val="tx1"/>
+            <a:schemeClr val="lt1"/>
           </a:fontRef>
         </p:style>
-      </p:cxnSp>
+        <p:txBody>
+          <a:bodyPr rtlCol="0" anchor="ctr"/>
+          <a:lstStyle/>
+          <a:p>
+            <a:pPr algn="ctr"/>
+          </a:p>
+        </p:txBody>
+      </p:sp>
       <p:cxnSp>
         <p:nvCxnSpPr>
           <p:cNvPr id="19" name="Connector 18"/>
@@ -4625,16 +4968,16 @@
           <p:nvPr/>
         </p:nvCxnSpPr>
         <p:spPr>
-          <a:xfrm flipV="1">
-            <a:off x="3858259" y="2959100"/>
-            <a:ext cx="2237741" cy="335279"/>
+          <a:xfrm>
+            <a:off x="571500" y="3429000"/>
+            <a:ext cx="11049000" cy="0"/>
           </a:xfrm>
           <a:prstGeom prst="line">
             <a:avLst/>
           </a:prstGeom>
-          <a:ln w="19050">
+          <a:ln w="9525">
             <a:solidFill>
-              <a:srgbClr val="2D6A6E"/>
+              <a:srgbClr val="E5E7EB"/>
             </a:solidFill>
           </a:ln>
           <a:effectLst/>
@@ -4661,14 +5004,14 @@
           <p:nvPr/>
         </p:nvCxnSpPr>
         <p:spPr>
-          <a:xfrm flipV="1">
-            <a:off x="6096000" y="2745740"/>
-            <a:ext cx="2237739" cy="213360"/>
+          <a:xfrm>
+            <a:off x="1620520" y="3176270"/>
+            <a:ext cx="2237739" cy="83820"/>
           </a:xfrm>
           <a:prstGeom prst="line">
             <a:avLst/>
           </a:prstGeom>
-          <a:ln w="19050">
+          <a:ln w="25400">
             <a:solidFill>
               <a:srgbClr val="2D6A6E"/>
             </a:solidFill>
@@ -4698,13 +5041,13 @@
         </p:nvCxnSpPr>
         <p:spPr>
           <a:xfrm flipV="1">
-            <a:off x="8333739" y="2608580"/>
-            <a:ext cx="2237740" cy="137160"/>
+            <a:off x="3858259" y="2952750"/>
+            <a:ext cx="2237741" cy="307340"/>
           </a:xfrm>
           <a:prstGeom prst="line">
             <a:avLst/>
           </a:prstGeom>
-          <a:ln w="19050">
+          <a:ln w="25400">
             <a:solidFill>
               <a:srgbClr val="2D6A6E"/>
             </a:solidFill>
@@ -4726,16 +5069,88 @@
           </a:fontRef>
         </p:style>
       </p:cxnSp>
-      <p:sp>
-        <p:nvSpPr>
-          <p:cNvPr id="22" name="Oval 21"/>
+      <p:cxnSp>
+        <p:nvCxnSpPr>
+          <p:cNvPr id="22" name="Connector 21"/>
+          <p:cNvCxnSpPr/>
+          <p:nvPr/>
+        </p:nvCxnSpPr>
+        <p:spPr>
+          <a:xfrm flipV="1">
+            <a:off x="6096000" y="2757169"/>
+            <a:ext cx="2237739" cy="195581"/>
+          </a:xfrm>
+          <a:prstGeom prst="line">
+            <a:avLst/>
+          </a:prstGeom>
+          <a:ln w="25400">
+            <a:solidFill>
+              <a:srgbClr val="2D6A6E"/>
+            </a:solidFill>
+          </a:ln>
+          <a:effectLst/>
+        </p:spPr>
+        <p:style>
+          <a:lnRef idx="2">
+            <a:schemeClr val="accent1"/>
+          </a:lnRef>
+          <a:fillRef idx="0">
+            <a:schemeClr val="accent1"/>
+          </a:fillRef>
+          <a:effectRef idx="1">
+            <a:schemeClr val="accent1"/>
+          </a:effectRef>
+          <a:fontRef idx="minor">
+            <a:schemeClr val="tx1"/>
+          </a:fontRef>
+        </p:style>
+      </p:cxnSp>
+      <p:cxnSp>
+        <p:nvCxnSpPr>
+          <p:cNvPr id="23" name="Connector 22"/>
+          <p:cNvCxnSpPr/>
+          <p:nvPr/>
+        </p:nvCxnSpPr>
+        <p:spPr>
+          <a:xfrm flipV="1">
+            <a:off x="8333739" y="2631440"/>
+            <a:ext cx="2237740" cy="125729"/>
+          </a:xfrm>
+          <a:prstGeom prst="line">
+            <a:avLst/>
+          </a:prstGeom>
+          <a:ln w="25400">
+            <a:solidFill>
+              <a:srgbClr val="2D6A6E"/>
+            </a:solidFill>
+          </a:ln>
+          <a:effectLst/>
+        </p:spPr>
+        <p:style>
+          <a:lnRef idx="2">
+            <a:schemeClr val="accent1"/>
+          </a:lnRef>
+          <a:fillRef idx="0">
+            <a:schemeClr val="accent1"/>
+          </a:fillRef>
+          <a:effectRef idx="1">
+            <a:schemeClr val="accent1"/>
+          </a:effectRef>
+          <a:fontRef idx="minor">
+            <a:schemeClr val="tx1"/>
+          </a:fontRef>
+        </p:style>
+      </p:cxnSp>
+      <p:sp>
+        <p:nvSpPr>
+          <p:cNvPr id="24" name="Oval 23"/>
           <p:cNvSpPr/>
           <p:nvPr/>
         </p:nvSpPr>
         <p:spPr>
           <a:xfrm>
-            <a:off x="1569720" y="3152139"/>
-            <a:ext cx="101600" cy="101600"/>
+            <a:off x="1557020" y="3112770"/>
+            <a:ext cx="127000" cy="127000"/>
           </a:xfrm>
           <a:prstGeom prst="ellipse">
             <a:avLst/>
@@ -4745,7 +5160,7 @@
           </a:solidFill>
           <a:ln w="19050">
             <a:solidFill>
-              <a:srgbClr val="FAFAF7"/>
+              <a:srgbClr val="FFFFFF"/>
             </a:solidFill>
           </a:ln>
           <a:effectLst/>
@@ -4774,14 +5189,14 @@
       </p:sp>
       <p:sp>
         <p:nvSpPr>
-          <p:cNvPr id="23" name="TextBox 22"/>
+          <p:cNvPr id="25" name="TextBox 24"/>
           <p:cNvSpPr txBox="1"/>
           <p:nvPr/>
         </p:nvSpPr>
         <p:spPr>
           <a:xfrm>
-            <a:off x="571500" y="3479800"/>
-            <a:ext cx="2098040" cy="165100"/>
+            <a:off x="571500" y="3530600"/>
+            <a:ext cx="2098040" cy="152400"/>
           </a:xfrm>
           <a:prstGeom prst="rect">
             <a:avLst/>
@@ -4789,7 +5204,7 @@
           <a:noFill/>
         </p:spPr>
         <p:txBody>
-          <a:bodyPr wrap="square" anchor="ctr" lIns="25400" rIns="25400" tIns="12700" bIns="12700">
+          <a:bodyPr wrap="square" anchor="ctr" lIns="25400" rIns="25400" tIns="25400" bIns="25400">
             <a:spAutoFit/>
           </a:bodyPr>
           <a:lstStyle/>
@@ -4800,7 +5215,7 @@
               </a:spcAft>
             </a:pPr>
             <a:r>
-              <a:rPr sz="800" b="1">
+              <a:rPr sz="850" b="1">
                 <a:solidFill>
                   <a:srgbClr val="2D6A6E"/>
                 </a:solidFill>
@@ -4813,14 +5228,53 @@
       </p:sp>
       <p:sp>
         <p:nvSpPr>
-          <p:cNvPr id="24" name="Oval 23"/>
+          <p:cNvPr id="26" name="TextBox 25"/>
+          <p:cNvSpPr txBox="1"/>
+          <p:nvPr/>
+        </p:nvSpPr>
+        <p:spPr>
+          <a:xfrm>
+            <a:off x="571500" y="3695700"/>
+            <a:ext cx="2098040" cy="139700"/>
+          </a:xfrm>
+          <a:prstGeom prst="rect">
+            <a:avLst/>
+          </a:prstGeom>
+          <a:noFill/>
+        </p:spPr>
+        <p:txBody>
+          <a:bodyPr wrap="square" anchor="ctr" lIns="25400" rIns="25400" tIns="25400" bIns="25400">
+            <a:spAutoFit/>
+          </a:bodyPr>
+          <a:lstStyle/>
+          <a:p>
+            <a:pPr algn="ctr">
+              <a:spcAft>
+                <a:spcPts val="0"/>
+              </a:spcAft>
+            </a:pPr>
+            <a:r>
+              <a:rPr sz="675" b="0">
+                <a:solidFill>
+                  <a:srgbClr val="4A5B6B"/>
+                </a:solidFill>
+                <a:latin typeface="Inter"/>
+              </a:rPr>
+              <a:t>unsure where to start</a:t>
+            </a:r>
+          </a:p>
+        </p:txBody>
+      </p:sp>
+      <p:sp>
+        <p:nvSpPr>
+          <p:cNvPr id="27" name="Oval 26"/>
           <p:cNvSpPr/>
           <p:nvPr/>
         </p:nvSpPr>
         <p:spPr>
           <a:xfrm>
-            <a:off x="3807459" y="3243580"/>
-            <a:ext cx="101600" cy="101600"/>
+            <a:off x="3794759" y="3196590"/>
+            <a:ext cx="127000" cy="127000"/>
           </a:xfrm>
           <a:prstGeom prst="ellipse">
             <a:avLst/>
@@ -4830,7 +5284,7 @@
           </a:solidFill>
           <a:ln w="19050">
             <a:solidFill>
-              <a:srgbClr val="FAFAF7"/>
+              <a:srgbClr val="FFFFFF"/>
             </a:solidFill>
           </a:ln>
           <a:effectLst/>
@@ -4859,14 +5313,14 @@
       </p:sp>
       <p:sp>
         <p:nvSpPr>
-          <p:cNvPr id="25" name="TextBox 24"/>
+          <p:cNvPr id="28" name="TextBox 27"/>
           <p:cNvSpPr txBox="1"/>
           <p:nvPr/>
         </p:nvSpPr>
         <p:spPr>
           <a:xfrm>
-            <a:off x="2809239" y="3479800"/>
-            <a:ext cx="2098040" cy="165100"/>
+            <a:off x="2809239" y="3530600"/>
+            <a:ext cx="2098040" cy="152400"/>
           </a:xfrm>
           <a:prstGeom prst="rect">
             <a:avLst/>
@@ -4874,7 +5328,7 @@
           <a:noFill/>
         </p:spPr>
         <p:txBody>
-          <a:bodyPr wrap="square" anchor="ctr" lIns="25400" rIns="25400" tIns="12700" bIns="12700">
+          <a:bodyPr wrap="square" anchor="ctr" lIns="25400" rIns="25400" tIns="25400" bIns="25400">
             <a:spAutoFit/>
           </a:bodyPr>
           <a:lstStyle/>
@@ -4885,7 +5339,7 @@
               </a:spcAft>
             </a:pPr>
             <a:r>
-              <a:rPr sz="800" b="1">
+              <a:rPr sz="850" b="1">
                 <a:solidFill>
                   <a:srgbClr val="2D6A6E"/>
                 </a:solidFill>
@@ -4898,14 +5352,53 @@
       </p:sp>
       <p:sp>
         <p:nvSpPr>
-          <p:cNvPr id="26" name="Oval 25"/>
+          <p:cNvPr id="29" name="TextBox 28"/>
+          <p:cNvSpPr txBox="1"/>
+          <p:nvPr/>
+        </p:nvSpPr>
+        <p:spPr>
+          <a:xfrm>
+            <a:off x="2809239" y="3695700"/>
+            <a:ext cx="2098040" cy="139700"/>
+          </a:xfrm>
+          <a:prstGeom prst="rect">
+            <a:avLst/>
+          </a:prstGeom>
+          <a:noFill/>
+        </p:spPr>
+        <p:txBody>
+          <a:bodyPr wrap="square" anchor="ctr" lIns="25400" rIns="25400" tIns="25400" bIns="25400">
+            <a:spAutoFit/>
+          </a:bodyPr>
+          <a:lstStyle/>
+          <a:p>
+            <a:pPr algn="ctr">
+              <a:spcAft>
+                <a:spcPts val="0"/>
+              </a:spcAft>
+            </a:pPr>
+            <a:r>
+              <a:rPr sz="675" b="0">
+                <a:solidFill>
+                  <a:srgbClr val="4A5B6B"/>
+                </a:solidFill>
+                <a:latin typeface="Inter"/>
+              </a:rPr>
+              <a:t>so much to take in</a:t>
+            </a:r>
+          </a:p>
+        </p:txBody>
+      </p:sp>
+      <p:sp>
+        <p:nvSpPr>
+          <p:cNvPr id="30" name="Oval 29"/>
           <p:cNvSpPr/>
           <p:nvPr/>
         </p:nvSpPr>
         <p:spPr>
           <a:xfrm>
-            <a:off x="6045200" y="2908300"/>
-            <a:ext cx="101600" cy="101600"/>
+            <a:off x="6032500" y="2889250"/>
+            <a:ext cx="127000" cy="127000"/>
           </a:xfrm>
           <a:prstGeom prst="ellipse">
             <a:avLst/>
@@ -4915,7 +5408,7 @@
           </a:solidFill>
           <a:ln w="19050">
             <a:solidFill>
-              <a:srgbClr val="FAFAF7"/>
+              <a:srgbClr val="FFFFFF"/>
             </a:solidFill>
           </a:ln>
           <a:effectLst/>
@@ -4944,14 +5437,14 @@
       </p:sp>
       <p:sp>
         <p:nvSpPr>
-          <p:cNvPr id="27" name="TextBox 26"/>
+          <p:cNvPr id="31" name="TextBox 30"/>
           <p:cNvSpPr txBox="1"/>
           <p:nvPr/>
         </p:nvSpPr>
         <p:spPr>
           <a:xfrm>
-            <a:off x="5046979" y="3479800"/>
-            <a:ext cx="2098040" cy="165100"/>
+            <a:off x="5046979" y="3530600"/>
+            <a:ext cx="2098040" cy="152400"/>
           </a:xfrm>
           <a:prstGeom prst="rect">
             <a:avLst/>
@@ -4959,7 +5452,7 @@
           <a:noFill/>
         </p:spPr>
         <p:txBody>
-          <a:bodyPr wrap="square" anchor="ctr" lIns="25400" rIns="25400" tIns="12700" bIns="12700">
+          <a:bodyPr wrap="square" anchor="ctr" lIns="25400" rIns="25400" tIns="25400" bIns="25400">
             <a:spAutoFit/>
           </a:bodyPr>
           <a:lstStyle/>
@@ -4970,7 +5463,7 @@
               </a:spcAft>
             </a:pPr>
             <a:r>
-              <a:rPr sz="800" b="1">
+              <a:rPr sz="850" b="1">
                 <a:solidFill>
                   <a:srgbClr val="2D6A6E"/>
                 </a:solidFill>
@@ -4983,14 +5476,53 @@
       </p:sp>
       <p:sp>
         <p:nvSpPr>
-          <p:cNvPr id="28" name="Oval 27"/>
+          <p:cNvPr id="32" name="TextBox 31"/>
+          <p:cNvSpPr txBox="1"/>
+          <p:nvPr/>
+        </p:nvSpPr>
+        <p:spPr>
+          <a:xfrm>
+            <a:off x="5046979" y="3695700"/>
+            <a:ext cx="2098040" cy="139700"/>
+          </a:xfrm>
+          <a:prstGeom prst="rect">
+            <a:avLst/>
+          </a:prstGeom>
+          <a:noFill/>
+        </p:spPr>
+        <p:txBody>
+          <a:bodyPr wrap="square" anchor="ctr" lIns="25400" rIns="25400" tIns="25400" bIns="25400">
+            <a:spAutoFit/>
+          </a:bodyPr>
+          <a:lstStyle/>
+          <a:p>
+            <a:pPr algn="ctr">
+              <a:spcAft>
+                <a:spcPts val="0"/>
+              </a:spcAft>
+            </a:pPr>
+            <a:r>
+              <a:rPr sz="675" b="0">
+                <a:solidFill>
+                  <a:srgbClr val="4A5B6B"/>
+                </a:solidFill>
+                <a:latin typeface="Inter"/>
+              </a:rPr>
+              <a:t>a clear path forward</a:t>
+            </a:r>
+          </a:p>
+        </p:txBody>
+      </p:sp>
+      <p:sp>
+        <p:nvSpPr>
+          <p:cNvPr id="33" name="Oval 32"/>
           <p:cNvSpPr/>
           <p:nvPr/>
         </p:nvSpPr>
         <p:spPr>
           <a:xfrm>
-            <a:off x="8282939" y="2694939"/>
-            <a:ext cx="101600" cy="101600"/>
+            <a:off x="8270240" y="2693670"/>
+            <a:ext cx="127000" cy="127000"/>
           </a:xfrm>
           <a:prstGeom prst="ellipse">
             <a:avLst/>
@@ -5000,7 +5532,7 @@
           </a:solidFill>
           <a:ln w="19050">
             <a:solidFill>
-              <a:srgbClr val="FAFAF7"/>
+              <a:srgbClr val="FFFFFF"/>
             </a:solidFill>
           </a:ln>
           <a:effectLst/>
@@ -5029,14 +5561,14 @@
       </p:sp>
       <p:sp>
         <p:nvSpPr>
-          <p:cNvPr id="29" name="TextBox 28"/>
+          <p:cNvPr id="34" name="TextBox 33"/>
           <p:cNvSpPr txBox="1"/>
           <p:nvPr/>
         </p:nvSpPr>
         <p:spPr>
           <a:xfrm>
-            <a:off x="7284719" y="3479800"/>
-            <a:ext cx="2098040" cy="165100"/>
+            <a:off x="7284719" y="3530600"/>
+            <a:ext cx="2098040" cy="152400"/>
           </a:xfrm>
           <a:prstGeom prst="rect">
             <a:avLst/>
@@ -5044,7 +5576,7 @@
           <a:noFill/>
         </p:spPr>
         <p:txBody>
-          <a:bodyPr wrap="square" anchor="ctr" lIns="25400" rIns="25400" tIns="12700" bIns="12700">
+          <a:bodyPr wrap="square" anchor="ctr" lIns="25400" rIns="25400" tIns="25400" bIns="25400">
             <a:spAutoFit/>
           </a:bodyPr>
           <a:lstStyle/>
@@ -5055,7 +5587,7 @@
               </a:spcAft>
             </a:pPr>
             <a:r>
-              <a:rPr sz="800" b="1">
+              <a:rPr sz="850" b="1">
                 <a:solidFill>
                   <a:srgbClr val="2D6A6E"/>
                 </a:solidFill>
@@ -5068,14 +5600,53 @@
       </p:sp>
       <p:sp>
         <p:nvSpPr>
-          <p:cNvPr id="30" name="Oval 29"/>
+          <p:cNvPr id="35" name="TextBox 34"/>
+          <p:cNvSpPr txBox="1"/>
+          <p:nvPr/>
+        </p:nvSpPr>
+        <p:spPr>
+          <a:xfrm>
+            <a:off x="7284719" y="3695700"/>
+            <a:ext cx="2098040" cy="139700"/>
+          </a:xfrm>
+          <a:prstGeom prst="rect">
+            <a:avLst/>
+          </a:prstGeom>
+          <a:noFill/>
+        </p:spPr>
+        <p:txBody>
+          <a:bodyPr wrap="square" anchor="ctr" lIns="25400" rIns="25400" tIns="25400" bIns="25400">
+            <a:spAutoFit/>
+          </a:bodyPr>
+          <a:lstStyle/>
+          <a:p>
+            <a:pPr algn="ctr">
+              <a:spcAft>
+                <a:spcPts val="0"/>
+              </a:spcAft>
+            </a:pPr>
+            <a:r>
+              <a:rPr sz="675" b="0">
+                <a:solidFill>
+                  <a:srgbClr val="4A5B6B"/>
+                </a:solidFill>
+                <a:latin typeface="Inter"/>
+              </a:rPr>
+              <a:t>kept in the loop</a:t>
+            </a:r>
+          </a:p>
+        </p:txBody>
+      </p:sp>
+      <p:sp>
+        <p:nvSpPr>
+          <p:cNvPr id="36" name="Oval 35"/>
           <p:cNvSpPr/>
           <p:nvPr/>
         </p:nvSpPr>
         <p:spPr>
           <a:xfrm>
-            <a:off x="10520680" y="2557780"/>
-            <a:ext cx="101600" cy="101600"/>
+            <a:off x="10507980" y="2567940"/>
+            <a:ext cx="127000" cy="127000"/>
           </a:xfrm>
           <a:prstGeom prst="ellipse">
             <a:avLst/>
@@ -5085,7 +5656,7 @@
           </a:solidFill>
           <a:ln w="19050">
             <a:solidFill>
-              <a:srgbClr val="FAFAF7"/>
+              <a:srgbClr val="FFFFFF"/>
             </a:solidFill>
           </a:ln>
           <a:effectLst/>
@@ -5114,14 +5685,14 @@
       </p:sp>
       <p:sp>
         <p:nvSpPr>
-          <p:cNvPr id="31" name="TextBox 30"/>
+          <p:cNvPr id="37" name="TextBox 36"/>
           <p:cNvSpPr txBox="1"/>
           <p:nvPr/>
         </p:nvSpPr>
         <p:spPr>
           <a:xfrm>
-            <a:off x="9522459" y="3479800"/>
-            <a:ext cx="2098040" cy="165100"/>
+            <a:off x="9522459" y="3530600"/>
+            <a:ext cx="2098040" cy="152400"/>
           </a:xfrm>
           <a:prstGeom prst="rect">
             <a:avLst/>
@@ -5129,7 +5700,7 @@
           <a:noFill/>
         </p:spPr>
         <p:txBody>
-          <a:bodyPr wrap="square" anchor="ctr" lIns="25400" rIns="25400" tIns="12700" bIns="12700">
+          <a:bodyPr wrap="square" anchor="ctr" lIns="25400" rIns="25400" tIns="25400" bIns="25400">
             <a:spAutoFit/>
           </a:bodyPr>
           <a:lstStyle/>
@@ -5140,7 +5711,7 @@
               </a:spcAft>
             </a:pPr>
             <a:r>
-              <a:rPr sz="800" b="1">
+              <a:rPr sz="850" b="1">
                 <a:solidFill>
                   <a:srgbClr val="2D6A6E"/>
                 </a:solidFill>
@@ -5153,13 +5724,52 @@
       </p:sp>
       <p:sp>
         <p:nvSpPr>
-          <p:cNvPr id="32" name="TextBox 31"/>
+          <p:cNvPr id="38" name="TextBox 37"/>
           <p:cNvSpPr txBox="1"/>
           <p:nvPr/>
         </p:nvSpPr>
         <p:spPr>
           <a:xfrm>
-            <a:off x="571500" y="3835400"/>
+            <a:off x="9522459" y="3695700"/>
+            <a:ext cx="2098040" cy="139700"/>
+          </a:xfrm>
+          <a:prstGeom prst="rect">
+            <a:avLst/>
+          </a:prstGeom>
+          <a:noFill/>
+        </p:spPr>
+        <p:txBody>
+          <a:bodyPr wrap="square" anchor="ctr" lIns="25400" rIns="25400" tIns="25400" bIns="25400">
+            <a:spAutoFit/>
+          </a:bodyPr>
+          <a:lstStyle/>
+          <a:p>
+            <a:pPr algn="ctr">
+              <a:spcAft>
+                <a:spcPts val="0"/>
+              </a:spcAft>
+            </a:pPr>
+            <a:r>
+              <a:rPr sz="675" b="0">
+                <a:solidFill>
+                  <a:srgbClr val="4A5B6B"/>
+                </a:solidFill>
+                <a:latin typeface="Inter"/>
+              </a:rPr>
+              <a:t>confident &amp; in control</a:t>
+            </a:r>
+          </a:p>
+        </p:txBody>
+      </p:sp>
+      <p:sp>
+        <p:nvSpPr>
+          <p:cNvPr id="39" name="TextBox 38"/>
+          <p:cNvSpPr txBox="1"/>
+          <p:nvPr/>
+        </p:nvSpPr>
+        <p:spPr>
+          <a:xfrm>
+            <a:off x="571500" y="4038600"/>
             <a:ext cx="5715000" cy="152400"/>
           </a:xfrm>
           <a:prstGeom prst="rect">
@@ -5168,7 +5778,7 @@
           <a:noFill/>
         </p:spPr>
         <p:txBody>
-          <a:bodyPr wrap="square" anchor="t" lIns="25400" rIns="25400" tIns="12700" bIns="12700">
+          <a:bodyPr wrap="square" anchor="t" lIns="25400" rIns="25400" tIns="25400" bIns="25400">
             <a:spAutoFit/>
           </a:bodyPr>
           <a:lstStyle/>
@@ -5192,22 +5802,22 @@
       </p:sp>
       <p:sp>
         <p:nvSpPr>
-          <p:cNvPr id="33" name="Rounded Rectangle 32"/>
+          <p:cNvPr id="40" name="Rounded Rectangle 39"/>
           <p:cNvSpPr/>
           <p:nvPr/>
         </p:nvSpPr>
         <p:spPr>
           <a:xfrm>
-            <a:off x="571500" y="4038600"/>
-            <a:ext cx="2098040" cy="749300"/>
+            <a:off x="571500" y="4241800"/>
+            <a:ext cx="2098040" cy="736600"/>
           </a:xfrm>
           <a:prstGeom prst="roundRect">
             <a:avLst>
-              <a:gd name="adj" fmla="val 10169"/>
+              <a:gd name="adj" fmla="val 10344"/>
             </a:avLst>
           </a:prstGeom>
           <a:solidFill>
-            <a:srgbClr val="FBF7F1"/>
+            <a:srgbClr val="F2F5F6"/>
           </a:solidFill>
           <a:ln w="12700">
             <a:solidFill>
@@ -5240,14 +5850,58 @@
       </p:sp>
       <p:sp>
         <p:nvSpPr>
-          <p:cNvPr id="34" name="TextBox 33"/>
+          <p:cNvPr id="41" name="Oval 40"/>
+          <p:cNvSpPr/>
+          <p:nvPr/>
+        </p:nvSpPr>
+        <p:spPr>
+          <a:xfrm>
+            <a:off x="673100" y="4343400"/>
+            <a:ext cx="57150" cy="57150"/>
+          </a:xfrm>
+          <a:prstGeom prst="ellipse">
+            <a:avLst/>
+          </a:prstGeom>
+          <a:solidFill>
+            <a:srgbClr val="F2A878"/>
+          </a:solidFill>
+          <a:ln>
+            <a:noFill/>
+          </a:ln>
+          <a:effectLst/>
+        </p:spPr>
+        <p:style>
+          <a:lnRef idx="1">
+            <a:schemeClr val="accent1"/>
+          </a:lnRef>
+          <a:fillRef idx="3">
+            <a:schemeClr val="accent1"/>
+          </a:fillRef>
+          <a:effectRef idx="2">
+            <a:schemeClr val="accent1"/>
+          </a:effectRef>
+          <a:fontRef idx="minor">
+            <a:schemeClr val="lt1"/>
+          </a:fontRef>
+        </p:style>
+        <p:txBody>
+          <a:bodyPr rtlCol="0" anchor="ctr"/>
+          <a:lstStyle/>
+          <a:p>
+            <a:pPr algn="ctr"/>
+          </a:p>
+        </p:txBody>
+      </p:sp>
+      <p:sp>
+        <p:nvSpPr>
+          <p:cNvPr id="42" name="TextBox 41"/>
           <p:cNvSpPr txBox="1"/>
           <p:nvPr/>
         </p:nvSpPr>
         <p:spPr>
           <a:xfrm>
-            <a:off x="660400" y="4038600"/>
-            <a:ext cx="1920239" cy="749300"/>
+            <a:off x="673100" y="4241800"/>
+            <a:ext cx="1894839" cy="736600"/>
           </a:xfrm>
           <a:prstGeom prst="rect">
             <a:avLst/>
@@ -5255,7 +5909,7 @@
           <a:noFill/>
         </p:spPr>
         <p:txBody>
-          <a:bodyPr wrap="square" anchor="ctr" lIns="25400" rIns="25400" tIns="12700" bIns="12700">
+          <a:bodyPr wrap="square" anchor="ctr" lIns="25400" rIns="25400" tIns="25400" bIns="25400">
             <a:normAutofit/>
           </a:bodyPr>
           <a:lstStyle/>
@@ -5268,7 +5922,7 @@
             <a:r>
               <a:rPr sz="800" b="0">
                 <a:solidFill>
-                  <a:srgbClr val="7A3B2E"/>
+                  <a:srgbClr val="3A4A55"/>
                 </a:solidFill>
                 <a:latin typeface="Inter"/>
               </a:rPr>
@@ -5279,22 +5933,22 @@
       </p:sp>
       <p:sp>
         <p:nvSpPr>
-          <p:cNvPr id="35" name="Rounded Rectangle 34"/>
+          <p:cNvPr id="43" name="Rounded Rectangle 42"/>
           <p:cNvSpPr/>
           <p:nvPr/>
         </p:nvSpPr>
         <p:spPr>
           <a:xfrm>
-            <a:off x="2809239" y="4038600"/>
-            <a:ext cx="2098040" cy="749300"/>
+            <a:off x="2809239" y="4241800"/>
+            <a:ext cx="2098040" cy="736600"/>
           </a:xfrm>
           <a:prstGeom prst="roundRect">
             <a:avLst>
-              <a:gd name="adj" fmla="val 10169"/>
+              <a:gd name="adj" fmla="val 10344"/>
             </a:avLst>
           </a:prstGeom>
           <a:solidFill>
-            <a:srgbClr val="FBF7F1"/>
+            <a:srgbClr val="F2F5F6"/>
           </a:solidFill>
           <a:ln w="12700">
             <a:solidFill>
@@ -5327,14 +5981,58 @@
       </p:sp>
       <p:sp>
         <p:nvSpPr>
-          <p:cNvPr id="36" name="TextBox 35"/>
+          <p:cNvPr id="44" name="Oval 43"/>
+          <p:cNvSpPr/>
+          <p:nvPr/>
+        </p:nvSpPr>
+        <p:spPr>
+          <a:xfrm>
+            <a:off x="2910840" y="4343400"/>
+            <a:ext cx="57150" cy="57150"/>
+          </a:xfrm>
+          <a:prstGeom prst="ellipse">
+            <a:avLst/>
+          </a:prstGeom>
+          <a:solidFill>
+            <a:srgbClr val="F2A878"/>
+          </a:solidFill>
+          <a:ln>
+            <a:noFill/>
+          </a:ln>
+          <a:effectLst/>
+        </p:spPr>
+        <p:style>
+          <a:lnRef idx="1">
+            <a:schemeClr val="accent1"/>
+          </a:lnRef>
+          <a:fillRef idx="3">
+            <a:schemeClr val="accent1"/>
+          </a:fillRef>
+          <a:effectRef idx="2">
+            <a:schemeClr val="accent1"/>
+          </a:effectRef>
+          <a:fontRef idx="minor">
+            <a:schemeClr val="lt1"/>
+          </a:fontRef>
+        </p:style>
+        <p:txBody>
+          <a:bodyPr rtlCol="0" anchor="ctr"/>
+          <a:lstStyle/>
+          <a:p>
+            <a:pPr algn="ctr"/>
+          </a:p>
+        </p:txBody>
+      </p:sp>
+      <p:sp>
+        <p:nvSpPr>
+          <p:cNvPr id="45" name="TextBox 44"/>
           <p:cNvSpPr txBox="1"/>
           <p:nvPr/>
         </p:nvSpPr>
         <p:spPr>
           <a:xfrm>
-            <a:off x="2898140" y="4038600"/>
-            <a:ext cx="1920239" cy="749300"/>
+            <a:off x="2910840" y="4241800"/>
+            <a:ext cx="1894839" cy="736600"/>
           </a:xfrm>
           <a:prstGeom prst="rect">
             <a:avLst/>
@@ -5342,7 +6040,7 @@
           <a:noFill/>
         </p:spPr>
         <p:txBody>
-          <a:bodyPr wrap="square" anchor="ctr" lIns="25400" rIns="25400" tIns="12700" bIns="12700">
+          <a:bodyPr wrap="square" anchor="ctr" lIns="25400" rIns="25400" tIns="25400" bIns="25400">
             <a:normAutofit/>
           </a:bodyPr>
           <a:lstStyle/>
@@ -5355,7 +6053,7 @@
             <a:r>
               <a:rPr sz="800" b="0">
                 <a:solidFill>
-                  <a:srgbClr val="7A3B2E"/>
+                  <a:srgbClr val="3A4A55"/>
                 </a:solidFill>
                 <a:latin typeface="Inter"/>
               </a:rPr>
@@ -5366,22 +6064,22 @@
       </p:sp>
       <p:sp>
         <p:nvSpPr>
-          <p:cNvPr id="37" name="Rounded Rectangle 36"/>
+          <p:cNvPr id="46" name="Rounded Rectangle 45"/>
           <p:cNvSpPr/>
           <p:nvPr/>
         </p:nvSpPr>
         <p:spPr>
           <a:xfrm>
-            <a:off x="5046979" y="4038600"/>
-            <a:ext cx="2098040" cy="749300"/>
+            <a:off x="5046979" y="4241800"/>
+            <a:ext cx="2098040" cy="736600"/>
           </a:xfrm>
           <a:prstGeom prst="roundRect">
             <a:avLst>
-              <a:gd name="adj" fmla="val 10169"/>
+              <a:gd name="adj" fmla="val 10344"/>
             </a:avLst>
           </a:prstGeom>
           <a:solidFill>
-            <a:srgbClr val="FBF7F1"/>
+            <a:srgbClr val="F2F5F6"/>
           </a:solidFill>
           <a:ln w="12700">
             <a:solidFill>
@@ -5414,14 +6112,58 @@
       </p:sp>
       <p:sp>
         <p:nvSpPr>
-          <p:cNvPr id="38" name="TextBox 37"/>
+          <p:cNvPr id="47" name="Oval 46"/>
+          <p:cNvSpPr/>
+          <p:nvPr/>
+        </p:nvSpPr>
+        <p:spPr>
+          <a:xfrm>
+            <a:off x="5148580" y="4343400"/>
+            <a:ext cx="57150" cy="57150"/>
+          </a:xfrm>
+          <a:prstGeom prst="ellipse">
+            <a:avLst/>
+          </a:prstGeom>
+          <a:solidFill>
+            <a:srgbClr val="F2A878"/>
+          </a:solidFill>
+          <a:ln>
+            <a:noFill/>
+          </a:ln>
+          <a:effectLst/>
+        </p:spPr>
+        <p:style>
+          <a:lnRef idx="1">
+            <a:schemeClr val="accent1"/>
+          </a:lnRef>
+          <a:fillRef idx="3">
+            <a:schemeClr val="accent1"/>
+          </a:fillRef>
+          <a:effectRef idx="2">
+            <a:schemeClr val="accent1"/>
+          </a:effectRef>
+          <a:fontRef idx="minor">
+            <a:schemeClr val="lt1"/>
+          </a:fontRef>
+        </p:style>
+        <p:txBody>
+          <a:bodyPr rtlCol="0" anchor="ctr"/>
+          <a:lstStyle/>
+          <a:p>
+            <a:pPr algn="ctr"/>
+          </a:p>
+        </p:txBody>
+      </p:sp>
+      <p:sp>
+        <p:nvSpPr>
+          <p:cNvPr id="48" name="TextBox 47"/>
           <p:cNvSpPr txBox="1"/>
           <p:nvPr/>
         </p:nvSpPr>
         <p:spPr>
           <a:xfrm>
-            <a:off x="5135880" y="4038600"/>
-            <a:ext cx="1920239" cy="749300"/>
+            <a:off x="5148580" y="4241800"/>
+            <a:ext cx="1894839" cy="736600"/>
           </a:xfrm>
           <a:prstGeom prst="rect">
             <a:avLst/>
@@ -5429,7 +6171,7 @@
           <a:noFill/>
         </p:spPr>
         <p:txBody>
-          <a:bodyPr wrap="square" anchor="ctr" lIns="25400" rIns="25400" tIns="12700" bIns="12700">
+          <a:bodyPr wrap="square" anchor="ctr" lIns="25400" rIns="25400" tIns="25400" bIns="25400">
             <a:normAutofit/>
           </a:bodyPr>
           <a:lstStyle/>
@@ -5442,7 +6184,7 @@
             <a:r>
               <a:rPr sz="800" b="0">
                 <a:solidFill>
-                  <a:srgbClr val="7A3B2E"/>
+                  <a:srgbClr val="3A4A55"/>
                 </a:solidFill>
                 <a:latin typeface="Inter"/>
               </a:rPr>
@@ -5453,22 +6195,22 @@
       </p:sp>
       <p:sp>
         <p:nvSpPr>
-          <p:cNvPr id="39" name="Rounded Rectangle 38"/>
+          <p:cNvPr id="49" name="Rounded Rectangle 48"/>
           <p:cNvSpPr/>
           <p:nvPr/>
         </p:nvSpPr>
         <p:spPr>
           <a:xfrm>
-            <a:off x="7284719" y="4038600"/>
-            <a:ext cx="2098040" cy="749300"/>
+            <a:off x="7284719" y="4241800"/>
+            <a:ext cx="2098040" cy="736600"/>
           </a:xfrm>
           <a:prstGeom prst="roundRect">
             <a:avLst>
-              <a:gd name="adj" fmla="val 10169"/>
+              <a:gd name="adj" fmla="val 10344"/>
             </a:avLst>
           </a:prstGeom>
           <a:solidFill>
-            <a:srgbClr val="FBF7F1"/>
+            <a:srgbClr val="F2F5F6"/>
           </a:solidFill>
           <a:ln w="12700">
             <a:solidFill>
@@ -5501,14 +6243,58 @@
       </p:sp>
       <p:sp>
         <p:nvSpPr>
-          <p:cNvPr id="40" name="TextBox 39"/>
+          <p:cNvPr id="50" name="Oval 49"/>
+          <p:cNvSpPr/>
+          <p:nvPr/>
+        </p:nvSpPr>
+        <p:spPr>
+          <a:xfrm>
+            <a:off x="7386319" y="4343400"/>
+            <a:ext cx="57150" cy="57150"/>
+          </a:xfrm>
+          <a:prstGeom prst="ellipse">
+            <a:avLst/>
+          </a:prstGeom>
+          <a:solidFill>
+            <a:srgbClr val="F2A878"/>
+          </a:solidFill>
+          <a:ln>
+            <a:noFill/>
+          </a:ln>
+          <a:effectLst/>
+        </p:spPr>
+        <p:style>
+          <a:lnRef idx="1">
+            <a:schemeClr val="accent1"/>
+          </a:lnRef>
+          <a:fillRef idx="3">
+            <a:schemeClr val="accent1"/>
+          </a:fillRef>
+          <a:effectRef idx="2">
+            <a:schemeClr val="accent1"/>
+          </a:effectRef>
+          <a:fontRef idx="minor">
+            <a:schemeClr val="lt1"/>
+          </a:fontRef>
+        </p:style>
+        <p:txBody>
+          <a:bodyPr rtlCol="0" anchor="ctr"/>
+          <a:lstStyle/>
+          <a:p>
+            <a:pPr algn="ctr"/>
+          </a:p>
+        </p:txBody>
+      </p:sp>
+      <p:sp>
+        <p:nvSpPr>
+          <p:cNvPr id="51" name="TextBox 50"/>
           <p:cNvSpPr txBox="1"/>
           <p:nvPr/>
         </p:nvSpPr>
         <p:spPr>
           <a:xfrm>
-            <a:off x="7373619" y="4038600"/>
-            <a:ext cx="1920239" cy="749300"/>
+            <a:off x="7386319" y="4241800"/>
+            <a:ext cx="1894839" cy="736600"/>
           </a:xfrm>
           <a:prstGeom prst="rect">
             <a:avLst/>
@@ -5516,7 +6302,7 @@
           <a:noFill/>
         </p:spPr>
         <p:txBody>
-          <a:bodyPr wrap="square" anchor="ctr" lIns="25400" rIns="25400" tIns="12700" bIns="12700">
+          <a:bodyPr wrap="square" anchor="ctr" lIns="25400" rIns="25400" tIns="25400" bIns="25400">
             <a:normAutofit/>
           </a:bodyPr>
           <a:lstStyle/>
@@ -5529,7 +6315,7 @@
             <a:r>
               <a:rPr sz="800" b="0">
                 <a:solidFill>
-                  <a:srgbClr val="7A3B2E"/>
+                  <a:srgbClr val="3A4A55"/>
                 </a:solidFill>
                 <a:latin typeface="Inter"/>
               </a:rPr>
@@ -5540,22 +6326,22 @@
       </p:sp>
       <p:sp>
         <p:nvSpPr>
-          <p:cNvPr id="41" name="Rounded Rectangle 40"/>
+          <p:cNvPr id="52" name="Rounded Rectangle 51"/>
           <p:cNvSpPr/>
           <p:nvPr/>
         </p:nvSpPr>
         <p:spPr>
           <a:xfrm>
-            <a:off x="9522459" y="4038600"/>
-            <a:ext cx="2098040" cy="749300"/>
+            <a:off x="9522459" y="4241800"/>
+            <a:ext cx="2098040" cy="736600"/>
           </a:xfrm>
           <a:prstGeom prst="roundRect">
             <a:avLst>
-              <a:gd name="adj" fmla="val 10169"/>
+              <a:gd name="adj" fmla="val 10344"/>
             </a:avLst>
           </a:prstGeom>
           <a:solidFill>
-            <a:srgbClr val="FBF7F1"/>
+            <a:srgbClr val="F2F5F6"/>
           </a:solidFill>
           <a:ln w="12700">
             <a:solidFill>
@@ -5588,97 +6374,17 @@
       </p:sp>
       <p:sp>
         <p:nvSpPr>
-          <p:cNvPr id="42" name="TextBox 41"/>
-          <p:cNvSpPr txBox="1"/>
-          <p:nvPr/>
-        </p:nvSpPr>
-        <p:spPr>
-          <a:xfrm>
-            <a:off x="9611360" y="4038600"/>
-            <a:ext cx="1920239" cy="749300"/>
-          </a:xfrm>
-          <a:prstGeom prst="rect">
-            <a:avLst/>
-          </a:prstGeom>
-          <a:noFill/>
-        </p:spPr>
-        <p:txBody>
-          <a:bodyPr wrap="square" anchor="ctr" lIns="25400" rIns="25400" tIns="12700" bIns="12700">
-            <a:normAutofit/>
-          </a:bodyPr>
-          <a:lstStyle/>
-          <a:p>
-            <a:pPr algn="ctr">
-              <a:spcAft>
-                <a:spcPts val="0"/>
-              </a:spcAft>
-            </a:pPr>
-            <a:r>
-              <a:rPr sz="800" b="0">
-                <a:solidFill>
-                  <a:srgbClr val="7A3B2E"/>
-                </a:solidFill>
-                <a:latin typeface="Inter"/>
-              </a:rPr>
-              <a:t>Carryover is ad-hoc (email / WhatsApp)</a:t>
-            </a:r>
-          </a:p>
-        </p:txBody>
-      </p:sp>
-      <p:sp>
-        <p:nvSpPr>
-          <p:cNvPr id="43" name="TextBox 42"/>
-          <p:cNvSpPr txBox="1"/>
-          <p:nvPr/>
-        </p:nvSpPr>
-        <p:spPr>
-          <a:xfrm>
-            <a:off x="571500" y="5067300"/>
-            <a:ext cx="5715000" cy="152400"/>
-          </a:xfrm>
-          <a:prstGeom prst="rect">
-            <a:avLst/>
-          </a:prstGeom>
-          <a:noFill/>
-        </p:spPr>
-        <p:txBody>
-          <a:bodyPr wrap="square" anchor="t" lIns="25400" rIns="25400" tIns="12700" bIns="12700">
-            <a:spAutoFit/>
-          </a:bodyPr>
-          <a:lstStyle/>
-          <a:p>
-            <a:pPr algn="l">
-              <a:spcAft>
-                <a:spcPts val="0"/>
-              </a:spcAft>
-            </a:pPr>
-            <a:r>
-              <a:rPr sz="700" b="1">
-                <a:solidFill>
-                  <a:srgbClr val="8597A4"/>
-                </a:solidFill>
-                <a:latin typeface="Inter"/>
-              </a:rPr>
-              <a:t>THE PRIZE — TARGETS</a:t>
-            </a:r>
-          </a:p>
-        </p:txBody>
-      </p:sp>
-      <p:sp>
-        <p:nvSpPr>
-          <p:cNvPr id="44" name="Rounded Rectangle 43"/>
+          <p:cNvPr id="53" name="Oval 52"/>
           <p:cNvSpPr/>
           <p:nvPr/>
         </p:nvSpPr>
         <p:spPr>
           <a:xfrm>
-            <a:off x="584200" y="5283200"/>
-            <a:ext cx="571500" cy="31750"/>
-          </a:xfrm>
-          <a:prstGeom prst="roundRect">
-            <a:avLst>
-              <a:gd name="adj" fmla="val 40000"/>
-            </a:avLst>
+            <a:off x="9624059" y="4343400"/>
+            <a:ext cx="57150" cy="57150"/>
+          </a:xfrm>
+          <a:prstGeom prst="ellipse">
+            <a:avLst/>
           </a:prstGeom>
           <a:solidFill>
             <a:srgbClr val="F2A878"/>
@@ -5712,14 +6418,14 @@
       </p:sp>
       <p:sp>
         <p:nvSpPr>
-          <p:cNvPr id="45" name="TextBox 44"/>
+          <p:cNvPr id="54" name="TextBox 53"/>
           <p:cNvSpPr txBox="1"/>
           <p:nvPr/>
         </p:nvSpPr>
         <p:spPr>
           <a:xfrm>
-            <a:off x="571500" y="5372100"/>
-            <a:ext cx="5207000" cy="355600"/>
+            <a:off x="9624059" y="4241800"/>
+            <a:ext cx="1894839" cy="736600"/>
           </a:xfrm>
           <a:prstGeom prst="rect">
             <a:avLst/>
@@ -5727,7 +6433,46 @@
           <a:noFill/>
         </p:spPr>
         <p:txBody>
-          <a:bodyPr wrap="square" anchor="t" lIns="25400" rIns="25400" tIns="12700" bIns="12700">
+          <a:bodyPr wrap="square" anchor="ctr" lIns="25400" rIns="25400" tIns="25400" bIns="25400">
+            <a:normAutofit/>
+          </a:bodyPr>
+          <a:lstStyle/>
+          <a:p>
+            <a:pPr algn="ctr">
+              <a:spcAft>
+                <a:spcPts val="0"/>
+              </a:spcAft>
+            </a:pPr>
+            <a:r>
+              <a:rPr sz="800" b="0">
+                <a:solidFill>
+                  <a:srgbClr val="3A4A55"/>
+                </a:solidFill>
+                <a:latin typeface="Inter"/>
+              </a:rPr>
+              <a:t>Carryover is ad-hoc (email / WhatsApp)</a:t>
+            </a:r>
+          </a:p>
+        </p:txBody>
+      </p:sp>
+      <p:sp>
+        <p:nvSpPr>
+          <p:cNvPr id="55" name="TextBox 54"/>
+          <p:cNvSpPr txBox="1"/>
+          <p:nvPr/>
+        </p:nvSpPr>
+        <p:spPr>
+          <a:xfrm>
+            <a:off x="571500" y="5156200"/>
+            <a:ext cx="5715000" cy="152400"/>
+          </a:xfrm>
+          <a:prstGeom prst="rect">
+            <a:avLst/>
+          </a:prstGeom>
+          <a:noFill/>
+        </p:spPr>
+        <p:txBody>
+          <a:bodyPr wrap="square" anchor="t" lIns="25400" rIns="25400" tIns="25400" bIns="25400">
             <a:spAutoFit/>
           </a:bodyPr>
           <a:lstStyle/>
@@ -5738,65 +6483,26 @@
               </a:spcAft>
             </a:pPr>
             <a:r>
-              <a:rPr sz="2100" b="1">
-                <a:solidFill>
-                  <a:srgbClr val="2D6A6E"/>
+              <a:rPr sz="700" b="1">
+                <a:solidFill>
+                  <a:srgbClr val="8597A4"/>
                 </a:solidFill>
                 <a:latin typeface="Inter"/>
               </a:rPr>
-              <a:t>≥ 4 hours / month</a:t>
-            </a:r>
-          </a:p>
-        </p:txBody>
-      </p:sp>
-      <p:sp>
-        <p:nvSpPr>
-          <p:cNvPr id="46" name="TextBox 45"/>
-          <p:cNvSpPr txBox="1"/>
-          <p:nvPr/>
-        </p:nvSpPr>
-        <p:spPr>
-          <a:xfrm>
-            <a:off x="571500" y="5791200"/>
-            <a:ext cx="5207000" cy="190500"/>
-          </a:xfrm>
-          <a:prstGeom prst="rect">
-            <a:avLst/>
-          </a:prstGeom>
-          <a:noFill/>
-        </p:spPr>
-        <p:txBody>
-          <a:bodyPr wrap="square" anchor="t" lIns="25400" rIns="25400" tIns="12700" bIns="12700">
-            <a:spAutoFit/>
-          </a:bodyPr>
-          <a:lstStyle/>
-          <a:p>
-            <a:pPr algn="l">
-              <a:spcAft>
-                <a:spcPts val="0"/>
-              </a:spcAft>
-            </a:pPr>
-            <a:r>
-              <a:rPr sz="900" b="0">
-                <a:solidFill>
-                  <a:srgbClr val="4A5B6B"/>
-                </a:solidFill>
-                <a:latin typeface="Inter"/>
-              </a:rPr>
-              <a:t>productive hours given back to each clinician</a:t>
-            </a:r>
-          </a:p>
-        </p:txBody>
-      </p:sp>
-      <p:sp>
-        <p:nvSpPr>
-          <p:cNvPr id="47" name="Rounded Rectangle 46"/>
+              <a:t>TARGET OUTCOMES</a:t>
+            </a:r>
+          </a:p>
+        </p:txBody>
+      </p:sp>
+      <p:sp>
+        <p:nvSpPr>
+          <p:cNvPr id="56" name="Rounded Rectangle 55"/>
           <p:cNvSpPr/>
           <p:nvPr/>
         </p:nvSpPr>
         <p:spPr>
           <a:xfrm>
-            <a:off x="6362700" y="5283200"/>
+            <a:off x="584200" y="5359400"/>
             <a:ext cx="571500" cy="31750"/>
           </a:xfrm>
           <a:prstGeom prst="roundRect">
@@ -5836,13 +6542,13 @@
       </p:sp>
       <p:sp>
         <p:nvSpPr>
-          <p:cNvPr id="48" name="TextBox 47"/>
+          <p:cNvPr id="57" name="TextBox 56"/>
           <p:cNvSpPr txBox="1"/>
           <p:nvPr/>
         </p:nvSpPr>
         <p:spPr>
           <a:xfrm>
-            <a:off x="6350000" y="5372100"/>
+            <a:off x="571500" y="5448300"/>
             <a:ext cx="5207000" cy="355600"/>
           </a:xfrm>
           <a:prstGeom prst="rect">
@@ -5851,7 +6557,7 @@
           <a:noFill/>
         </p:spPr>
         <p:txBody>
-          <a:bodyPr wrap="square" anchor="t" lIns="25400" rIns="25400" tIns="12700" bIns="12700">
+          <a:bodyPr wrap="square" anchor="t" lIns="25400" rIns="25400" tIns="25400" bIns="25400">
             <a:spAutoFit/>
           </a:bodyPr>
           <a:lstStyle/>
@@ -5868,20 +6574,20 @@
                 </a:solidFill>
                 <a:latin typeface="Inter"/>
               </a:rPr>
-              <a:t>Same-day</a:t>
-            </a:r>
-          </a:p>
-        </p:txBody>
-      </p:sp>
-      <p:sp>
-        <p:nvSpPr>
-          <p:cNvPr id="49" name="TextBox 48"/>
+              <a:t>≥ 4 hours / month</a:t>
+            </a:r>
+          </a:p>
+        </p:txBody>
+      </p:sp>
+      <p:sp>
+        <p:nvSpPr>
+          <p:cNvPr id="58" name="TextBox 57"/>
           <p:cNvSpPr txBox="1"/>
           <p:nvPr/>
         </p:nvSpPr>
         <p:spPr>
           <a:xfrm>
-            <a:off x="6350000" y="5791200"/>
+            <a:off x="571500" y="5867400"/>
             <a:ext cx="5207000" cy="190500"/>
           </a:xfrm>
           <a:prstGeom prst="rect">
@@ -5890,7 +6596,7 @@
           <a:noFill/>
         </p:spPr>
         <p:txBody>
-          <a:bodyPr wrap="square" anchor="t" lIns="25400" rIns="25400" tIns="12700" bIns="12700">
+          <a:bodyPr wrap="square" anchor="t" lIns="25400" rIns="25400" tIns="25400" bIns="25400">
             <a:spAutoFit/>
           </a:bodyPr>
           <a:lstStyle/>
@@ -5907,21 +6613,67 @@
                 </a:solidFill>
                 <a:latin typeface="Inter"/>
               </a:rPr>
-              <a:t>client summaries &amp; reports, vs the ~3-week manual baseline</a:t>
-            </a:r>
-          </a:p>
-        </p:txBody>
-      </p:sp>
-      <p:sp>
-        <p:nvSpPr>
-          <p:cNvPr id="50" name="TextBox 49"/>
+              <a:t>productive hours given back to each clinician</a:t>
+            </a:r>
+          </a:p>
+        </p:txBody>
+      </p:sp>
+      <p:sp>
+        <p:nvSpPr>
+          <p:cNvPr id="59" name="Rounded Rectangle 58"/>
+          <p:cNvSpPr/>
+          <p:nvPr/>
+        </p:nvSpPr>
+        <p:spPr>
+          <a:xfrm>
+            <a:off x="6362700" y="5359400"/>
+            <a:ext cx="571500" cy="31750"/>
+          </a:xfrm>
+          <a:prstGeom prst="roundRect">
+            <a:avLst>
+              <a:gd name="adj" fmla="val 40000"/>
+            </a:avLst>
+          </a:prstGeom>
+          <a:solidFill>
+            <a:srgbClr val="F2A878"/>
+          </a:solidFill>
+          <a:ln>
+            <a:noFill/>
+          </a:ln>
+          <a:effectLst/>
+        </p:spPr>
+        <p:style>
+          <a:lnRef idx="1">
+            <a:schemeClr val="accent1"/>
+          </a:lnRef>
+          <a:fillRef idx="3">
+            <a:schemeClr val="accent1"/>
+          </a:fillRef>
+          <a:effectRef idx="2">
+            <a:schemeClr val="accent1"/>
+          </a:effectRef>
+          <a:fontRef idx="minor">
+            <a:schemeClr val="lt1"/>
+          </a:fontRef>
+        </p:style>
+        <p:txBody>
+          <a:bodyPr rtlCol="0" anchor="ctr"/>
+          <a:lstStyle/>
+          <a:p>
+            <a:pPr algn="ctr"/>
+          </a:p>
+        </p:txBody>
+      </p:sp>
+      <p:sp>
+        <p:nvSpPr>
+          <p:cNvPr id="60" name="TextBox 59"/>
           <p:cNvSpPr txBox="1"/>
           <p:nvPr/>
         </p:nvSpPr>
         <p:spPr>
           <a:xfrm>
-            <a:off x="571500" y="6604000"/>
-            <a:ext cx="5715000" cy="139700"/>
+            <a:off x="6350000" y="5448300"/>
+            <a:ext cx="5207000" cy="355600"/>
           </a:xfrm>
           <a:prstGeom prst="rect">
             <a:avLst/>
@@ -5929,7 +6681,7 @@
           <a:noFill/>
         </p:spPr>
         <p:txBody>
-          <a:bodyPr wrap="square" anchor="t" lIns="25400" rIns="25400" tIns="12700" bIns="12700">
+          <a:bodyPr wrap="square" anchor="t" lIns="25400" rIns="25400" tIns="25400" bIns="25400">
             <a:spAutoFit/>
           </a:bodyPr>
           <a:lstStyle/>
@@ -5940,6 +6692,84 @@
               </a:spcAft>
             </a:pPr>
             <a:r>
+              <a:rPr sz="2100" b="1">
+                <a:solidFill>
+                  <a:srgbClr val="2D6A6E"/>
+                </a:solidFill>
+                <a:latin typeface="Inter"/>
+              </a:rPr>
+              <a:t>Same-day</a:t>
+            </a:r>
+          </a:p>
+        </p:txBody>
+      </p:sp>
+      <p:sp>
+        <p:nvSpPr>
+          <p:cNvPr id="61" name="TextBox 60"/>
+          <p:cNvSpPr txBox="1"/>
+          <p:nvPr/>
+        </p:nvSpPr>
+        <p:spPr>
+          <a:xfrm>
+            <a:off x="6350000" y="5867400"/>
+            <a:ext cx="5207000" cy="190500"/>
+          </a:xfrm>
+          <a:prstGeom prst="rect">
+            <a:avLst/>
+          </a:prstGeom>
+          <a:noFill/>
+        </p:spPr>
+        <p:txBody>
+          <a:bodyPr wrap="square" anchor="t" lIns="25400" rIns="25400" tIns="25400" bIns="25400">
+            <a:spAutoFit/>
+          </a:bodyPr>
+          <a:lstStyle/>
+          <a:p>
+            <a:pPr algn="l">
+              <a:spcAft>
+                <a:spcPts val="0"/>
+              </a:spcAft>
+            </a:pPr>
+            <a:r>
+              <a:rPr sz="900" b="0">
+                <a:solidFill>
+                  <a:srgbClr val="4A5B6B"/>
+                </a:solidFill>
+                <a:latin typeface="Inter"/>
+              </a:rPr>
+              <a:t>client summaries &amp; reports, vs the ~3-week manual baseline</a:t>
+            </a:r>
+          </a:p>
+        </p:txBody>
+      </p:sp>
+      <p:sp>
+        <p:nvSpPr>
+          <p:cNvPr id="62" name="TextBox 61"/>
+          <p:cNvSpPr txBox="1"/>
+          <p:nvPr/>
+        </p:nvSpPr>
+        <p:spPr>
+          <a:xfrm>
+            <a:off x="571500" y="6604000"/>
+            <a:ext cx="5715000" cy="139700"/>
+          </a:xfrm>
+          <a:prstGeom prst="rect">
+            <a:avLst/>
+          </a:prstGeom>
+          <a:noFill/>
+        </p:spPr>
+        <p:txBody>
+          <a:bodyPr wrap="square" anchor="t" lIns="25400" rIns="25400" tIns="25400" bIns="25400">
+            <a:spAutoFit/>
+          </a:bodyPr>
+          <a:lstStyle/>
+          <a:p>
+            <a:pPr algn="l">
+              <a:spcAft>
+                <a:spcPts val="0"/>
+              </a:spcAft>
+            </a:pPr>
+            <a:r>
               <a:rPr sz="600" b="0">
                 <a:solidFill>
                   <a:srgbClr val="8597A4"/>
@@ -5953,7 +6783,7 @@
       </p:sp>
       <p:sp>
         <p:nvSpPr>
-          <p:cNvPr id="51" name="TextBox 50"/>
+          <p:cNvPr id="63" name="TextBox 62"/>
           <p:cNvSpPr txBox="1"/>
           <p:nvPr/>
         </p:nvSpPr>
@@ -5968,7 +6798,7 @@
           <a:noFill/>
         </p:spPr>
         <p:txBody>
-          <a:bodyPr wrap="square" anchor="t" lIns="25400" rIns="25400" tIns="12700" bIns="12700">
+          <a:bodyPr wrap="square" anchor="t" lIns="25400" rIns="25400" tIns="25400" bIns="25400">
             <a:spAutoFit/>
           </a:bodyPr>
           <a:lstStyle/>
@@ -6069,7 +6899,7 @@
           <a:noFill/>
         </p:spPr>
         <p:txBody>
-          <a:bodyPr wrap="square" anchor="t" lIns="25400" rIns="25400" tIns="12700" bIns="12700">
+          <a:bodyPr wrap="square" anchor="t" lIns="25400" rIns="25400" tIns="25400" bIns="25400">
             <a:spAutoFit/>
           </a:bodyPr>
           <a:lstStyle/>
@@ -6108,7 +6938,7 @@
           <a:noFill/>
         </p:spPr>
         <p:txBody>
-          <a:bodyPr wrap="square" anchor="t" lIns="25400" rIns="25400" tIns="12700" bIns="12700">
+          <a:bodyPr wrap="square" anchor="t" lIns="25400" rIns="25400" tIns="25400" bIns="25400">
             <a:spAutoFit/>
           </a:bodyPr>
           <a:lstStyle/>
@@ -6147,7 +6977,7 @@
           <a:noFill/>
         </p:spPr>
         <p:txBody>
-          <a:bodyPr wrap="square" anchor="t" lIns="25400" rIns="25400" tIns="12700" bIns="12700">
+          <a:bodyPr wrap="square" anchor="t" lIns="25400" rIns="25400" tIns="25400" bIns="25400">
             <a:spAutoFit/>
           </a:bodyPr>
           <a:lstStyle/>
@@ -6232,7 +7062,7 @@
           <a:noFill/>
         </p:spPr>
         <p:txBody>
-          <a:bodyPr wrap="square" anchor="ctr" lIns="25400" rIns="25400" tIns="12700" bIns="12700">
+          <a:bodyPr wrap="square" anchor="ctr" lIns="25400" rIns="25400" tIns="25400" bIns="25400">
             <a:spAutoFit/>
           </a:bodyPr>
           <a:lstStyle/>
@@ -6271,7 +7101,7 @@
           <a:noFill/>
         </p:spPr>
         <p:txBody>
-          <a:bodyPr wrap="square" anchor="ctr" lIns="25400" rIns="25400" tIns="12700" bIns="12700">
+          <a:bodyPr wrap="square" anchor="ctr" lIns="25400" rIns="25400" tIns="25400" bIns="25400">
             <a:spAutoFit/>
           </a:bodyPr>
           <a:lstStyle/>
@@ -6310,7 +7140,7 @@
           <a:noFill/>
         </p:spPr>
         <p:txBody>
-          <a:bodyPr wrap="square" anchor="ctr" lIns="25400" rIns="25400" tIns="12700" bIns="12700">
+          <a:bodyPr wrap="square" anchor="ctr" lIns="25400" rIns="25400" tIns="25400" bIns="25400">
             <a:spAutoFit/>
           </a:bodyPr>
           <a:lstStyle/>
@@ -6349,7 +7179,7 @@
           <a:noFill/>
         </p:spPr>
         <p:txBody>
-          <a:bodyPr wrap="square" anchor="ctr" lIns="25400" rIns="25400" tIns="12700" bIns="12700">
+          <a:bodyPr wrap="square" anchor="ctr" lIns="25400" rIns="25400" tIns="25400" bIns="25400">
             <a:spAutoFit/>
           </a:bodyPr>
           <a:lstStyle/>
@@ -6434,7 +7264,7 @@
           <a:noFill/>
         </p:spPr>
         <p:txBody>
-          <a:bodyPr wrap="square" anchor="ctr" lIns="25400" rIns="25400" tIns="12700" bIns="12700">
+          <a:bodyPr wrap="square" anchor="ctr" lIns="25400" rIns="25400" tIns="25400" bIns="25400">
             <a:normAutofit/>
           </a:bodyPr>
           <a:lstStyle/>
@@ -6519,7 +7349,7 @@
           <a:noFill/>
         </p:spPr>
         <p:txBody>
-          <a:bodyPr wrap="square" anchor="ctr" lIns="25400" rIns="25400" tIns="12700" bIns="12700">
+          <a:bodyPr wrap="square" anchor="ctr" lIns="25400" rIns="25400" tIns="25400" bIns="25400">
             <a:normAutofit/>
           </a:bodyPr>
           <a:lstStyle/>
@@ -6604,7 +7434,7 @@
           <a:noFill/>
         </p:spPr>
         <p:txBody>
-          <a:bodyPr wrap="square" anchor="ctr" lIns="25400" rIns="25400" tIns="12700" bIns="12700">
+          <a:bodyPr wrap="square" anchor="ctr" lIns="25400" rIns="25400" tIns="25400" bIns="25400">
             <a:normAutofit/>
           </a:bodyPr>
           <a:lstStyle/>
@@ -6689,7 +7519,7 @@
           <a:noFill/>
         </p:spPr>
         <p:txBody>
-          <a:bodyPr wrap="square" anchor="ctr" lIns="25400" rIns="25400" tIns="12700" bIns="12700">
+          <a:bodyPr wrap="square" anchor="ctr" lIns="25400" rIns="25400" tIns="25400" bIns="25400">
             <a:normAutofit/>
           </a:bodyPr>
           <a:lstStyle/>
@@ -6774,7 +7604,7 @@
           <a:noFill/>
         </p:spPr>
         <p:txBody>
-          <a:bodyPr wrap="square" anchor="ctr" lIns="25400" rIns="25400" tIns="12700" bIns="12700">
+          <a:bodyPr wrap="square" anchor="ctr" lIns="25400" rIns="25400" tIns="25400" bIns="25400">
             <a:normAutofit/>
           </a:bodyPr>
           <a:lstStyle/>
@@ -6859,7 +7689,7 @@
           <a:noFill/>
         </p:spPr>
         <p:txBody>
-          <a:bodyPr wrap="square" anchor="ctr" lIns="25400" rIns="25400" tIns="12700" bIns="12700">
+          <a:bodyPr wrap="square" anchor="ctr" lIns="25400" rIns="25400" tIns="25400" bIns="25400">
             <a:normAutofit/>
           </a:bodyPr>
           <a:lstStyle/>
@@ -6944,7 +7774,7 @@
           <a:noFill/>
         </p:spPr>
         <p:txBody>
-          <a:bodyPr wrap="square" anchor="ctr" lIns="25400" rIns="25400" tIns="12700" bIns="12700">
+          <a:bodyPr wrap="square" anchor="ctr" lIns="25400" rIns="25400" tIns="25400" bIns="25400">
             <a:normAutofit/>
           </a:bodyPr>
           <a:lstStyle/>
@@ -7029,7 +7859,7 @@
           <a:noFill/>
         </p:spPr>
         <p:txBody>
-          <a:bodyPr wrap="square" anchor="ctr" lIns="25400" rIns="25400" tIns="12700" bIns="12700">
+          <a:bodyPr wrap="square" anchor="ctr" lIns="25400" rIns="25400" tIns="25400" bIns="25400">
             <a:normAutofit/>
           </a:bodyPr>
           <a:lstStyle/>
@@ -7114,7 +7944,7 @@
           <a:noFill/>
         </p:spPr>
         <p:txBody>
-          <a:bodyPr wrap="square" anchor="ctr" lIns="25400" rIns="25400" tIns="12700" bIns="12700">
+          <a:bodyPr wrap="square" anchor="ctr" lIns="25400" rIns="25400" tIns="25400" bIns="25400">
             <a:normAutofit/>
           </a:bodyPr>
           <a:lstStyle/>
@@ -7199,7 +8029,7 @@
           <a:noFill/>
         </p:spPr>
         <p:txBody>
-          <a:bodyPr wrap="square" anchor="ctr" lIns="25400" rIns="25400" tIns="12700" bIns="12700">
+          <a:bodyPr wrap="square" anchor="ctr" lIns="25400" rIns="25400" tIns="25400" bIns="25400">
             <a:normAutofit/>
           </a:bodyPr>
           <a:lstStyle/>
@@ -7284,7 +8114,7 @@
           <a:noFill/>
         </p:spPr>
         <p:txBody>
-          <a:bodyPr wrap="square" anchor="ctr" lIns="25400" rIns="25400" tIns="12700" bIns="12700">
+          <a:bodyPr wrap="square" anchor="ctr" lIns="25400" rIns="25400" tIns="25400" bIns="25400">
             <a:normAutofit/>
           </a:bodyPr>
           <a:lstStyle/>
@@ -7369,7 +8199,7 @@
           <a:noFill/>
         </p:spPr>
         <p:txBody>
-          <a:bodyPr wrap="square" anchor="ctr" lIns="25400" rIns="25400" tIns="12700" bIns="12700">
+          <a:bodyPr wrap="square" anchor="ctr" lIns="25400" rIns="25400" tIns="25400" bIns="25400">
             <a:normAutofit/>
           </a:bodyPr>
           <a:lstStyle/>
@@ -7454,7 +8284,7 @@
           <a:noFill/>
         </p:spPr>
         <p:txBody>
-          <a:bodyPr wrap="square" anchor="ctr" lIns="25400" rIns="25400" tIns="12700" bIns="12700">
+          <a:bodyPr wrap="square" anchor="ctr" lIns="25400" rIns="25400" tIns="25400" bIns="25400">
             <a:normAutofit/>
           </a:bodyPr>
           <a:lstStyle/>
@@ -7539,7 +8369,7 @@
           <a:noFill/>
         </p:spPr>
         <p:txBody>
-          <a:bodyPr wrap="square" anchor="ctr" lIns="25400" rIns="25400" tIns="12700" bIns="12700">
+          <a:bodyPr wrap="square" anchor="ctr" lIns="25400" rIns="25400" tIns="25400" bIns="25400">
             <a:normAutofit/>
           </a:bodyPr>
           <a:lstStyle/>
@@ -7624,7 +8454,7 @@
           <a:noFill/>
         </p:spPr>
         <p:txBody>
-          <a:bodyPr wrap="square" anchor="ctr" lIns="25400" rIns="25400" tIns="12700" bIns="12700">
+          <a:bodyPr wrap="square" anchor="ctr" lIns="25400" rIns="25400" tIns="25400" bIns="25400">
             <a:normAutofit/>
           </a:bodyPr>
           <a:lstStyle/>
@@ -7709,7 +8539,7 @@
           <a:noFill/>
         </p:spPr>
         <p:txBody>
-          <a:bodyPr wrap="square" anchor="ctr" lIns="25400" rIns="25400" tIns="12700" bIns="12700">
+          <a:bodyPr wrap="square" anchor="ctr" lIns="25400" rIns="25400" tIns="25400" bIns="25400">
             <a:normAutofit/>
           </a:bodyPr>
           <a:lstStyle/>
@@ -7794,7 +8624,7 @@
           <a:noFill/>
         </p:spPr>
         <p:txBody>
-          <a:bodyPr wrap="square" anchor="ctr" lIns="25400" rIns="25400" tIns="12700" bIns="12700">
+          <a:bodyPr wrap="square" anchor="ctr" lIns="25400" rIns="25400" tIns="25400" bIns="25400">
             <a:normAutofit/>
           </a:bodyPr>
           <a:lstStyle/>
@@ -7879,7 +8709,7 @@
           <a:noFill/>
         </p:spPr>
         <p:txBody>
-          <a:bodyPr wrap="square" anchor="ctr" lIns="25400" rIns="25400" tIns="12700" bIns="12700">
+          <a:bodyPr wrap="square" anchor="ctr" lIns="25400" rIns="25400" tIns="25400" bIns="25400">
             <a:normAutofit/>
           </a:bodyPr>
           <a:lstStyle/>
@@ -7964,7 +8794,7 @@
           <a:noFill/>
         </p:spPr>
         <p:txBody>
-          <a:bodyPr wrap="square" anchor="ctr" lIns="25400" rIns="25400" tIns="12700" bIns="12700">
+          <a:bodyPr wrap="square" anchor="ctr" lIns="25400" rIns="25400" tIns="25400" bIns="25400">
             <a:normAutofit/>
           </a:bodyPr>
           <a:lstStyle/>
@@ -8049,7 +8879,7 @@
           <a:noFill/>
         </p:spPr>
         <p:txBody>
-          <a:bodyPr wrap="square" anchor="ctr" lIns="25400" rIns="25400" tIns="12700" bIns="12700">
+          <a:bodyPr wrap="square" anchor="ctr" lIns="25400" rIns="25400" tIns="25400" bIns="25400">
             <a:normAutofit/>
           </a:bodyPr>
           <a:lstStyle/>
@@ -8134,7 +8964,7 @@
           <a:noFill/>
         </p:spPr>
         <p:txBody>
-          <a:bodyPr wrap="square" anchor="ctr" lIns="25400" rIns="25400" tIns="12700" bIns="12700">
+          <a:bodyPr wrap="square" anchor="ctr" lIns="25400" rIns="25400" tIns="25400" bIns="25400">
             <a:normAutofit/>
           </a:bodyPr>
           <a:lstStyle/>
@@ -8219,7 +9049,7 @@
           <a:noFill/>
         </p:spPr>
         <p:txBody>
-          <a:bodyPr wrap="square" anchor="ctr" lIns="25400" rIns="25400" tIns="12700" bIns="12700">
+          <a:bodyPr wrap="square" anchor="ctr" lIns="25400" rIns="25400" tIns="25400" bIns="25400">
             <a:normAutofit/>
           </a:bodyPr>
           <a:lstStyle/>
@@ -8304,7 +9134,7 @@
           <a:noFill/>
         </p:spPr>
         <p:txBody>
-          <a:bodyPr wrap="square" anchor="ctr" lIns="25400" rIns="25400" tIns="12700" bIns="12700">
+          <a:bodyPr wrap="square" anchor="ctr" lIns="25400" rIns="25400" tIns="25400" bIns="25400">
             <a:normAutofit/>
           </a:bodyPr>
           <a:lstStyle/>
@@ -8389,7 +9219,7 @@
           <a:noFill/>
         </p:spPr>
         <p:txBody>
-          <a:bodyPr wrap="square" anchor="ctr" lIns="25400" rIns="25400" tIns="12700" bIns="12700">
+          <a:bodyPr wrap="square" anchor="ctr" lIns="25400" rIns="25400" tIns="25400" bIns="25400">
             <a:normAutofit/>
           </a:bodyPr>
           <a:lstStyle/>
@@ -8474,7 +9304,7 @@
           <a:noFill/>
         </p:spPr>
         <p:txBody>
-          <a:bodyPr wrap="square" anchor="ctr" lIns="25400" rIns="25400" tIns="12700" bIns="12700">
+          <a:bodyPr wrap="square" anchor="ctr" lIns="25400" rIns="25400" tIns="25400" bIns="25400">
             <a:normAutofit/>
           </a:bodyPr>
           <a:lstStyle/>
@@ -8559,7 +9389,7 @@
           <a:noFill/>
         </p:spPr>
         <p:txBody>
-          <a:bodyPr wrap="square" anchor="ctr" lIns="25400" rIns="25400" tIns="12700" bIns="12700">
+          <a:bodyPr wrap="square" anchor="ctr" lIns="25400" rIns="25400" tIns="25400" bIns="25400">
             <a:normAutofit/>
           </a:bodyPr>
           <a:lstStyle/>
@@ -8644,7 +9474,7 @@
           <a:noFill/>
         </p:spPr>
         <p:txBody>
-          <a:bodyPr wrap="square" anchor="ctr" lIns="25400" rIns="25400" tIns="12700" bIns="12700">
+          <a:bodyPr wrap="square" anchor="ctr" lIns="25400" rIns="25400" tIns="25400" bIns="25400">
             <a:normAutofit/>
           </a:bodyPr>
           <a:lstStyle/>
@@ -8729,7 +9559,7 @@
           <a:noFill/>
         </p:spPr>
         <p:txBody>
-          <a:bodyPr wrap="square" anchor="ctr" lIns="25400" rIns="25400" tIns="12700" bIns="12700">
+          <a:bodyPr wrap="square" anchor="ctr" lIns="25400" rIns="25400" tIns="25400" bIns="25400">
             <a:normAutofit/>
           </a:bodyPr>
           <a:lstStyle/>
@@ -8814,7 +9644,7 @@
           <a:noFill/>
         </p:spPr>
         <p:txBody>
-          <a:bodyPr wrap="square" anchor="ctr" lIns="25400" rIns="25400" tIns="12700" bIns="12700">
+          <a:bodyPr wrap="square" anchor="ctr" lIns="25400" rIns="25400" tIns="25400" bIns="25400">
             <a:normAutofit/>
           </a:bodyPr>
           <a:lstStyle/>
@@ -8899,7 +9729,7 @@
           <a:noFill/>
         </p:spPr>
         <p:txBody>
-          <a:bodyPr wrap="square" anchor="ctr" lIns="25400" rIns="25400" tIns="12700" bIns="12700">
+          <a:bodyPr wrap="square" anchor="ctr" lIns="25400" rIns="25400" tIns="25400" bIns="25400">
             <a:normAutofit/>
           </a:bodyPr>
           <a:lstStyle/>
@@ -8984,7 +9814,7 @@
           <a:noFill/>
         </p:spPr>
         <p:txBody>
-          <a:bodyPr wrap="square" anchor="ctr" lIns="25400" rIns="25400" tIns="12700" bIns="12700">
+          <a:bodyPr wrap="square" anchor="ctr" lIns="25400" rIns="25400" tIns="25400" bIns="25400">
             <a:normAutofit/>
           </a:bodyPr>
           <a:lstStyle/>
@@ -9069,7 +9899,7 @@
           <a:noFill/>
         </p:spPr>
         <p:txBody>
-          <a:bodyPr wrap="square" anchor="ctr" lIns="25400" rIns="25400" tIns="12700" bIns="12700">
+          <a:bodyPr wrap="square" anchor="ctr" lIns="25400" rIns="25400" tIns="25400" bIns="25400">
             <a:normAutofit/>
           </a:bodyPr>
           <a:lstStyle/>
@@ -9108,7 +9938,7 @@
           <a:noFill/>
         </p:spPr>
         <p:txBody>
-          <a:bodyPr wrap="square" anchor="t" lIns="25400" rIns="25400" tIns="12700" bIns="12700">
+          <a:bodyPr wrap="square" anchor="t" lIns="25400" rIns="25400" tIns="25400" bIns="25400">
             <a:spAutoFit/>
           </a:bodyPr>
           <a:lstStyle/>
@@ -9193,7 +10023,7 @@
           <a:noFill/>
         </p:spPr>
         <p:txBody>
-          <a:bodyPr wrap="square" anchor="ctr" lIns="25400" rIns="25400" tIns="12700" bIns="12700">
+          <a:bodyPr wrap="square" anchor="ctr" lIns="25400" rIns="25400" tIns="25400" bIns="25400">
             <a:normAutofit/>
           </a:bodyPr>
           <a:lstStyle/>
@@ -9278,7 +10108,7 @@
           <a:noFill/>
         </p:spPr>
         <p:txBody>
-          <a:bodyPr wrap="square" anchor="ctr" lIns="25400" rIns="25400" tIns="12700" bIns="12700">
+          <a:bodyPr wrap="square" anchor="ctr" lIns="25400" rIns="25400" tIns="25400" bIns="25400">
             <a:normAutofit/>
           </a:bodyPr>
           <a:lstStyle/>
@@ -9363,7 +10193,7 @@
           <a:noFill/>
         </p:spPr>
         <p:txBody>
-          <a:bodyPr wrap="square" anchor="ctr" lIns="25400" rIns="25400" tIns="12700" bIns="12700">
+          <a:bodyPr wrap="square" anchor="ctr" lIns="25400" rIns="25400" tIns="25400" bIns="25400">
             <a:normAutofit/>
           </a:bodyPr>
           <a:lstStyle/>
@@ -9448,7 +10278,7 @@
           <a:noFill/>
         </p:spPr>
         <p:txBody>
-          <a:bodyPr wrap="square" anchor="ctr" lIns="25400" rIns="25400" tIns="12700" bIns="12700">
+          <a:bodyPr wrap="square" anchor="ctr" lIns="25400" rIns="25400" tIns="25400" bIns="25400">
             <a:normAutofit/>
           </a:bodyPr>
           <a:lstStyle/>
@@ -9487,7 +10317,7 @@
           <a:noFill/>
         </p:spPr>
         <p:txBody>
-          <a:bodyPr wrap="square" anchor="t" lIns="25400" rIns="25400" tIns="12700" bIns="12700">
+          <a:bodyPr wrap="square" anchor="t" lIns="25400" rIns="25400" tIns="25400" bIns="25400">
             <a:spAutoFit/>
           </a:bodyPr>
           <a:lstStyle/>
@@ -9526,7 +10356,7 @@
           <a:noFill/>
         </p:spPr>
         <p:txBody>
-          <a:bodyPr wrap="square" anchor="t" lIns="25400" rIns="25400" tIns="12700" bIns="12700">
+          <a:bodyPr wrap="square" anchor="t" lIns="25400" rIns="25400" tIns="25400" bIns="25400">
             <a:spAutoFit/>
           </a:bodyPr>
           <a:lstStyle/>
@@ -9565,7 +10395,7 @@
           <a:noFill/>
         </p:spPr>
         <p:txBody>
-          <a:bodyPr wrap="square" anchor="t" lIns="25400" rIns="25400" tIns="12700" bIns="12700">
+          <a:bodyPr wrap="square" anchor="t" lIns="25400" rIns="25400" tIns="25400" bIns="25400">
             <a:spAutoFit/>
           </a:bodyPr>
           <a:lstStyle/>
@@ -9666,7 +10496,7 @@
           <a:noFill/>
         </p:spPr>
         <p:txBody>
-          <a:bodyPr wrap="square" anchor="t" lIns="25400" rIns="25400" tIns="12700" bIns="12700">
+          <a:bodyPr wrap="square" anchor="t" lIns="25400" rIns="25400" tIns="25400" bIns="25400">
             <a:spAutoFit/>
           </a:bodyPr>
           <a:lstStyle/>
@@ -9683,7 +10513,7 @@
                 </a:solidFill>
                 <a:latin typeface="Inter"/>
               </a:rPr>
-              <a:t>PROCESS FLOW · TO-BE</a:t>
+              <a:t>PROCESS FLOW</a:t>
             </a:r>
           </a:p>
         </p:txBody>
@@ -9705,7 +10535,7 @@
           <a:noFill/>
         </p:spPr>
         <p:txBody>
-          <a:bodyPr wrap="square" anchor="t" lIns="25400" rIns="25400" tIns="12700" bIns="12700">
+          <a:bodyPr wrap="square" anchor="t" lIns="25400" rIns="25400" tIns="25400" bIns="25400">
             <a:spAutoFit/>
           </a:bodyPr>
           <a:lstStyle/>
@@ -9736,7 +10566,7 @@
         <p:spPr>
           <a:xfrm>
             <a:off x="571500" y="1003300"/>
-            <a:ext cx="10922000" cy="317500"/>
+            <a:ext cx="10922000" cy="254000"/>
           </a:xfrm>
           <a:prstGeom prst="rect">
             <a:avLst/>
@@ -9744,7 +10574,7 @@
           <a:noFill/>
         </p:spPr>
         <p:txBody>
-          <a:bodyPr wrap="square" anchor="t" lIns="25400" rIns="25400" tIns="12700" bIns="12700">
+          <a:bodyPr wrap="square" anchor="t" lIns="25400" rIns="25400" tIns="25400" bIns="25400">
             <a:spAutoFit/>
           </a:bodyPr>
           <a:lstStyle/>
@@ -9761,7 +10591,7 @@
                 </a:solidFill>
                 <a:latin typeface="Inter"/>
               </a:rPr>
-              <a:t>A swimlane map of the proposed (To-Be) process — read against today's As-Is to spot what to optimise, and use it to design the prototypes and screens.</a:t>
+              <a:t>A swimlane map of the proposed process.</a:t>
             </a:r>
           </a:p>
         </p:txBody>
@@ -10274,8 +11104,8 @@
         </p:nvSpPr>
         <p:spPr>
           <a:xfrm>
-            <a:off x="1397000" y="1866899"/>
-            <a:ext cx="1016000" cy="457200"/>
+            <a:off x="1435100" y="1854200"/>
+            <a:ext cx="1041400" cy="482600"/>
           </a:xfrm>
           <a:prstGeom prst="roundRect">
             <a:avLst>
@@ -10283,7 +11113,7 @@
             </a:avLst>
           </a:prstGeom>
           <a:solidFill>
-            <a:srgbClr val="FBF7F1"/>
+            <a:srgbClr val="FFFFFF"/>
           </a:solidFill>
           <a:ln w="12700">
             <a:solidFill>
@@ -10322,8 +11152,8 @@
         </p:nvSpPr>
         <p:spPr>
           <a:xfrm>
-            <a:off x="1460500" y="1866899"/>
-            <a:ext cx="889000" cy="457200"/>
+            <a:off x="1498600" y="1854200"/>
+            <a:ext cx="914400" cy="482600"/>
           </a:xfrm>
           <a:prstGeom prst="rect">
             <a:avLst/>
@@ -10331,7 +11161,7 @@
           <a:noFill/>
         </p:spPr>
         <p:txBody>
-          <a:bodyPr wrap="square" anchor="ctr" lIns="25400" rIns="25400" tIns="12700" bIns="12700">
+          <a:bodyPr wrap="square" anchor="ctr" lIns="25400" rIns="25400" tIns="25400" bIns="25400">
             <a:normAutofit/>
           </a:bodyPr>
           <a:lstStyle/>
@@ -10361,7 +11191,94 @@
         </p:nvSpPr>
         <p:spPr>
           <a:xfrm>
-            <a:off x="1397000" y="4362450"/>
+            <a:off x="10775950" y="1854200"/>
+            <a:ext cx="952500" cy="482600"/>
+          </a:xfrm>
+          <a:prstGeom prst="roundRect">
+            <a:avLst>
+              <a:gd name="adj" fmla="val 50000"/>
+            </a:avLst>
+          </a:prstGeom>
+          <a:solidFill>
+            <a:srgbClr val="FFFFFF"/>
+          </a:solidFill>
+          <a:ln w="12700">
+            <a:solidFill>
+              <a:srgbClr val="C98A5E"/>
+            </a:solidFill>
+          </a:ln>
+          <a:effectLst/>
+        </p:spPr>
+        <p:style>
+          <a:lnRef idx="1">
+            <a:schemeClr val="accent1"/>
+          </a:lnRef>
+          <a:fillRef idx="3">
+            <a:schemeClr val="accent1"/>
+          </a:fillRef>
+          <a:effectRef idx="2">
+            <a:schemeClr val="accent1"/>
+          </a:effectRef>
+          <a:fontRef idx="minor">
+            <a:schemeClr val="lt1"/>
+          </a:fontRef>
+        </p:style>
+        <p:txBody>
+          <a:bodyPr rtlCol="0" anchor="ctr"/>
+          <a:lstStyle/>
+          <a:p>
+            <a:pPr algn="ctr"/>
+          </a:p>
+        </p:txBody>
+      </p:sp>
+      <p:sp>
+        <p:nvSpPr>
+          <p:cNvPr id="21" name="TextBox 20"/>
+          <p:cNvSpPr txBox="1"/>
+          <p:nvPr/>
+        </p:nvSpPr>
+        <p:spPr>
+          <a:xfrm>
+            <a:off x="10839450" y="1854200"/>
+            <a:ext cx="825500" cy="482600"/>
+          </a:xfrm>
+          <a:prstGeom prst="rect">
+            <a:avLst/>
+          </a:prstGeom>
+          <a:noFill/>
+        </p:spPr>
+        <p:txBody>
+          <a:bodyPr wrap="square" anchor="ctr" lIns="25400" rIns="25400" tIns="25400" bIns="25400">
+            <a:normAutofit/>
+          </a:bodyPr>
+          <a:lstStyle/>
+          <a:p>
+            <a:pPr algn="ctr">
+              <a:spcAft>
+                <a:spcPts val="0"/>
+              </a:spcAft>
+            </a:pPr>
+            <a:r>
+              <a:rPr sz="625" b="1">
+                <a:solidFill>
+                  <a:srgbClr val="142433"/>
+                </a:solidFill>
+                <a:latin typeface="Inter"/>
+              </a:rPr>
+              <a:t>Ongoing care</a:t>
+            </a:r>
+          </a:p>
+        </p:txBody>
+      </p:sp>
+      <p:sp>
+        <p:nvSpPr>
+          <p:cNvPr id="22" name="Rounded Rectangle 21"/>
+          <p:cNvSpPr/>
+          <p:nvPr/>
+        </p:nvSpPr>
+        <p:spPr>
+          <a:xfrm>
+            <a:off x="2540000" y="1873250"/>
             <a:ext cx="1016000" cy="444500"/>
           </a:xfrm>
           <a:prstGeom prst="roundRect">
@@ -10403,13 +11320,13 @@
       </p:sp>
       <p:sp>
         <p:nvSpPr>
-          <p:cNvPr id="21" name="TextBox 20"/>
+          <p:cNvPr id="23" name="TextBox 22"/>
           <p:cNvSpPr txBox="1"/>
           <p:nvPr/>
         </p:nvSpPr>
         <p:spPr>
           <a:xfrm>
-            <a:off x="1460500" y="4362450"/>
+            <a:off x="2603500" y="1873250"/>
             <a:ext cx="889000" cy="444500"/>
           </a:xfrm>
           <a:prstGeom prst="rect">
@@ -10418,7 +11335,7 @@
           <a:noFill/>
         </p:spPr>
         <p:txBody>
-          <a:bodyPr wrap="square" anchor="ctr" lIns="25400" rIns="25400" tIns="12700" bIns="12700">
+          <a:bodyPr wrap="square" anchor="ctr" lIns="25400" rIns="25400" tIns="25400" bIns="25400">
             <a:normAutofit/>
           </a:bodyPr>
           <a:lstStyle/>
@@ -10435,20 +11352,20 @@
                 </a:solidFill>
                 <a:latin typeface="Inter"/>
               </a:rPr>
-              <a:t>Capture enquiry + smart intake</a:t>
-            </a:r>
-          </a:p>
-        </p:txBody>
-      </p:sp>
-      <p:sp>
-        <p:nvSpPr>
-          <p:cNvPr id="22" name="Rounded Rectangle 21"/>
+              <a:t>Complete intake &amp; consent</a:t>
+            </a:r>
+          </a:p>
+        </p:txBody>
+      </p:sp>
+      <p:sp>
+        <p:nvSpPr>
+          <p:cNvPr id="24" name="Rounded Rectangle 23"/>
           <p:cNvSpPr/>
           <p:nvPr/>
         </p:nvSpPr>
         <p:spPr>
           <a:xfrm>
-            <a:off x="2362200" y="1873250"/>
+            <a:off x="9626600" y="1873250"/>
             <a:ext cx="1016000" cy="444500"/>
           </a:xfrm>
           <a:prstGeom prst="roundRect">
@@ -10490,13 +11407,13 @@
       </p:sp>
       <p:sp>
         <p:nvSpPr>
-          <p:cNvPr id="23" name="TextBox 22"/>
+          <p:cNvPr id="25" name="TextBox 24"/>
           <p:cNvSpPr txBox="1"/>
           <p:nvPr/>
         </p:nvSpPr>
         <p:spPr>
           <a:xfrm>
-            <a:off x="2425700" y="1873250"/>
+            <a:off x="9690100" y="1873250"/>
             <a:ext cx="889000" cy="444500"/>
           </a:xfrm>
           <a:prstGeom prst="rect">
@@ -10505,7 +11422,7 @@
           <a:noFill/>
         </p:spPr>
         <p:txBody>
-          <a:bodyPr wrap="square" anchor="ctr" lIns="25400" rIns="25400" tIns="12700" bIns="12700">
+          <a:bodyPr wrap="square" anchor="ctr" lIns="25400" rIns="25400" tIns="25400" bIns="25400">
             <a:normAutofit/>
           </a:bodyPr>
           <a:lstStyle/>
@@ -10522,20 +11439,77 @@
                 </a:solidFill>
                 <a:latin typeface="Inter"/>
               </a:rPr>
-              <a:t>Complete intake &amp; consent</a:t>
-            </a:r>
-          </a:p>
-        </p:txBody>
-      </p:sp>
-      <p:sp>
-        <p:nvSpPr>
-          <p:cNvPr id="24" name="Rounded Rectangle 23"/>
+              <a:t>Receive summary (app)</a:t>
+            </a:r>
+          </a:p>
+        </p:txBody>
+      </p:sp>
+      <p:sp>
+        <p:nvSpPr>
+          <p:cNvPr id="26" name="Diamond 25"/>
           <p:cNvSpPr/>
           <p:nvPr/>
         </p:nvSpPr>
         <p:spPr>
           <a:xfrm>
-            <a:off x="3327400" y="4362450"/>
+            <a:off x="6038850" y="3009900"/>
+            <a:ext cx="1092200" cy="660400"/>
+          </a:xfrm>
+          <a:prstGeom prst="diamond">
+            <a:avLst/>
+          </a:prstGeom>
+          <a:solidFill>
+            <a:srgbClr val="FFF0E6"/>
+          </a:solidFill>
+          <a:ln w="19050">
+            <a:solidFill>
+              <a:srgbClr val="C45A1A"/>
+            </a:solidFill>
+          </a:ln>
+          <a:effectLst/>
+        </p:spPr>
+        <p:style>
+          <a:lnRef idx="1">
+            <a:schemeClr val="accent1"/>
+          </a:lnRef>
+          <a:fillRef idx="3">
+            <a:schemeClr val="accent1"/>
+          </a:fillRef>
+          <a:effectRef idx="2">
+            <a:schemeClr val="accent1"/>
+          </a:effectRef>
+          <a:fontRef idx="minor">
+            <a:schemeClr val="lt1"/>
+          </a:fontRef>
+        </p:style>
+        <p:txBody>
+          <a:bodyPr rtlCol="0" anchor="ctr" wrap="square" lIns="25400" rIns="25400" tIns="25400" bIns="25400">
+            <a:normAutofit/>
+          </a:bodyPr>
+          <a:lstStyle/>
+          <a:p>
+            <a:pPr algn="ctr"/>
+            <a:r>
+              <a:rPr sz="625" b="1">
+                <a:solidFill>
+                  <a:srgbClr val="142433"/>
+                </a:solidFill>
+                <a:latin typeface="Inter"/>
+              </a:rPr>
+              <a:t>Ongoing therapy?</a:t>
+            </a:r>
+          </a:p>
+        </p:txBody>
+      </p:sp>
+      <p:sp>
+        <p:nvSpPr>
+          <p:cNvPr id="27" name="Rounded Rectangle 26"/>
+          <p:cNvSpPr/>
+          <p:nvPr/>
+        </p:nvSpPr>
+        <p:spPr>
+          <a:xfrm>
+            <a:off x="3613150" y="3117850"/>
             <a:ext cx="1016000" cy="444500"/>
           </a:xfrm>
           <a:prstGeom prst="roundRect">
@@ -10577,13 +11551,13 @@
       </p:sp>
       <p:sp>
         <p:nvSpPr>
-          <p:cNvPr id="25" name="TextBox 24"/>
+          <p:cNvPr id="28" name="TextBox 27"/>
           <p:cNvSpPr txBox="1"/>
           <p:nvPr/>
         </p:nvSpPr>
         <p:spPr>
           <a:xfrm>
-            <a:off x="3390900" y="4362450"/>
+            <a:off x="3676649" y="3117850"/>
             <a:ext cx="889000" cy="444500"/>
           </a:xfrm>
           <a:prstGeom prst="rect">
@@ -10592,7 +11566,7 @@
           <a:noFill/>
         </p:spPr>
         <p:txBody>
-          <a:bodyPr wrap="square" anchor="ctr" lIns="25400" rIns="25400" tIns="12700" bIns="12700">
+          <a:bodyPr wrap="square" anchor="ctr" lIns="25400" rIns="25400" tIns="25400" bIns="25400">
             <a:normAutofit/>
           </a:bodyPr>
           <a:lstStyle/>
@@ -10609,20 +11583,20 @@
                 </a:solidFill>
                 <a:latin typeface="Inter"/>
               </a:rPr>
-              <a:t>AI prep brief (DRAFT)</a:t>
-            </a:r>
-          </a:p>
-        </p:txBody>
-      </p:sp>
-      <p:sp>
-        <p:nvSpPr>
-          <p:cNvPr id="26" name="Rounded Rectangle 25"/>
+              <a:t>Review overview + prep</a:t>
+            </a:r>
+          </a:p>
+        </p:txBody>
+      </p:sp>
+      <p:sp>
+        <p:nvSpPr>
+          <p:cNvPr id="29" name="Rounded Rectangle 28"/>
           <p:cNvSpPr/>
           <p:nvPr/>
         </p:nvSpPr>
         <p:spPr>
           <a:xfrm>
-            <a:off x="4292600" y="3117850"/>
+            <a:off x="4826000" y="3117850"/>
             <a:ext cx="1016000" cy="444500"/>
           </a:xfrm>
           <a:prstGeom prst="roundRect">
@@ -10664,13 +11638,13 @@
       </p:sp>
       <p:sp>
         <p:nvSpPr>
-          <p:cNvPr id="27" name="TextBox 26"/>
+          <p:cNvPr id="30" name="TextBox 29"/>
           <p:cNvSpPr txBox="1"/>
           <p:nvPr/>
         </p:nvSpPr>
         <p:spPr>
           <a:xfrm>
-            <a:off x="4356100" y="3117850"/>
+            <a:off x="4889500" y="3117850"/>
             <a:ext cx="889000" cy="444500"/>
           </a:xfrm>
           <a:prstGeom prst="rect">
@@ -10679,7 +11653,7 @@
           <a:noFill/>
         </p:spPr>
         <p:txBody>
-          <a:bodyPr wrap="square" anchor="ctr" lIns="25400" rIns="25400" tIns="12700" bIns="12700">
+          <a:bodyPr wrap="square" anchor="ctr" lIns="25400" rIns="25400" tIns="25400" bIns="25400">
             <a:normAutofit/>
           </a:bodyPr>
           <a:lstStyle/>
@@ -10696,20 +11670,20 @@
                 </a:solidFill>
                 <a:latin typeface="Inter"/>
               </a:rPr>
-              <a:t>Review overview + prep</a:t>
-            </a:r>
-          </a:p>
-        </p:txBody>
-      </p:sp>
-      <p:sp>
-        <p:nvSpPr>
-          <p:cNvPr id="28" name="Rounded Rectangle 27"/>
+              <a:t>Consultation (~20 min)</a:t>
+            </a:r>
+          </a:p>
+        </p:txBody>
+      </p:sp>
+      <p:sp>
+        <p:nvSpPr>
+          <p:cNvPr id="31" name="Rounded Rectangle 30"/>
           <p:cNvSpPr/>
           <p:nvPr/>
         </p:nvSpPr>
         <p:spPr>
           <a:xfrm>
-            <a:off x="4292600" y="5607050"/>
+            <a:off x="7454900" y="3117850"/>
             <a:ext cx="1016000" cy="444500"/>
           </a:xfrm>
           <a:prstGeom prst="roundRect">
@@ -10751,13 +11725,13 @@
       </p:sp>
       <p:sp>
         <p:nvSpPr>
-          <p:cNvPr id="29" name="TextBox 28"/>
+          <p:cNvPr id="32" name="TextBox 31"/>
           <p:cNvSpPr txBox="1"/>
           <p:nvPr/>
         </p:nvSpPr>
         <p:spPr>
           <a:xfrm>
-            <a:off x="4356100" y="5607050"/>
+            <a:off x="7518399" y="3117850"/>
             <a:ext cx="889000" cy="444500"/>
           </a:xfrm>
           <a:prstGeom prst="rect">
@@ -10766,7 +11740,7 @@
           <a:noFill/>
         </p:spPr>
         <p:txBody>
-          <a:bodyPr wrap="square" anchor="ctr" lIns="25400" rIns="25400" tIns="12700" bIns="12700">
+          <a:bodyPr wrap="square" anchor="ctr" lIns="25400" rIns="25400" tIns="25400" bIns="25400">
             <a:normAutofit/>
           </a:bodyPr>
           <a:lstStyle/>
@@ -10783,20 +11757,20 @@
                 </a:solidFill>
                 <a:latin typeface="Inter"/>
               </a:rPr>
-              <a:t>Calendar / video link</a:t>
-            </a:r>
-          </a:p>
-        </p:txBody>
-      </p:sp>
-      <p:sp>
-        <p:nvSpPr>
-          <p:cNvPr id="30" name="Rounded Rectangle 29"/>
+              <a:t>Strategy advice &amp; home tips</a:t>
+            </a:r>
+          </a:p>
+        </p:txBody>
+      </p:sp>
+      <p:sp>
+        <p:nvSpPr>
+          <p:cNvPr id="33" name="Rounded Rectangle 32"/>
           <p:cNvSpPr/>
           <p:nvPr/>
         </p:nvSpPr>
         <p:spPr>
           <a:xfrm>
-            <a:off x="5257800" y="3117850"/>
+            <a:off x="8940800" y="3117850"/>
             <a:ext cx="1016000" cy="444500"/>
           </a:xfrm>
           <a:prstGeom prst="roundRect">
@@ -10838,13 +11812,13 @@
       </p:sp>
       <p:sp>
         <p:nvSpPr>
-          <p:cNvPr id="31" name="TextBox 30"/>
+          <p:cNvPr id="34" name="TextBox 33"/>
           <p:cNvSpPr txBox="1"/>
           <p:nvPr/>
         </p:nvSpPr>
         <p:spPr>
           <a:xfrm>
-            <a:off x="5321300" y="3117850"/>
+            <a:off x="9004300" y="3117850"/>
             <a:ext cx="889000" cy="444500"/>
           </a:xfrm>
           <a:prstGeom prst="rect">
@@ -10853,7 +11827,7 @@
           <a:noFill/>
         </p:spPr>
         <p:txBody>
-          <a:bodyPr wrap="square" anchor="ctr" lIns="25400" rIns="25400" tIns="12700" bIns="12700">
+          <a:bodyPr wrap="square" anchor="ctr" lIns="25400" rIns="25400" tIns="25400" bIns="25400">
             <a:normAutofit/>
           </a:bodyPr>
           <a:lstStyle/>
@@ -10870,77 +11844,20 @@
                 </a:solidFill>
                 <a:latin typeface="Inter"/>
               </a:rPr>
-              <a:t>Consultation (~20 min)</a:t>
-            </a:r>
-          </a:p>
-        </p:txBody>
-      </p:sp>
-      <p:sp>
-        <p:nvSpPr>
-          <p:cNvPr id="32" name="Diamond 31"/>
+              <a:t>Edit &amp; sign plan</a:t>
+            </a:r>
+          </a:p>
+        </p:txBody>
+      </p:sp>
+      <p:sp>
+        <p:nvSpPr>
+          <p:cNvPr id="35" name="Rounded Rectangle 34"/>
           <p:cNvSpPr/>
           <p:nvPr/>
         </p:nvSpPr>
         <p:spPr>
           <a:xfrm>
-            <a:off x="6184900" y="3009900"/>
-            <a:ext cx="1092200" cy="660400"/>
-          </a:xfrm>
-          <a:prstGeom prst="diamond">
-            <a:avLst/>
-          </a:prstGeom>
-          <a:solidFill>
-            <a:srgbClr val="FFF0E6"/>
-          </a:solidFill>
-          <a:ln w="19050">
-            <a:solidFill>
-              <a:srgbClr val="C45A1A"/>
-            </a:solidFill>
-          </a:ln>
-          <a:effectLst/>
-        </p:spPr>
-        <p:style>
-          <a:lnRef idx="1">
-            <a:schemeClr val="accent1"/>
-          </a:lnRef>
-          <a:fillRef idx="3">
-            <a:schemeClr val="accent1"/>
-          </a:fillRef>
-          <a:effectRef idx="2">
-            <a:schemeClr val="accent1"/>
-          </a:effectRef>
-          <a:fontRef idx="minor">
-            <a:schemeClr val="lt1"/>
-          </a:fontRef>
-        </p:style>
-        <p:txBody>
-          <a:bodyPr rtlCol="0" anchor="ctr" wrap="square" lIns="38100" rIns="38100" tIns="12700" bIns="12700">
-            <a:normAutofit/>
-          </a:bodyPr>
-          <a:lstStyle/>
-          <a:p>
-            <a:pPr algn="ctr"/>
-            <a:r>
-              <a:rPr sz="625" b="1">
-                <a:solidFill>
-                  <a:srgbClr val="142433"/>
-                </a:solidFill>
-                <a:latin typeface="Inter"/>
-              </a:rPr>
-              <a:t>Ongoing therapy?</a:t>
-            </a:r>
-          </a:p>
-        </p:txBody>
-      </p:sp>
-      <p:sp>
-        <p:nvSpPr>
-          <p:cNvPr id="33" name="Rounded Rectangle 32"/>
-          <p:cNvSpPr/>
-          <p:nvPr/>
-        </p:nvSpPr>
-        <p:spPr>
-          <a:xfrm>
-            <a:off x="7188200" y="4362450"/>
+            <a:off x="10083800" y="3117850"/>
             <a:ext cx="1016000" cy="444500"/>
           </a:xfrm>
           <a:prstGeom prst="roundRect">
@@ -10982,13 +11899,13 @@
       </p:sp>
       <p:sp>
         <p:nvSpPr>
-          <p:cNvPr id="34" name="TextBox 33"/>
+          <p:cNvPr id="36" name="TextBox 35"/>
           <p:cNvSpPr txBox="1"/>
           <p:nvPr/>
         </p:nvSpPr>
         <p:spPr>
           <a:xfrm>
-            <a:off x="7251700" y="4362450"/>
+            <a:off x="10147300" y="3117850"/>
             <a:ext cx="889000" cy="444500"/>
           </a:xfrm>
           <a:prstGeom prst="rect">
@@ -10997,7 +11914,7 @@
           <a:noFill/>
         </p:spPr>
         <p:txBody>
-          <a:bodyPr wrap="square" anchor="ctr" lIns="25400" rIns="25400" tIns="12700" bIns="12700">
+          <a:bodyPr wrap="square" anchor="ctr" lIns="25400" rIns="25400" tIns="25400" bIns="25400">
             <a:normAutofit/>
           </a:bodyPr>
           <a:lstStyle/>
@@ -11014,20 +11931,20 @@
                 </a:solidFill>
                 <a:latin typeface="Inter"/>
               </a:rPr>
-              <a:t>AI session plan (DRAFT)</a:t>
-            </a:r>
-          </a:p>
-        </p:txBody>
-      </p:sp>
-      <p:sp>
-        <p:nvSpPr>
-          <p:cNvPr id="35" name="Rounded Rectangle 34"/>
+              <a:t>Review &amp; send summary</a:t>
+            </a:r>
+          </a:p>
+        </p:txBody>
+      </p:sp>
+      <p:sp>
+        <p:nvSpPr>
+          <p:cNvPr id="37" name="Rounded Rectangle 36"/>
           <p:cNvSpPr/>
           <p:nvPr/>
         </p:nvSpPr>
         <p:spPr>
           <a:xfrm>
-            <a:off x="7188200" y="3117850"/>
+            <a:off x="1435100" y="4362450"/>
             <a:ext cx="1016000" cy="444500"/>
           </a:xfrm>
           <a:prstGeom prst="roundRect">
@@ -11069,13 +11986,13 @@
       </p:sp>
       <p:sp>
         <p:nvSpPr>
-          <p:cNvPr id="36" name="TextBox 35"/>
+          <p:cNvPr id="38" name="TextBox 37"/>
           <p:cNvSpPr txBox="1"/>
           <p:nvPr/>
         </p:nvSpPr>
         <p:spPr>
           <a:xfrm>
-            <a:off x="7251700" y="3117850"/>
+            <a:off x="1498600" y="4362450"/>
             <a:ext cx="889000" cy="444500"/>
           </a:xfrm>
           <a:prstGeom prst="rect">
@@ -11084,7 +12001,7 @@
           <a:noFill/>
         </p:spPr>
         <p:txBody>
-          <a:bodyPr wrap="square" anchor="ctr" lIns="25400" rIns="25400" tIns="12700" bIns="12700">
+          <a:bodyPr wrap="square" anchor="ctr" lIns="25400" rIns="25400" tIns="25400" bIns="25400">
             <a:normAutofit/>
           </a:bodyPr>
           <a:lstStyle/>
@@ -11101,20 +12018,20 @@
                 </a:solidFill>
                 <a:latin typeface="Inter"/>
               </a:rPr>
-              <a:t>Strategy advice &amp; home tips</a:t>
-            </a:r>
-          </a:p>
-        </p:txBody>
-      </p:sp>
-      <p:sp>
-        <p:nvSpPr>
-          <p:cNvPr id="37" name="Rounded Rectangle 36"/>
+              <a:t>Capture enquiry + smart intake</a:t>
+            </a:r>
+          </a:p>
+        </p:txBody>
+      </p:sp>
+      <p:sp>
+        <p:nvSpPr>
+          <p:cNvPr id="39" name="Rounded Rectangle 38"/>
           <p:cNvSpPr/>
           <p:nvPr/>
         </p:nvSpPr>
         <p:spPr>
           <a:xfrm>
-            <a:off x="8153399" y="3117850"/>
+            <a:off x="2762250" y="4362450"/>
             <a:ext cx="1016000" cy="444500"/>
           </a:xfrm>
           <a:prstGeom prst="roundRect">
@@ -11156,13 +12073,13 @@
       </p:sp>
       <p:sp>
         <p:nvSpPr>
-          <p:cNvPr id="38" name="TextBox 37"/>
+          <p:cNvPr id="40" name="TextBox 39"/>
           <p:cNvSpPr txBox="1"/>
           <p:nvPr/>
         </p:nvSpPr>
         <p:spPr>
           <a:xfrm>
-            <a:off x="8216900" y="3117850"/>
+            <a:off x="2825750" y="4362450"/>
             <a:ext cx="889000" cy="444500"/>
           </a:xfrm>
           <a:prstGeom prst="rect">
@@ -11171,7 +12088,7 @@
           <a:noFill/>
         </p:spPr>
         <p:txBody>
-          <a:bodyPr wrap="square" anchor="ctr" lIns="25400" rIns="25400" tIns="12700" bIns="12700">
+          <a:bodyPr wrap="square" anchor="ctr" lIns="25400" rIns="25400" tIns="25400" bIns="25400">
             <a:normAutofit/>
           </a:bodyPr>
           <a:lstStyle/>
@@ -11188,20 +12105,20 @@
                 </a:solidFill>
                 <a:latin typeface="Inter"/>
               </a:rPr>
-              <a:t>Edit &amp; sign plan</a:t>
-            </a:r>
-          </a:p>
-        </p:txBody>
-      </p:sp>
-      <p:sp>
-        <p:nvSpPr>
-          <p:cNvPr id="39" name="Rounded Rectangle 38"/>
+              <a:t>AI prep brief (DRAFT)</a:t>
+            </a:r>
+          </a:p>
+        </p:txBody>
+      </p:sp>
+      <p:sp>
+        <p:nvSpPr>
+          <p:cNvPr id="41" name="Rounded Rectangle 40"/>
           <p:cNvSpPr/>
           <p:nvPr/>
         </p:nvSpPr>
         <p:spPr>
           <a:xfrm>
-            <a:off x="9118600" y="4362450"/>
+            <a:off x="7188200" y="4362450"/>
             <a:ext cx="1016000" cy="444500"/>
           </a:xfrm>
           <a:prstGeom prst="roundRect">
@@ -11243,13 +12160,13 @@
       </p:sp>
       <p:sp>
         <p:nvSpPr>
-          <p:cNvPr id="40" name="TextBox 39"/>
+          <p:cNvPr id="42" name="TextBox 41"/>
           <p:cNvSpPr txBox="1"/>
           <p:nvPr/>
         </p:nvSpPr>
         <p:spPr>
           <a:xfrm>
-            <a:off x="9182100" y="4362450"/>
+            <a:off x="7251700" y="4362450"/>
             <a:ext cx="889000" cy="444500"/>
           </a:xfrm>
           <a:prstGeom prst="rect">
@@ -11258,7 +12175,7 @@
           <a:noFill/>
         </p:spPr>
         <p:txBody>
-          <a:bodyPr wrap="square" anchor="ctr" lIns="25400" rIns="25400" tIns="12700" bIns="12700">
+          <a:bodyPr wrap="square" anchor="ctr" lIns="25400" rIns="25400" tIns="25400" bIns="25400">
             <a:normAutofit/>
           </a:bodyPr>
           <a:lstStyle/>
@@ -11275,20 +12192,20 @@
                 </a:solidFill>
                 <a:latin typeface="Inter"/>
               </a:rPr>
-              <a:t>AI family summary (DRAFT)</a:t>
-            </a:r>
-          </a:p>
-        </p:txBody>
-      </p:sp>
-      <p:sp>
-        <p:nvSpPr>
-          <p:cNvPr id="41" name="Rounded Rectangle 40"/>
+              <a:t>AI session plan (DRAFT)</a:t>
+            </a:r>
+          </a:p>
+        </p:txBody>
+      </p:sp>
+      <p:sp>
+        <p:nvSpPr>
+          <p:cNvPr id="43" name="Rounded Rectangle 42"/>
           <p:cNvSpPr/>
           <p:nvPr/>
         </p:nvSpPr>
         <p:spPr>
           <a:xfrm>
-            <a:off x="10083800" y="3117850"/>
+            <a:off x="9118600" y="4362450"/>
             <a:ext cx="1016000" cy="444500"/>
           </a:xfrm>
           <a:prstGeom prst="roundRect">
@@ -11330,13 +12247,13 @@
       </p:sp>
       <p:sp>
         <p:nvSpPr>
-          <p:cNvPr id="42" name="TextBox 41"/>
+          <p:cNvPr id="44" name="TextBox 43"/>
           <p:cNvSpPr txBox="1"/>
           <p:nvPr/>
         </p:nvSpPr>
         <p:spPr>
           <a:xfrm>
-            <a:off x="10147300" y="3117850"/>
+            <a:off x="9182100" y="4362450"/>
             <a:ext cx="889000" cy="444500"/>
           </a:xfrm>
           <a:prstGeom prst="rect">
@@ -11345,7 +12262,7 @@
           <a:noFill/>
         </p:spPr>
         <p:txBody>
-          <a:bodyPr wrap="square" anchor="ctr" lIns="25400" rIns="25400" tIns="12700" bIns="12700">
+          <a:bodyPr wrap="square" anchor="ctr" lIns="25400" rIns="25400" tIns="25400" bIns="25400">
             <a:normAutofit/>
           </a:bodyPr>
           <a:lstStyle/>
@@ -11362,20 +12279,20 @@
                 </a:solidFill>
                 <a:latin typeface="Inter"/>
               </a:rPr>
-              <a:t>Review &amp; send summary</a:t>
-            </a:r>
-          </a:p>
-        </p:txBody>
-      </p:sp>
-      <p:sp>
-        <p:nvSpPr>
-          <p:cNvPr id="43" name="Rounded Rectangle 42"/>
+              <a:t>AI family summary (DRAFT)</a:t>
+            </a:r>
+          </a:p>
+        </p:txBody>
+      </p:sp>
+      <p:sp>
+        <p:nvSpPr>
+          <p:cNvPr id="45" name="Rounded Rectangle 44"/>
           <p:cNvSpPr/>
           <p:nvPr/>
         </p:nvSpPr>
         <p:spPr>
           <a:xfrm>
-            <a:off x="9626600" y="1873250"/>
+            <a:off x="10363200" y="4362450"/>
             <a:ext cx="1016000" cy="444500"/>
           </a:xfrm>
           <a:prstGeom prst="roundRect">
@@ -11417,13 +12334,13 @@
       </p:sp>
       <p:sp>
         <p:nvSpPr>
-          <p:cNvPr id="44" name="TextBox 43"/>
+          <p:cNvPr id="46" name="TextBox 45"/>
           <p:cNvSpPr txBox="1"/>
           <p:nvPr/>
         </p:nvSpPr>
         <p:spPr>
           <a:xfrm>
-            <a:off x="9690100" y="1873250"/>
+            <a:off x="10426700" y="4362450"/>
             <a:ext cx="889000" cy="444500"/>
           </a:xfrm>
           <a:prstGeom prst="rect">
@@ -11432,7 +12349,7 @@
           <a:noFill/>
         </p:spPr>
         <p:txBody>
-          <a:bodyPr wrap="square" anchor="ctr" lIns="25400" rIns="25400" tIns="12700" bIns="12700">
+          <a:bodyPr wrap="square" anchor="ctr" lIns="25400" rIns="25400" tIns="25400" bIns="25400">
             <a:normAutofit/>
           </a:bodyPr>
           <a:lstStyle/>
@@ -11449,20 +12366,20 @@
                 </a:solidFill>
                 <a:latin typeface="Inter"/>
               </a:rPr>
-              <a:t>Receive summary (app)</a:t>
-            </a:r>
-          </a:p>
-        </p:txBody>
-      </p:sp>
-      <p:sp>
-        <p:nvSpPr>
-          <p:cNvPr id="45" name="Rounded Rectangle 44"/>
+              <a:t>Carryover + progress portal</a:t>
+            </a:r>
+          </a:p>
+        </p:txBody>
+      </p:sp>
+      <p:sp>
+        <p:nvSpPr>
+          <p:cNvPr id="47" name="Rounded Rectangle 46"/>
           <p:cNvSpPr/>
           <p:nvPr/>
         </p:nvSpPr>
         <p:spPr>
           <a:xfrm>
-            <a:off x="10083800" y="4362450"/>
+            <a:off x="4292600" y="5607050"/>
             <a:ext cx="1016000" cy="444500"/>
           </a:xfrm>
           <a:prstGeom prst="roundRect">
@@ -11504,13 +12421,13 @@
       </p:sp>
       <p:sp>
         <p:nvSpPr>
-          <p:cNvPr id="46" name="TextBox 45"/>
+          <p:cNvPr id="48" name="TextBox 47"/>
           <p:cNvSpPr txBox="1"/>
           <p:nvPr/>
         </p:nvSpPr>
         <p:spPr>
           <a:xfrm>
-            <a:off x="10147300" y="4362450"/>
+            <a:off x="4356100" y="5607050"/>
             <a:ext cx="889000" cy="444500"/>
           </a:xfrm>
           <a:prstGeom prst="rect">
@@ -11519,7 +12436,7 @@
           <a:noFill/>
         </p:spPr>
         <p:txBody>
-          <a:bodyPr wrap="square" anchor="ctr" lIns="25400" rIns="25400" tIns="12700" bIns="12700">
+          <a:bodyPr wrap="square" anchor="ctr" lIns="25400" rIns="25400" tIns="25400" bIns="25400">
             <a:normAutofit/>
           </a:bodyPr>
           <a:lstStyle/>
@@ -11536,20 +12453,20 @@
                 </a:solidFill>
                 <a:latin typeface="Inter"/>
               </a:rPr>
-              <a:t>Carryover + progress portal</a:t>
-            </a:r>
-          </a:p>
-        </p:txBody>
-      </p:sp>
-      <p:sp>
-        <p:nvSpPr>
-          <p:cNvPr id="47" name="Rounded Rectangle 46"/>
+              <a:t>Calendar / video link</a:t>
+            </a:r>
+          </a:p>
+        </p:txBody>
+      </p:sp>
+      <p:sp>
+        <p:nvSpPr>
+          <p:cNvPr id="49" name="Rounded Rectangle 48"/>
           <p:cNvSpPr/>
           <p:nvPr/>
         </p:nvSpPr>
         <p:spPr>
           <a:xfrm>
-            <a:off x="10083800" y="5607050"/>
+            <a:off x="10363200" y="5613400"/>
             <a:ext cx="1016000" cy="444500"/>
           </a:xfrm>
           <a:prstGeom prst="roundRect">
@@ -11591,13 +12508,13 @@
       </p:sp>
       <p:sp>
         <p:nvSpPr>
-          <p:cNvPr id="48" name="TextBox 47"/>
+          <p:cNvPr id="50" name="TextBox 49"/>
           <p:cNvSpPr txBox="1"/>
           <p:nvPr/>
         </p:nvSpPr>
         <p:spPr>
           <a:xfrm>
-            <a:off x="10147300" y="5607050"/>
+            <a:off x="10426700" y="5613400"/>
             <a:ext cx="889000" cy="444500"/>
           </a:xfrm>
           <a:prstGeom prst="rect">
@@ -11606,7 +12523,7 @@
           <a:noFill/>
         </p:spPr>
         <p:txBody>
-          <a:bodyPr wrap="square" anchor="ctr" lIns="25400" rIns="25400" tIns="12700" bIns="12700">
+          <a:bodyPr wrap="square" anchor="ctr" lIns="25400" rIns="25400" tIns="25400" bIns="25400">
             <a:normAutofit/>
           </a:bodyPr>
           <a:lstStyle/>
@@ -11628,93 +12545,6 @@
           </a:p>
         </p:txBody>
       </p:sp>
-      <p:sp>
-        <p:nvSpPr>
-          <p:cNvPr id="49" name="Rounded Rectangle 48"/>
-          <p:cNvSpPr/>
-          <p:nvPr/>
-        </p:nvSpPr>
-        <p:spPr>
-          <a:xfrm>
-            <a:off x="10775950" y="1866899"/>
-            <a:ext cx="952500" cy="457200"/>
-          </a:xfrm>
-          <a:prstGeom prst="roundRect">
-            <a:avLst>
-              <a:gd name="adj" fmla="val 50000"/>
-            </a:avLst>
-          </a:prstGeom>
-          <a:solidFill>
-            <a:srgbClr val="FBF7F1"/>
-          </a:solidFill>
-          <a:ln w="12700">
-            <a:solidFill>
-              <a:srgbClr val="C98A5E"/>
-            </a:solidFill>
-          </a:ln>
-          <a:effectLst/>
-        </p:spPr>
-        <p:style>
-          <a:lnRef idx="1">
-            <a:schemeClr val="accent1"/>
-          </a:lnRef>
-          <a:fillRef idx="3">
-            <a:schemeClr val="accent1"/>
-          </a:fillRef>
-          <a:effectRef idx="2">
-            <a:schemeClr val="accent1"/>
-          </a:effectRef>
-          <a:fontRef idx="minor">
-            <a:schemeClr val="lt1"/>
-          </a:fontRef>
-        </p:style>
-        <p:txBody>
-          <a:bodyPr rtlCol="0" anchor="ctr"/>
-          <a:lstStyle/>
-          <a:p>
-            <a:pPr algn="ctr"/>
-          </a:p>
-        </p:txBody>
-      </p:sp>
-      <p:sp>
-        <p:nvSpPr>
-          <p:cNvPr id="50" name="TextBox 49"/>
-          <p:cNvSpPr txBox="1"/>
-          <p:nvPr/>
-        </p:nvSpPr>
-        <p:spPr>
-          <a:xfrm>
-            <a:off x="10839450" y="1866899"/>
-            <a:ext cx="825500" cy="457200"/>
-          </a:xfrm>
-          <a:prstGeom prst="rect">
-            <a:avLst/>
-          </a:prstGeom>
-          <a:noFill/>
-        </p:spPr>
-        <p:txBody>
-          <a:bodyPr wrap="square" anchor="ctr" lIns="25400" rIns="25400" tIns="12700" bIns="12700">
-            <a:normAutofit/>
-          </a:bodyPr>
-          <a:lstStyle/>
-          <a:p>
-            <a:pPr algn="ctr">
-              <a:spcAft>
-                <a:spcPts val="0"/>
-              </a:spcAft>
-            </a:pPr>
-            <a:r>
-              <a:rPr sz="625" b="1">
-                <a:solidFill>
-                  <a:srgbClr val="142433"/>
-                </a:solidFill>
-                <a:latin typeface="Inter"/>
-              </a:rPr>
-              <a:t>Ongoing care</a:t>
-            </a:r>
-          </a:p>
-        </p:txBody>
-      </p:sp>
       <p:cxnSp>
         <p:nvCxnSpPr>
           <p:cNvPr id="51" name="Connector 50"/>
@@ -11722,9 +12552,9 @@
           <p:nvPr/>
         </p:nvCxnSpPr>
         <p:spPr>
-          <a:xfrm>
-            <a:off x="1905000" y="2324100"/>
-            <a:ext cx="0" cy="2038350"/>
+          <a:xfrm flipH="1">
+            <a:off x="1943100" y="2336800"/>
+            <a:ext cx="12700" cy="2025650"/>
           </a:xfrm>
           <a:prstGeom prst="bentConnector3">
             <a:avLst/>
@@ -11760,8 +12590,8 @@
         </p:nvCxnSpPr>
         <p:spPr>
           <a:xfrm flipV="1">
-            <a:off x="1905000" y="2317750"/>
-            <a:ext cx="965200" cy="2044700"/>
+            <a:off x="1943100" y="2317750"/>
+            <a:ext cx="1104900" cy="2044700"/>
           </a:xfrm>
           <a:prstGeom prst="bentConnector3">
             <a:avLst/>
@@ -11797,8 +12627,8 @@
         </p:nvCxnSpPr>
         <p:spPr>
           <a:xfrm>
-            <a:off x="2870200" y="2317750"/>
-            <a:ext cx="965200" cy="2044700"/>
+            <a:off x="3048000" y="2317750"/>
+            <a:ext cx="222250" cy="2044700"/>
           </a:xfrm>
           <a:prstGeom prst="bentConnector3">
             <a:avLst/>
@@ -11834,8 +12664,8 @@
         </p:nvCxnSpPr>
         <p:spPr>
           <a:xfrm flipV="1">
-            <a:off x="3835400" y="3562350"/>
-            <a:ext cx="965200" cy="800100"/>
+            <a:off x="3270250" y="3562350"/>
+            <a:ext cx="850900" cy="800100"/>
           </a:xfrm>
           <a:prstGeom prst="bentConnector3">
             <a:avLst/>
@@ -11872,7 +12702,7 @@
         <p:spPr>
           <a:xfrm flipV="1">
             <a:off x="4800600" y="3562350"/>
-            <a:ext cx="965200" cy="2044700"/>
+            <a:ext cx="533400" cy="2044700"/>
           </a:xfrm>
           <a:prstGeom prst="bentConnector3">
             <a:avLst/>
@@ -11907,9 +12737,9 @@
           <p:nvPr/>
         </p:nvCxnSpPr>
         <p:spPr>
-          <a:xfrm flipH="1">
-            <a:off x="5257800" y="3340100"/>
-            <a:ext cx="50800" cy="0"/>
+          <a:xfrm>
+            <a:off x="4629150" y="3340100"/>
+            <a:ext cx="196850" cy="0"/>
           </a:xfrm>
           <a:prstGeom prst="bentConnector3">
             <a:avLst/>
@@ -11944,9 +12774,9 @@
           <p:nvPr/>
         </p:nvCxnSpPr>
         <p:spPr>
-          <a:xfrm flipH="1">
-            <a:off x="6184900" y="3340100"/>
-            <a:ext cx="88900" cy="0"/>
+          <a:xfrm>
+            <a:off x="5842000" y="3340100"/>
+            <a:ext cx="196850" cy="0"/>
           </a:xfrm>
           <a:prstGeom prst="bentConnector3">
             <a:avLst/>
@@ -11982,8 +12812,8 @@
         </p:nvCxnSpPr>
         <p:spPr>
           <a:xfrm>
-            <a:off x="6731000" y="3670300"/>
-            <a:ext cx="965199" cy="692150"/>
+            <a:off x="6584950" y="3670300"/>
+            <a:ext cx="1111249" cy="692150"/>
           </a:xfrm>
           <a:prstGeom prst="bentConnector3">
             <a:avLst/>
@@ -12019,7 +12849,7 @@
         </p:nvSpPr>
         <p:spPr>
           <a:xfrm>
-            <a:off x="7023100" y="3876674"/>
+            <a:off x="6950075" y="3876674"/>
             <a:ext cx="381000" cy="139700"/>
           </a:xfrm>
           <a:prstGeom prst="rect">
@@ -12053,9 +12883,9 @@
           <p:nvPr/>
         </p:nvCxnSpPr>
         <p:spPr>
-          <a:xfrm flipH="1">
-            <a:off x="7188200" y="3340100"/>
-            <a:ext cx="88900" cy="0"/>
+          <a:xfrm>
+            <a:off x="7131050" y="3340100"/>
+            <a:ext cx="323850" cy="0"/>
           </a:xfrm>
           <a:prstGeom prst="bentConnector3">
             <a:avLst/>
@@ -12091,7 +12921,7 @@
         </p:nvSpPr>
         <p:spPr>
           <a:xfrm>
-            <a:off x="7042150" y="3200400"/>
+            <a:off x="7102475" y="3200400"/>
             <a:ext cx="381000" cy="139700"/>
           </a:xfrm>
           <a:prstGeom prst="rect">
@@ -12126,8 +12956,8 @@
         </p:nvCxnSpPr>
         <p:spPr>
           <a:xfrm flipV="1">
-            <a:off x="7696199" y="3562350"/>
-            <a:ext cx="965201" cy="800100"/>
+            <a:off x="8204199" y="3340100"/>
+            <a:ext cx="736601" cy="1244600"/>
           </a:xfrm>
           <a:prstGeom prst="bentConnector3">
             <a:avLst/>
@@ -12163,8 +12993,8 @@
         </p:nvCxnSpPr>
         <p:spPr>
           <a:xfrm>
-            <a:off x="8661400" y="3562350"/>
-            <a:ext cx="965200" cy="800100"/>
+            <a:off x="9448800" y="3562350"/>
+            <a:ext cx="177800" cy="800100"/>
           </a:xfrm>
           <a:prstGeom prst="bentConnector3">
             <a:avLst/>
@@ -12200,8 +13030,8 @@
         </p:nvCxnSpPr>
         <p:spPr>
           <a:xfrm>
-            <a:off x="8204199" y="3340100"/>
-            <a:ext cx="914401" cy="1244600"/>
+            <a:off x="8470900" y="3340100"/>
+            <a:ext cx="647700" cy="1244600"/>
           </a:xfrm>
           <a:prstGeom prst="bentConnector3">
             <a:avLst/>
@@ -12312,7 +13142,7 @@
         <p:spPr>
           <a:xfrm>
             <a:off x="10591800" y="3562350"/>
-            <a:ext cx="0" cy="800100"/>
+            <a:ext cx="279400" cy="800100"/>
           </a:xfrm>
           <a:prstGeom prst="bentConnector3">
             <a:avLst/>
@@ -12385,8 +13215,8 @@
         </p:nvCxnSpPr>
         <p:spPr>
           <a:xfrm>
-            <a:off x="10591800" y="4806950"/>
-            <a:ext cx="0" cy="800100"/>
+            <a:off x="10871200" y="4806950"/>
+            <a:ext cx="0" cy="806450"/>
           </a:xfrm>
           <a:prstGeom prst="bentConnector3">
             <a:avLst/>
@@ -12431,7 +13261,7 @@
           <a:noFill/>
         </p:spPr>
         <p:txBody>
-          <a:bodyPr wrap="square" anchor="t" lIns="25400" rIns="25400" tIns="12700" bIns="12700">
+          <a:bodyPr wrap="square" anchor="t" lIns="25400" rIns="25400" tIns="25400" bIns="25400">
             <a:spAutoFit/>
           </a:bodyPr>
           <a:lstStyle/>
@@ -12470,7 +13300,7 @@
           <a:noFill/>
         </p:spPr>
         <p:txBody>
-          <a:bodyPr wrap="square" anchor="t" lIns="25400" rIns="25400" tIns="12700" bIns="12700">
+          <a:bodyPr wrap="square" anchor="t" lIns="25400" rIns="25400" tIns="25400" bIns="25400">
             <a:spAutoFit/>
           </a:bodyPr>
           <a:lstStyle/>
@@ -12509,7 +13339,7 @@
           <a:noFill/>
         </p:spPr>
         <p:txBody>
-          <a:bodyPr wrap="square" anchor="t" lIns="25400" rIns="25400" tIns="12700" bIns="12700">
+          <a:bodyPr wrap="square" anchor="t" lIns="25400" rIns="25400" tIns="25400" bIns="25400">
             <a:spAutoFit/>
           </a:bodyPr>
           <a:lstStyle/>

</xml_diff>

<commit_message>
design: correlate sentiment to phases on slide 2
Ties each sentiment point to its phase by column: vertical guide lines from
each phase card to its node, node + mood label + pain dot colour-matched to the
phase colour, and a 'how each phase feels' label. Makes the phase-sentiment
mapping intuitive instead of two disconnected rows.

https://claude.ai/code/session_015v7JWiWTXQN2Qco9pisXZ1
</commit_message>
<xml_diff>
--- a/docs/design/Sona_Care_Journey_Deck.pptx
+++ b/docs/design/Sona_Care_Journey_Deck.pptx
@@ -4857,7 +4857,7 @@
         <p:spPr>
           <a:xfrm>
             <a:off x="571500" y="2286000"/>
-            <a:ext cx="5715000" cy="152400"/>
+            <a:ext cx="7620000" cy="152400"/>
           </a:xfrm>
           <a:prstGeom prst="rect">
             <a:avLst/>
@@ -4882,21 +4882,201 @@
                 </a:solidFill>
                 <a:latin typeface="Inter"/>
               </a:rPr>
-              <a:t>SENTIMENT · FAMILY + CLINICIAN</a:t>
-            </a:r>
-          </a:p>
-        </p:txBody>
-      </p:sp>
-      <p:sp>
-        <p:nvSpPr>
-          <p:cNvPr id="18" name="Freeform 17"/>
+              <a:t>HOW EACH PHASE FEELS  ·  one point per phase, family + clinician</a:t>
+            </a:r>
+          </a:p>
+        </p:txBody>
+      </p:sp>
+      <p:cxnSp>
+        <p:nvCxnSpPr>
+          <p:cNvPr id="18" name="Connector 17"/>
+          <p:cNvCxnSpPr/>
+          <p:nvPr/>
+        </p:nvCxnSpPr>
+        <p:spPr>
+          <a:xfrm>
+            <a:off x="1620520" y="2095499"/>
+            <a:ext cx="0" cy="1038607"/>
+          </a:xfrm>
+          <a:prstGeom prst="line">
+            <a:avLst/>
+          </a:prstGeom>
+          <a:ln w="9525">
+            <a:solidFill>
+              <a:srgbClr val="D7DDE0"/>
+            </a:solidFill>
+          </a:ln>
+          <a:effectLst/>
+        </p:spPr>
+        <p:style>
+          <a:lnRef idx="2">
+            <a:schemeClr val="accent1"/>
+          </a:lnRef>
+          <a:fillRef idx="0">
+            <a:schemeClr val="accent1"/>
+          </a:fillRef>
+          <a:effectRef idx="1">
+            <a:schemeClr val="accent1"/>
+          </a:effectRef>
+          <a:fontRef idx="minor">
+            <a:schemeClr val="tx1"/>
+          </a:fontRef>
+        </p:style>
+      </p:cxnSp>
+      <p:cxnSp>
+        <p:nvCxnSpPr>
+          <p:cNvPr id="19" name="Connector 18"/>
+          <p:cNvCxnSpPr/>
+          <p:nvPr/>
+        </p:nvCxnSpPr>
+        <p:spPr>
+          <a:xfrm>
+            <a:off x="3858259" y="2095499"/>
+            <a:ext cx="0" cy="1120903"/>
+          </a:xfrm>
+          <a:prstGeom prst="line">
+            <a:avLst/>
+          </a:prstGeom>
+          <a:ln w="9525">
+            <a:solidFill>
+              <a:srgbClr val="D7DDE0"/>
+            </a:solidFill>
+          </a:ln>
+          <a:effectLst/>
+        </p:spPr>
+        <p:style>
+          <a:lnRef idx="2">
+            <a:schemeClr val="accent1"/>
+          </a:lnRef>
+          <a:fillRef idx="0">
+            <a:schemeClr val="accent1"/>
+          </a:fillRef>
+          <a:effectRef idx="1">
+            <a:schemeClr val="accent1"/>
+          </a:effectRef>
+          <a:fontRef idx="minor">
+            <a:schemeClr val="tx1"/>
+          </a:fontRef>
+        </p:style>
+      </p:cxnSp>
+      <p:cxnSp>
+        <p:nvCxnSpPr>
+          <p:cNvPr id="20" name="Connector 19"/>
+          <p:cNvCxnSpPr/>
+          <p:nvPr/>
+        </p:nvCxnSpPr>
+        <p:spPr>
+          <a:xfrm>
+            <a:off x="6096000" y="2095499"/>
+            <a:ext cx="0" cy="819151"/>
+          </a:xfrm>
+          <a:prstGeom prst="line">
+            <a:avLst/>
+          </a:prstGeom>
+          <a:ln w="9525">
+            <a:solidFill>
+              <a:srgbClr val="D7DDE0"/>
+            </a:solidFill>
+          </a:ln>
+          <a:effectLst/>
+        </p:spPr>
+        <p:style>
+          <a:lnRef idx="2">
+            <a:schemeClr val="accent1"/>
+          </a:lnRef>
+          <a:fillRef idx="0">
+            <a:schemeClr val="accent1"/>
+          </a:fillRef>
+          <a:effectRef idx="1">
+            <a:schemeClr val="accent1"/>
+          </a:effectRef>
+          <a:fontRef idx="minor">
+            <a:schemeClr val="tx1"/>
+          </a:fontRef>
+        </p:style>
+      </p:cxnSp>
+      <p:cxnSp>
+        <p:nvCxnSpPr>
+          <p:cNvPr id="21" name="Connector 20"/>
+          <p:cNvCxnSpPr/>
+          <p:nvPr/>
+        </p:nvCxnSpPr>
+        <p:spPr>
+          <a:xfrm>
+            <a:off x="8333739" y="2095499"/>
+            <a:ext cx="0" cy="627127"/>
+          </a:xfrm>
+          <a:prstGeom prst="line">
+            <a:avLst/>
+          </a:prstGeom>
+          <a:ln w="9525">
+            <a:solidFill>
+              <a:srgbClr val="D7DDE0"/>
+            </a:solidFill>
+          </a:ln>
+          <a:effectLst/>
+        </p:spPr>
+        <p:style>
+          <a:lnRef idx="2">
+            <a:schemeClr val="accent1"/>
+          </a:lnRef>
+          <a:fillRef idx="0">
+            <a:schemeClr val="accent1"/>
+          </a:fillRef>
+          <a:effectRef idx="1">
+            <a:schemeClr val="accent1"/>
+          </a:effectRef>
+          <a:fontRef idx="minor">
+            <a:schemeClr val="tx1"/>
+          </a:fontRef>
+        </p:style>
+      </p:cxnSp>
+      <p:cxnSp>
+        <p:nvCxnSpPr>
+          <p:cNvPr id="22" name="Connector 21"/>
+          <p:cNvCxnSpPr/>
+          <p:nvPr/>
+        </p:nvCxnSpPr>
+        <p:spPr>
+          <a:xfrm>
+            <a:off x="10571479" y="2095499"/>
+            <a:ext cx="0" cy="503683"/>
+          </a:xfrm>
+          <a:prstGeom prst="line">
+            <a:avLst/>
+          </a:prstGeom>
+          <a:ln w="9525">
+            <a:solidFill>
+              <a:srgbClr val="D7DDE0"/>
+            </a:solidFill>
+          </a:ln>
+          <a:effectLst/>
+        </p:spPr>
+        <p:style>
+          <a:lnRef idx="2">
+            <a:schemeClr val="accent1"/>
+          </a:lnRef>
+          <a:fillRef idx="0">
+            <a:schemeClr val="accent1"/>
+          </a:fillRef>
+          <a:effectRef idx="1">
+            <a:schemeClr val="accent1"/>
+          </a:effectRef>
+          <a:fontRef idx="minor">
+            <a:schemeClr val="tx1"/>
+          </a:fontRef>
+        </p:style>
+      </p:cxnSp>
+      <p:sp>
+        <p:nvSpPr>
+          <p:cNvPr id="23" name="Freeform 22"/>
           <p:cNvSpPr/>
           <p:nvPr/>
         </p:nvSpPr>
         <p:spPr>
           <a:xfrm>
-            <a:off x="1620520" y="2631440"/>
-            <a:ext cx="8950959" cy="797560"/>
+            <a:off x="1620520" y="2656332"/>
+            <a:ext cx="8950959" cy="772668"/>
           </a:xfrm>
           <a:custGeom>
             <a:avLst/>
@@ -4905,27 +5085,27 @@
             <a:cxnLst/>
             <a:rect l="l" t="t" r="r" b="b"/>
             <a:pathLst>
-              <a:path w="8950959" h="797560">
+              <a:path w="8950959" h="772668">
                 <a:moveTo>
-                  <a:pt x="0" y="797560"/>
+                  <a:pt x="0" y="772668"/>
                 </a:moveTo>
                 <a:lnTo>
-                  <a:pt x="0" y="544830"/>
+                  <a:pt x="0" y="534924"/>
                 </a:lnTo>
                 <a:lnTo>
-                  <a:pt x="2237739" y="628650"/>
+                  <a:pt x="2237739" y="617220"/>
                 </a:lnTo>
                 <a:lnTo>
-                  <a:pt x="4475480" y="321310"/>
+                  <a:pt x="4475480" y="315468"/>
                 </a:lnTo>
                 <a:lnTo>
-                  <a:pt x="6713219" y="125729"/>
+                  <a:pt x="6713219" y="123444"/>
                 </a:lnTo>
                 <a:lnTo>
                   <a:pt x="8950959" y="0"/>
                 </a:lnTo>
                 <a:lnTo>
-                  <a:pt x="8950959" y="797560"/>
+                  <a:pt x="8950959" y="772668"/>
                 </a:lnTo>
                 <a:close/>
               </a:path>
@@ -4963,7 +5143,7 @@
       </p:sp>
       <p:cxnSp>
         <p:nvCxnSpPr>
-          <p:cNvPr id="19" name="Connector 18"/>
+          <p:cNvPr id="24" name="Connector 23"/>
           <p:cNvCxnSpPr/>
           <p:nvPr/>
         </p:nvCxnSpPr>
@@ -4999,14 +5179,14 @@
       </p:cxnSp>
       <p:cxnSp>
         <p:nvCxnSpPr>
-          <p:cNvPr id="20" name="Connector 19"/>
+          <p:cNvPr id="25" name="Connector 24"/>
           <p:cNvCxnSpPr/>
           <p:nvPr/>
         </p:nvCxnSpPr>
         <p:spPr>
           <a:xfrm>
-            <a:off x="1620520" y="3176270"/>
-            <a:ext cx="2237739" cy="83820"/>
+            <a:off x="1620520" y="3191256"/>
+            <a:ext cx="2237739" cy="82296"/>
           </a:xfrm>
           <a:prstGeom prst="line">
             <a:avLst/>
@@ -5035,14 +5215,14 @@
       </p:cxnSp>
       <p:cxnSp>
         <p:nvCxnSpPr>
-          <p:cNvPr id="21" name="Connector 20"/>
+          <p:cNvPr id="26" name="Connector 25"/>
           <p:cNvCxnSpPr/>
           <p:nvPr/>
         </p:nvCxnSpPr>
         <p:spPr>
           <a:xfrm flipV="1">
-            <a:off x="3858259" y="2952750"/>
-            <a:ext cx="2237741" cy="307340"/>
+            <a:off x="3858259" y="2971800"/>
+            <a:ext cx="2237741" cy="301752"/>
           </a:xfrm>
           <a:prstGeom prst="line">
             <a:avLst/>
@@ -5071,14 +5251,14 @@
       </p:cxnSp>
       <p:cxnSp>
         <p:nvCxnSpPr>
-          <p:cNvPr id="22" name="Connector 21"/>
+          <p:cNvPr id="27" name="Connector 26"/>
           <p:cNvCxnSpPr/>
           <p:nvPr/>
         </p:nvCxnSpPr>
         <p:spPr>
           <a:xfrm flipV="1">
-            <a:off x="6096000" y="2757169"/>
-            <a:ext cx="2237739" cy="195581"/>
+            <a:off x="6096000" y="2779776"/>
+            <a:ext cx="2237739" cy="192024"/>
           </a:xfrm>
           <a:prstGeom prst="line">
             <a:avLst/>
@@ -5107,14 +5287,14 @@
       </p:cxnSp>
       <p:cxnSp>
         <p:nvCxnSpPr>
-          <p:cNvPr id="23" name="Connector 22"/>
+          <p:cNvPr id="28" name="Connector 27"/>
           <p:cNvCxnSpPr/>
           <p:nvPr/>
         </p:nvCxnSpPr>
         <p:spPr>
           <a:xfrm flipV="1">
-            <a:off x="8333739" y="2631440"/>
-            <a:ext cx="2237740" cy="125729"/>
+            <a:off x="8333739" y="2656332"/>
+            <a:ext cx="2237740" cy="123444"/>
           </a:xfrm>
           <a:prstGeom prst="line">
             <a:avLst/>
@@ -5143,14 +5323,14 @@
       </p:cxnSp>
       <p:sp>
         <p:nvSpPr>
-          <p:cNvPr id="24" name="Oval 23"/>
+          <p:cNvPr id="29" name="Oval 28"/>
           <p:cNvSpPr/>
           <p:nvPr/>
         </p:nvSpPr>
         <p:spPr>
           <a:xfrm>
-            <a:off x="1557020" y="3112770"/>
-            <a:ext cx="127000" cy="127000"/>
+            <a:off x="1550670" y="3121406"/>
+            <a:ext cx="139700" cy="139700"/>
           </a:xfrm>
           <a:prstGeom prst="ellipse">
             <a:avLst/>
@@ -5189,7 +5369,7 @@
       </p:sp>
       <p:sp>
         <p:nvSpPr>
-          <p:cNvPr id="25" name="TextBox 24"/>
+          <p:cNvPr id="30" name="TextBox 29"/>
           <p:cNvSpPr txBox="1"/>
           <p:nvPr/>
         </p:nvSpPr>
@@ -5228,7 +5408,7 @@
       </p:sp>
       <p:sp>
         <p:nvSpPr>
-          <p:cNvPr id="26" name="TextBox 25"/>
+          <p:cNvPr id="31" name="TextBox 30"/>
           <p:cNvSpPr txBox="1"/>
           <p:nvPr/>
         </p:nvSpPr>
@@ -5267,20 +5447,20 @@
       </p:sp>
       <p:sp>
         <p:nvSpPr>
-          <p:cNvPr id="27" name="Oval 26"/>
+          <p:cNvPr id="32" name="Oval 31"/>
           <p:cNvSpPr/>
           <p:nvPr/>
         </p:nvSpPr>
         <p:spPr>
           <a:xfrm>
-            <a:off x="3794759" y="3196590"/>
-            <a:ext cx="127000" cy="127000"/>
+            <a:off x="3788409" y="3203701"/>
+            <a:ext cx="139700" cy="139700"/>
           </a:xfrm>
           <a:prstGeom prst="ellipse">
             <a:avLst/>
           </a:prstGeom>
           <a:solidFill>
-            <a:srgbClr val="2D6A6E"/>
+            <a:srgbClr val="356985"/>
           </a:solidFill>
           <a:ln w="19050">
             <a:solidFill>
@@ -5313,7 +5493,7 @@
       </p:sp>
       <p:sp>
         <p:nvSpPr>
-          <p:cNvPr id="28" name="TextBox 27"/>
+          <p:cNvPr id="33" name="TextBox 32"/>
           <p:cNvSpPr txBox="1"/>
           <p:nvPr/>
         </p:nvSpPr>
@@ -5341,7 +5521,7 @@
             <a:r>
               <a:rPr sz="850" b="1">
                 <a:solidFill>
-                  <a:srgbClr val="2D6A6E"/>
+                  <a:srgbClr val="356985"/>
                 </a:solidFill>
                 <a:latin typeface="Inter"/>
               </a:rPr>
@@ -5352,7 +5532,7 @@
       </p:sp>
       <p:sp>
         <p:nvSpPr>
-          <p:cNvPr id="29" name="TextBox 28"/>
+          <p:cNvPr id="34" name="TextBox 33"/>
           <p:cNvSpPr txBox="1"/>
           <p:nvPr/>
         </p:nvSpPr>
@@ -5391,20 +5571,20 @@
       </p:sp>
       <p:sp>
         <p:nvSpPr>
-          <p:cNvPr id="30" name="Oval 29"/>
+          <p:cNvPr id="35" name="Oval 34"/>
           <p:cNvSpPr/>
           <p:nvPr/>
         </p:nvSpPr>
         <p:spPr>
           <a:xfrm>
-            <a:off x="6032500" y="2889250"/>
-            <a:ext cx="127000" cy="127000"/>
+            <a:off x="6026150" y="2901950"/>
+            <a:ext cx="139700" cy="139700"/>
           </a:xfrm>
           <a:prstGeom prst="ellipse">
             <a:avLst/>
           </a:prstGeom>
           <a:solidFill>
-            <a:srgbClr val="2D6A6E"/>
+            <a:srgbClr val="C0703F"/>
           </a:solidFill>
           <a:ln w="19050">
             <a:solidFill>
@@ -5437,7 +5617,7 @@
       </p:sp>
       <p:sp>
         <p:nvSpPr>
-          <p:cNvPr id="31" name="TextBox 30"/>
+          <p:cNvPr id="36" name="TextBox 35"/>
           <p:cNvSpPr txBox="1"/>
           <p:nvPr/>
         </p:nvSpPr>
@@ -5465,7 +5645,7 @@
             <a:r>
               <a:rPr sz="850" b="1">
                 <a:solidFill>
-                  <a:srgbClr val="2D6A6E"/>
+                  <a:srgbClr val="C0703F"/>
                 </a:solidFill>
                 <a:latin typeface="Inter"/>
               </a:rPr>
@@ -5476,7 +5656,7 @@
       </p:sp>
       <p:sp>
         <p:nvSpPr>
-          <p:cNvPr id="32" name="TextBox 31"/>
+          <p:cNvPr id="37" name="TextBox 36"/>
           <p:cNvSpPr txBox="1"/>
           <p:nvPr/>
         </p:nvSpPr>
@@ -5515,20 +5695,20 @@
       </p:sp>
       <p:sp>
         <p:nvSpPr>
-          <p:cNvPr id="33" name="Oval 32"/>
+          <p:cNvPr id="38" name="Oval 37"/>
           <p:cNvSpPr/>
           <p:nvPr/>
         </p:nvSpPr>
         <p:spPr>
           <a:xfrm>
-            <a:off x="8270240" y="2693670"/>
-            <a:ext cx="127000" cy="127000"/>
+            <a:off x="8263890" y="2709926"/>
+            <a:ext cx="139700" cy="139700"/>
           </a:xfrm>
           <a:prstGeom prst="ellipse">
             <a:avLst/>
           </a:prstGeom>
           <a:solidFill>
-            <a:srgbClr val="2D6A6E"/>
+            <a:srgbClr val="6E5A86"/>
           </a:solidFill>
           <a:ln w="19050">
             <a:solidFill>
@@ -5561,7 +5741,7 @@
       </p:sp>
       <p:sp>
         <p:nvSpPr>
-          <p:cNvPr id="34" name="TextBox 33"/>
+          <p:cNvPr id="39" name="TextBox 38"/>
           <p:cNvSpPr txBox="1"/>
           <p:nvPr/>
         </p:nvSpPr>
@@ -5589,7 +5769,7 @@
             <a:r>
               <a:rPr sz="850" b="1">
                 <a:solidFill>
-                  <a:srgbClr val="2D6A6E"/>
+                  <a:srgbClr val="6E5A86"/>
                 </a:solidFill>
                 <a:latin typeface="Inter"/>
               </a:rPr>
@@ -5600,7 +5780,7 @@
       </p:sp>
       <p:sp>
         <p:nvSpPr>
-          <p:cNvPr id="35" name="TextBox 34"/>
+          <p:cNvPr id="40" name="TextBox 39"/>
           <p:cNvSpPr txBox="1"/>
           <p:nvPr/>
         </p:nvSpPr>
@@ -5639,20 +5819,20 @@
       </p:sp>
       <p:sp>
         <p:nvSpPr>
-          <p:cNvPr id="36" name="Oval 35"/>
+          <p:cNvPr id="41" name="Oval 40"/>
           <p:cNvSpPr/>
           <p:nvPr/>
         </p:nvSpPr>
         <p:spPr>
           <a:xfrm>
-            <a:off x="10507980" y="2567940"/>
-            <a:ext cx="127000" cy="127000"/>
+            <a:off x="10501630" y="2586482"/>
+            <a:ext cx="139700" cy="139700"/>
           </a:xfrm>
           <a:prstGeom prst="ellipse">
             <a:avLst/>
           </a:prstGeom>
           <a:solidFill>
-            <a:srgbClr val="2D6A6E"/>
+            <a:srgbClr val="4C8060"/>
           </a:solidFill>
           <a:ln w="19050">
             <a:solidFill>
@@ -5685,7 +5865,7 @@
       </p:sp>
       <p:sp>
         <p:nvSpPr>
-          <p:cNvPr id="37" name="TextBox 36"/>
+          <p:cNvPr id="42" name="TextBox 41"/>
           <p:cNvSpPr txBox="1"/>
           <p:nvPr/>
         </p:nvSpPr>
@@ -5713,7 +5893,7 @@
             <a:r>
               <a:rPr sz="850" b="1">
                 <a:solidFill>
-                  <a:srgbClr val="2D6A6E"/>
+                  <a:srgbClr val="4C8060"/>
                 </a:solidFill>
                 <a:latin typeface="Inter"/>
               </a:rPr>
@@ -5724,7 +5904,7 @@
       </p:sp>
       <p:sp>
         <p:nvSpPr>
-          <p:cNvPr id="38" name="TextBox 37"/>
+          <p:cNvPr id="43" name="TextBox 42"/>
           <p:cNvSpPr txBox="1"/>
           <p:nvPr/>
         </p:nvSpPr>
@@ -5763,7 +5943,7 @@
       </p:sp>
       <p:sp>
         <p:nvSpPr>
-          <p:cNvPr id="39" name="TextBox 38"/>
+          <p:cNvPr id="44" name="TextBox 43"/>
           <p:cNvSpPr txBox="1"/>
           <p:nvPr/>
         </p:nvSpPr>
@@ -5802,7 +5982,7 @@
       </p:sp>
       <p:sp>
         <p:nvSpPr>
-          <p:cNvPr id="40" name="Rounded Rectangle 39"/>
+          <p:cNvPr id="45" name="Rounded Rectangle 44"/>
           <p:cNvSpPr/>
           <p:nvPr/>
         </p:nvSpPr>
@@ -5850,7 +6030,7 @@
       </p:sp>
       <p:sp>
         <p:nvSpPr>
-          <p:cNvPr id="41" name="Oval 40"/>
+          <p:cNvPr id="46" name="Oval 45"/>
           <p:cNvSpPr/>
           <p:nvPr/>
         </p:nvSpPr>
@@ -5863,7 +6043,7 @@
             <a:avLst/>
           </a:prstGeom>
           <a:solidFill>
-            <a:srgbClr val="F2A878"/>
+            <a:srgbClr val="2D6A6E"/>
           </a:solidFill>
           <a:ln>
             <a:noFill/>
@@ -5894,7 +6074,7 @@
       </p:sp>
       <p:sp>
         <p:nvSpPr>
-          <p:cNvPr id="42" name="TextBox 41"/>
+          <p:cNvPr id="47" name="TextBox 46"/>
           <p:cNvSpPr txBox="1"/>
           <p:nvPr/>
         </p:nvSpPr>
@@ -5933,7 +6113,7 @@
       </p:sp>
       <p:sp>
         <p:nvSpPr>
-          <p:cNvPr id="43" name="Rounded Rectangle 42"/>
+          <p:cNvPr id="48" name="Rounded Rectangle 47"/>
           <p:cNvSpPr/>
           <p:nvPr/>
         </p:nvSpPr>
@@ -5981,7 +6161,7 @@
       </p:sp>
       <p:sp>
         <p:nvSpPr>
-          <p:cNvPr id="44" name="Oval 43"/>
+          <p:cNvPr id="49" name="Oval 48"/>
           <p:cNvSpPr/>
           <p:nvPr/>
         </p:nvSpPr>
@@ -5994,7 +6174,7 @@
             <a:avLst/>
           </a:prstGeom>
           <a:solidFill>
-            <a:srgbClr val="F2A878"/>
+            <a:srgbClr val="356985"/>
           </a:solidFill>
           <a:ln>
             <a:noFill/>
@@ -6025,7 +6205,7 @@
       </p:sp>
       <p:sp>
         <p:nvSpPr>
-          <p:cNvPr id="45" name="TextBox 44"/>
+          <p:cNvPr id="50" name="TextBox 49"/>
           <p:cNvSpPr txBox="1"/>
           <p:nvPr/>
         </p:nvSpPr>
@@ -6064,7 +6244,7 @@
       </p:sp>
       <p:sp>
         <p:nvSpPr>
-          <p:cNvPr id="46" name="Rounded Rectangle 45"/>
+          <p:cNvPr id="51" name="Rounded Rectangle 50"/>
           <p:cNvSpPr/>
           <p:nvPr/>
         </p:nvSpPr>
@@ -6112,7 +6292,7 @@
       </p:sp>
       <p:sp>
         <p:nvSpPr>
-          <p:cNvPr id="47" name="Oval 46"/>
+          <p:cNvPr id="52" name="Oval 51"/>
           <p:cNvSpPr/>
           <p:nvPr/>
         </p:nvSpPr>
@@ -6125,7 +6305,7 @@
             <a:avLst/>
           </a:prstGeom>
           <a:solidFill>
-            <a:srgbClr val="F2A878"/>
+            <a:srgbClr val="C0703F"/>
           </a:solidFill>
           <a:ln>
             <a:noFill/>
@@ -6156,7 +6336,7 @@
       </p:sp>
       <p:sp>
         <p:nvSpPr>
-          <p:cNvPr id="48" name="TextBox 47"/>
+          <p:cNvPr id="53" name="TextBox 52"/>
           <p:cNvSpPr txBox="1"/>
           <p:nvPr/>
         </p:nvSpPr>
@@ -6195,7 +6375,7 @@
       </p:sp>
       <p:sp>
         <p:nvSpPr>
-          <p:cNvPr id="49" name="Rounded Rectangle 48"/>
+          <p:cNvPr id="54" name="Rounded Rectangle 53"/>
           <p:cNvSpPr/>
           <p:nvPr/>
         </p:nvSpPr>
@@ -6243,7 +6423,7 @@
       </p:sp>
       <p:sp>
         <p:nvSpPr>
-          <p:cNvPr id="50" name="Oval 49"/>
+          <p:cNvPr id="55" name="Oval 54"/>
           <p:cNvSpPr/>
           <p:nvPr/>
         </p:nvSpPr>
@@ -6256,7 +6436,7 @@
             <a:avLst/>
           </a:prstGeom>
           <a:solidFill>
-            <a:srgbClr val="F2A878"/>
+            <a:srgbClr val="6E5A86"/>
           </a:solidFill>
           <a:ln>
             <a:noFill/>
@@ -6287,7 +6467,7 @@
       </p:sp>
       <p:sp>
         <p:nvSpPr>
-          <p:cNvPr id="51" name="TextBox 50"/>
+          <p:cNvPr id="56" name="TextBox 55"/>
           <p:cNvSpPr txBox="1"/>
           <p:nvPr/>
         </p:nvSpPr>
@@ -6326,7 +6506,7 @@
       </p:sp>
       <p:sp>
         <p:nvSpPr>
-          <p:cNvPr id="52" name="Rounded Rectangle 51"/>
+          <p:cNvPr id="57" name="Rounded Rectangle 56"/>
           <p:cNvSpPr/>
           <p:nvPr/>
         </p:nvSpPr>
@@ -6374,7 +6554,7 @@
       </p:sp>
       <p:sp>
         <p:nvSpPr>
-          <p:cNvPr id="53" name="Oval 52"/>
+          <p:cNvPr id="58" name="Oval 57"/>
           <p:cNvSpPr/>
           <p:nvPr/>
         </p:nvSpPr>
@@ -6385,6 +6565,130 @@
           </a:xfrm>
           <a:prstGeom prst="ellipse">
             <a:avLst/>
+          </a:prstGeom>
+          <a:solidFill>
+            <a:srgbClr val="4C8060"/>
+          </a:solidFill>
+          <a:ln>
+            <a:noFill/>
+          </a:ln>
+          <a:effectLst/>
+        </p:spPr>
+        <p:style>
+          <a:lnRef idx="1">
+            <a:schemeClr val="accent1"/>
+          </a:lnRef>
+          <a:fillRef idx="3">
+            <a:schemeClr val="accent1"/>
+          </a:fillRef>
+          <a:effectRef idx="2">
+            <a:schemeClr val="accent1"/>
+          </a:effectRef>
+          <a:fontRef idx="minor">
+            <a:schemeClr val="lt1"/>
+          </a:fontRef>
+        </p:style>
+        <p:txBody>
+          <a:bodyPr rtlCol="0" anchor="ctr"/>
+          <a:lstStyle/>
+          <a:p>
+            <a:pPr algn="ctr"/>
+          </a:p>
+        </p:txBody>
+      </p:sp>
+      <p:sp>
+        <p:nvSpPr>
+          <p:cNvPr id="59" name="TextBox 58"/>
+          <p:cNvSpPr txBox="1"/>
+          <p:nvPr/>
+        </p:nvSpPr>
+        <p:spPr>
+          <a:xfrm>
+            <a:off x="9624059" y="4241800"/>
+            <a:ext cx="1894839" cy="736600"/>
+          </a:xfrm>
+          <a:prstGeom prst="rect">
+            <a:avLst/>
+          </a:prstGeom>
+          <a:noFill/>
+        </p:spPr>
+        <p:txBody>
+          <a:bodyPr wrap="square" anchor="ctr" lIns="25400" rIns="25400" tIns="25400" bIns="25400">
+            <a:normAutofit/>
+          </a:bodyPr>
+          <a:lstStyle/>
+          <a:p>
+            <a:pPr algn="ctr">
+              <a:spcAft>
+                <a:spcPts val="0"/>
+              </a:spcAft>
+            </a:pPr>
+            <a:r>
+              <a:rPr sz="800" b="0">
+                <a:solidFill>
+                  <a:srgbClr val="3A4A55"/>
+                </a:solidFill>
+                <a:latin typeface="Inter"/>
+              </a:rPr>
+              <a:t>Carryover is ad-hoc (email / WhatsApp)</a:t>
+            </a:r>
+          </a:p>
+        </p:txBody>
+      </p:sp>
+      <p:sp>
+        <p:nvSpPr>
+          <p:cNvPr id="60" name="TextBox 59"/>
+          <p:cNvSpPr txBox="1"/>
+          <p:nvPr/>
+        </p:nvSpPr>
+        <p:spPr>
+          <a:xfrm>
+            <a:off x="571500" y="5156200"/>
+            <a:ext cx="5715000" cy="152400"/>
+          </a:xfrm>
+          <a:prstGeom prst="rect">
+            <a:avLst/>
+          </a:prstGeom>
+          <a:noFill/>
+        </p:spPr>
+        <p:txBody>
+          <a:bodyPr wrap="square" anchor="t" lIns="25400" rIns="25400" tIns="25400" bIns="25400">
+            <a:spAutoFit/>
+          </a:bodyPr>
+          <a:lstStyle/>
+          <a:p>
+            <a:pPr algn="l">
+              <a:spcAft>
+                <a:spcPts val="0"/>
+              </a:spcAft>
+            </a:pPr>
+            <a:r>
+              <a:rPr sz="700" b="1">
+                <a:solidFill>
+                  <a:srgbClr val="8597A4"/>
+                </a:solidFill>
+                <a:latin typeface="Inter"/>
+              </a:rPr>
+              <a:t>TARGET OUTCOMES</a:t>
+            </a:r>
+          </a:p>
+        </p:txBody>
+      </p:sp>
+      <p:sp>
+        <p:nvSpPr>
+          <p:cNvPr id="61" name="Rounded Rectangle 60"/>
+          <p:cNvSpPr/>
+          <p:nvPr/>
+        </p:nvSpPr>
+        <p:spPr>
+          <a:xfrm>
+            <a:off x="584200" y="5359400"/>
+            <a:ext cx="571500" cy="31750"/>
+          </a:xfrm>
+          <a:prstGeom prst="roundRect">
+            <a:avLst>
+              <a:gd name="adj" fmla="val 40000"/>
+            </a:avLst>
           </a:prstGeom>
           <a:solidFill>
             <a:srgbClr val="F2A878"/>
@@ -6418,53 +6722,14 @@
       </p:sp>
       <p:sp>
         <p:nvSpPr>
-          <p:cNvPr id="54" name="TextBox 53"/>
+          <p:cNvPr id="62" name="TextBox 61"/>
           <p:cNvSpPr txBox="1"/>
           <p:nvPr/>
         </p:nvSpPr>
         <p:spPr>
           <a:xfrm>
-            <a:off x="9624059" y="4241800"/>
-            <a:ext cx="1894839" cy="736600"/>
-          </a:xfrm>
-          <a:prstGeom prst="rect">
-            <a:avLst/>
-          </a:prstGeom>
-          <a:noFill/>
-        </p:spPr>
-        <p:txBody>
-          <a:bodyPr wrap="square" anchor="ctr" lIns="25400" rIns="25400" tIns="25400" bIns="25400">
-            <a:normAutofit/>
-          </a:bodyPr>
-          <a:lstStyle/>
-          <a:p>
-            <a:pPr algn="ctr">
-              <a:spcAft>
-                <a:spcPts val="0"/>
-              </a:spcAft>
-            </a:pPr>
-            <a:r>
-              <a:rPr sz="800" b="0">
-                <a:solidFill>
-                  <a:srgbClr val="3A4A55"/>
-                </a:solidFill>
-                <a:latin typeface="Inter"/>
-              </a:rPr>
-              <a:t>Carryover is ad-hoc (email / WhatsApp)</a:t>
-            </a:r>
-          </a:p>
-        </p:txBody>
-      </p:sp>
-      <p:sp>
-        <p:nvSpPr>
-          <p:cNvPr id="55" name="TextBox 54"/>
-          <p:cNvSpPr txBox="1"/>
-          <p:nvPr/>
-        </p:nvSpPr>
-        <p:spPr>
-          <a:xfrm>
-            <a:off x="571500" y="5156200"/>
-            <a:ext cx="5715000" cy="152400"/>
+            <a:off x="571500" y="5448300"/>
+            <a:ext cx="5207000" cy="355600"/>
           </a:xfrm>
           <a:prstGeom prst="rect">
             <a:avLst/>
@@ -6483,26 +6748,65 @@
               </a:spcAft>
             </a:pPr>
             <a:r>
-              <a:rPr sz="700" b="1">
-                <a:solidFill>
-                  <a:srgbClr val="8597A4"/>
+              <a:rPr sz="2100" b="1">
+                <a:solidFill>
+                  <a:srgbClr val="2D6A6E"/>
                 </a:solidFill>
                 <a:latin typeface="Inter"/>
               </a:rPr>
-              <a:t>TARGET OUTCOMES</a:t>
-            </a:r>
-          </a:p>
-        </p:txBody>
-      </p:sp>
-      <p:sp>
-        <p:nvSpPr>
-          <p:cNvPr id="56" name="Rounded Rectangle 55"/>
+              <a:t>≥ 4 hours / month</a:t>
+            </a:r>
+          </a:p>
+        </p:txBody>
+      </p:sp>
+      <p:sp>
+        <p:nvSpPr>
+          <p:cNvPr id="63" name="TextBox 62"/>
+          <p:cNvSpPr txBox="1"/>
+          <p:nvPr/>
+        </p:nvSpPr>
+        <p:spPr>
+          <a:xfrm>
+            <a:off x="571500" y="5867400"/>
+            <a:ext cx="5207000" cy="190500"/>
+          </a:xfrm>
+          <a:prstGeom prst="rect">
+            <a:avLst/>
+          </a:prstGeom>
+          <a:noFill/>
+        </p:spPr>
+        <p:txBody>
+          <a:bodyPr wrap="square" anchor="t" lIns="25400" rIns="25400" tIns="25400" bIns="25400">
+            <a:spAutoFit/>
+          </a:bodyPr>
+          <a:lstStyle/>
+          <a:p>
+            <a:pPr algn="l">
+              <a:spcAft>
+                <a:spcPts val="0"/>
+              </a:spcAft>
+            </a:pPr>
+            <a:r>
+              <a:rPr sz="900" b="0">
+                <a:solidFill>
+                  <a:srgbClr val="4A5B6B"/>
+                </a:solidFill>
+                <a:latin typeface="Inter"/>
+              </a:rPr>
+              <a:t>productive hours given back to each clinician</a:t>
+            </a:r>
+          </a:p>
+        </p:txBody>
+      </p:sp>
+      <p:sp>
+        <p:nvSpPr>
+          <p:cNvPr id="64" name="Rounded Rectangle 63"/>
           <p:cNvSpPr/>
           <p:nvPr/>
         </p:nvSpPr>
         <p:spPr>
           <a:xfrm>
-            <a:off x="584200" y="5359400"/>
+            <a:off x="6362700" y="5359400"/>
             <a:ext cx="571500" cy="31750"/>
           </a:xfrm>
           <a:prstGeom prst="roundRect">
@@ -6542,13 +6846,13 @@
       </p:sp>
       <p:sp>
         <p:nvSpPr>
-          <p:cNvPr id="57" name="TextBox 56"/>
+          <p:cNvPr id="65" name="TextBox 64"/>
           <p:cNvSpPr txBox="1"/>
           <p:nvPr/>
         </p:nvSpPr>
         <p:spPr>
           <a:xfrm>
-            <a:off x="571500" y="5448300"/>
+            <a:off x="6350000" y="5448300"/>
             <a:ext cx="5207000" cy="355600"/>
           </a:xfrm>
           <a:prstGeom prst="rect">
@@ -6574,20 +6878,20 @@
                 </a:solidFill>
                 <a:latin typeface="Inter"/>
               </a:rPr>
-              <a:t>≥ 4 hours / month</a:t>
-            </a:r>
-          </a:p>
-        </p:txBody>
-      </p:sp>
-      <p:sp>
-        <p:nvSpPr>
-          <p:cNvPr id="58" name="TextBox 57"/>
+              <a:t>Same-day</a:t>
+            </a:r>
+          </a:p>
+        </p:txBody>
+      </p:sp>
+      <p:sp>
+        <p:nvSpPr>
+          <p:cNvPr id="66" name="TextBox 65"/>
           <p:cNvSpPr txBox="1"/>
           <p:nvPr/>
         </p:nvSpPr>
         <p:spPr>
           <a:xfrm>
-            <a:off x="571500" y="5867400"/>
+            <a:off x="6350000" y="5867400"/>
             <a:ext cx="5207000" cy="190500"/>
           </a:xfrm>
           <a:prstGeom prst="rect">
@@ -6613,67 +6917,21 @@
                 </a:solidFill>
                 <a:latin typeface="Inter"/>
               </a:rPr>
-              <a:t>productive hours given back to each clinician</a:t>
-            </a:r>
-          </a:p>
-        </p:txBody>
-      </p:sp>
-      <p:sp>
-        <p:nvSpPr>
-          <p:cNvPr id="59" name="Rounded Rectangle 58"/>
-          <p:cNvSpPr/>
-          <p:nvPr/>
-        </p:nvSpPr>
-        <p:spPr>
-          <a:xfrm>
-            <a:off x="6362700" y="5359400"/>
-            <a:ext cx="571500" cy="31750"/>
-          </a:xfrm>
-          <a:prstGeom prst="roundRect">
-            <a:avLst>
-              <a:gd name="adj" fmla="val 40000"/>
-            </a:avLst>
-          </a:prstGeom>
-          <a:solidFill>
-            <a:srgbClr val="F2A878"/>
-          </a:solidFill>
-          <a:ln>
-            <a:noFill/>
-          </a:ln>
-          <a:effectLst/>
-        </p:spPr>
-        <p:style>
-          <a:lnRef idx="1">
-            <a:schemeClr val="accent1"/>
-          </a:lnRef>
-          <a:fillRef idx="3">
-            <a:schemeClr val="accent1"/>
-          </a:fillRef>
-          <a:effectRef idx="2">
-            <a:schemeClr val="accent1"/>
-          </a:effectRef>
-          <a:fontRef idx="minor">
-            <a:schemeClr val="lt1"/>
-          </a:fontRef>
-        </p:style>
-        <p:txBody>
-          <a:bodyPr rtlCol="0" anchor="ctr"/>
-          <a:lstStyle/>
-          <a:p>
-            <a:pPr algn="ctr"/>
-          </a:p>
-        </p:txBody>
-      </p:sp>
-      <p:sp>
-        <p:nvSpPr>
-          <p:cNvPr id="60" name="TextBox 59"/>
+              <a:t>client summaries &amp; reports, vs the ~3-week manual baseline</a:t>
+            </a:r>
+          </a:p>
+        </p:txBody>
+      </p:sp>
+      <p:sp>
+        <p:nvSpPr>
+          <p:cNvPr id="67" name="TextBox 66"/>
           <p:cNvSpPr txBox="1"/>
           <p:nvPr/>
         </p:nvSpPr>
         <p:spPr>
           <a:xfrm>
-            <a:off x="6350000" y="5448300"/>
-            <a:ext cx="5207000" cy="355600"/>
+            <a:off x="571500" y="6604000"/>
+            <a:ext cx="5715000" cy="139700"/>
           </a:xfrm>
           <a:prstGeom prst="rect">
             <a:avLst/>
@@ -6692,84 +6950,6 @@
               </a:spcAft>
             </a:pPr>
             <a:r>
-              <a:rPr sz="2100" b="1">
-                <a:solidFill>
-                  <a:srgbClr val="2D6A6E"/>
-                </a:solidFill>
-                <a:latin typeface="Inter"/>
-              </a:rPr>
-              <a:t>Same-day</a:t>
-            </a:r>
-          </a:p>
-        </p:txBody>
-      </p:sp>
-      <p:sp>
-        <p:nvSpPr>
-          <p:cNvPr id="61" name="TextBox 60"/>
-          <p:cNvSpPr txBox="1"/>
-          <p:nvPr/>
-        </p:nvSpPr>
-        <p:spPr>
-          <a:xfrm>
-            <a:off x="6350000" y="5867400"/>
-            <a:ext cx="5207000" cy="190500"/>
-          </a:xfrm>
-          <a:prstGeom prst="rect">
-            <a:avLst/>
-          </a:prstGeom>
-          <a:noFill/>
-        </p:spPr>
-        <p:txBody>
-          <a:bodyPr wrap="square" anchor="t" lIns="25400" rIns="25400" tIns="25400" bIns="25400">
-            <a:spAutoFit/>
-          </a:bodyPr>
-          <a:lstStyle/>
-          <a:p>
-            <a:pPr algn="l">
-              <a:spcAft>
-                <a:spcPts val="0"/>
-              </a:spcAft>
-            </a:pPr>
-            <a:r>
-              <a:rPr sz="900" b="0">
-                <a:solidFill>
-                  <a:srgbClr val="4A5B6B"/>
-                </a:solidFill>
-                <a:latin typeface="Inter"/>
-              </a:rPr>
-              <a:t>client summaries &amp; reports, vs the ~3-week manual baseline</a:t>
-            </a:r>
-          </a:p>
-        </p:txBody>
-      </p:sp>
-      <p:sp>
-        <p:nvSpPr>
-          <p:cNvPr id="62" name="TextBox 61"/>
-          <p:cNvSpPr txBox="1"/>
-          <p:nvPr/>
-        </p:nvSpPr>
-        <p:spPr>
-          <a:xfrm>
-            <a:off x="571500" y="6604000"/>
-            <a:ext cx="5715000" cy="139700"/>
-          </a:xfrm>
-          <a:prstGeom prst="rect">
-            <a:avLst/>
-          </a:prstGeom>
-          <a:noFill/>
-        </p:spPr>
-        <p:txBody>
-          <a:bodyPr wrap="square" anchor="t" lIns="25400" rIns="25400" tIns="25400" bIns="25400">
-            <a:spAutoFit/>
-          </a:bodyPr>
-          <a:lstStyle/>
-          <a:p>
-            <a:pPr algn="l">
-              <a:spcAft>
-                <a:spcPts val="0"/>
-              </a:spcAft>
-            </a:pPr>
-            <a:r>
               <a:rPr sz="600" b="0">
                 <a:solidFill>
                   <a:srgbClr val="8597A4"/>
@@ -6783,7 +6963,7 @@
       </p:sp>
       <p:sp>
         <p:nvSpPr>
-          <p:cNvPr id="63" name="TextBox 62"/>
+          <p:cNvPr id="68" name="TextBox 67"/>
           <p:cNvSpPr txBox="1"/>
           <p:nvPr/>
         </p:nvSpPr>

</xml_diff>

<commit_message>
design: review fixes — rename to AI practice partner, drop kid-screen principle, UK spelling, fewer em-dashes
- Replace 'AI co-pilot' with 'AI practice partner' across board, deck and notes
- Remove 'No screen time for children' from Slide 1 anchor principles (now three)
- Standardise on UK spelling (paediatric, generalise, colour)
- Replace prose em-dashes with colons/semicolons/commas to read less AI-generated
- Regenerate PPTX + PDF

https://claude.ai/code/session_015v7JWiWTXQN2Qco9pisXZ1
</commit_message>
<xml_diff>
--- a/docs/design/Sona_Care_Journey_Deck.pptx
+++ b/docs/design/Sona_Care_Journey_Deck.pptx
@@ -3208,7 +3208,7 @@
                 </a:solidFill>
                 <a:latin typeface="Inter"/>
               </a:rPr>
-              <a:t>Sona — Care Journey &amp; Product Overview</a:t>
+              <a:t>Sona: Care Journey &amp; Product Overview</a:t>
             </a:r>
           </a:p>
         </p:txBody>
@@ -3247,7 +3247,7 @@
                 </a:solidFill>
                 <a:latin typeface="Inter"/>
               </a:rPr>
-              <a:t>An AI co-pilot that reduces admin burnout in UK private Speech &amp; Language Therapy (SLT) — giving clinicians more productive time for care across a client's first 30 days.</a:t>
+              <a:t>An AI practice partner that reduces admin burnout in UK private Speech &amp; Language Therapy (SLT), giving clinicians more productive time for care across a client's first 30 days.</a:t>
             </a:r>
           </a:p>
         </p:txBody>
@@ -3371,7 +3371,7 @@
                 </a:solidFill>
                 <a:latin typeface="Inter"/>
               </a:rPr>
-              <a:t>Sona is an AI co-pilot for UK private Speech &amp; Language Therapy (SLT) practices.</a:t>
+              <a:t>Sona is an AI practice partner for UK private Speech &amp; Language Therapy (SLT).</a:t>
             </a:r>
           </a:p>
           <a:p>
@@ -3390,7 +3390,7 @@
                 </a:solidFill>
                 <a:latin typeface="Inter"/>
               </a:rPr>
-              <a:t>It does the repetitive admin alongside the clinician — capturing the enquiry, smart intake, consult prep, the triage decision, the first session plan and the family summary, always as drafts for the clinician to review.</a:t>
+              <a:t>It does the repetitive admin alongside the clinician: intake, consult prep, triage, the first session plan and family summary, all as drafts the clinician reviews.</a:t>
             </a:r>
           </a:p>
           <a:p>
@@ -3409,7 +3409,7 @@
                 </a:solidFill>
                 <a:latin typeface="Inter"/>
               </a:rPr>
-              <a:t>Sona augments clinicians — it increases human productivity: less admin burnout, more time for care.</a:t>
+              <a:t>Sona augments clinicians; it increases human productivity: less admin burnout, more time for care.</a:t>
             </a:r>
           </a:p>
         </p:txBody>
@@ -3575,7 +3575,7 @@
                 </a:solidFill>
                 <a:latin typeface="Inter"/>
               </a:rPr>
-              <a:t>  —  the journey &amp; the value</a:t>
+              <a:t>:  the journey &amp; the value</a:t>
             </a:r>
           </a:p>
         </p:txBody>
@@ -3619,7 +3619,7 @@
                 </a:solidFill>
                 <a:latin typeface="Inter"/>
               </a:rPr>
-              <a:t>  —  the proposed solution</a:t>
+              <a:t>:  the proposed solution</a:t>
             </a:r>
           </a:p>
         </p:txBody>
@@ -3663,7 +3663,7 @@
                 </a:solidFill>
                 <a:latin typeface="Inter"/>
               </a:rPr>
-              <a:t>  —  the To-Be swimlane</a:t>
+              <a:t>:  the To-Be swimlane</a:t>
             </a:r>
           </a:p>
         </p:txBody>
@@ -3741,8 +3741,8 @@
                 </a:solidFill>
                 <a:latin typeface="Inter"/>
               </a:rPr>
-              <a:t>client / parent / carer — the family or adult client
-clinician / SLT — the therapist    ·    practice — the private clinic</a:t>
+              <a:t>client / parent / carer: the family or adult client
+clinician / SLT: the therapist    ·    practice: the private clinic</a:t>
             </a:r>
           </a:p>
         </p:txBody>
@@ -3840,8 +3840,8 @@
         </p:nvSpPr>
         <p:spPr>
           <a:xfrm>
-            <a:off x="838200" y="6273800"/>
-            <a:ext cx="2730500" cy="254000"/>
+            <a:off x="889000" y="6273800"/>
+            <a:ext cx="3302000" cy="254000"/>
           </a:xfrm>
           <a:prstGeom prst="rect">
             <a:avLst/>
@@ -3879,8 +3879,8 @@
         </p:nvSpPr>
         <p:spPr>
           <a:xfrm>
-            <a:off x="3568700" y="6273800"/>
-            <a:ext cx="2730500" cy="254000"/>
+            <a:off x="4527550" y="6273800"/>
+            <a:ext cx="3302000" cy="254000"/>
           </a:xfrm>
           <a:prstGeom prst="rect">
             <a:avLst/>
@@ -3905,7 +3905,7 @@
                 </a:solidFill>
                 <a:latin typeface="Inter"/>
               </a:rPr>
-              <a:t>No screen time for children</a:t>
+              <a:t>UK data residency + audit</a:t>
             </a:r>
           </a:p>
         </p:txBody>
@@ -3918,8 +3918,8 @@
         </p:nvSpPr>
         <p:spPr>
           <a:xfrm>
-            <a:off x="6299200" y="6273800"/>
-            <a:ext cx="2730500" cy="254000"/>
+            <a:off x="8172450" y="6273800"/>
+            <a:ext cx="3302000" cy="254000"/>
           </a:xfrm>
           <a:prstGeom prst="rect">
             <a:avLst/>
@@ -3944,45 +3944,6 @@
                 </a:solidFill>
                 <a:latin typeface="Inter"/>
               </a:rPr>
-              <a:t>UK data residency + audit</a:t>
-            </a:r>
-          </a:p>
-        </p:txBody>
-      </p:sp>
-      <p:sp>
-        <p:nvSpPr>
-          <p:cNvPr id="22" name="TextBox 21"/>
-          <p:cNvSpPr txBox="1"/>
-          <p:nvPr/>
-        </p:nvSpPr>
-        <p:spPr>
-          <a:xfrm>
-            <a:off x="8902700" y="6273800"/>
-            <a:ext cx="2730500" cy="254000"/>
-          </a:xfrm>
-          <a:prstGeom prst="rect">
-            <a:avLst/>
-          </a:prstGeom>
-          <a:noFill/>
-        </p:spPr>
-        <p:txBody>
-          <a:bodyPr wrap="square" anchor="t" lIns="25400" rIns="25400" tIns="25400" bIns="25400">
-            <a:spAutoFit/>
-          </a:bodyPr>
-          <a:lstStyle/>
-          <a:p>
-            <a:pPr algn="l">
-              <a:spcAft>
-                <a:spcPts val="0"/>
-              </a:spcAft>
-            </a:pPr>
-            <a:r>
-              <a:rPr sz="1300" b="0">
-                <a:solidFill>
-                  <a:srgbClr val="1E4A4D"/>
-                </a:solidFill>
-                <a:latin typeface="Inter"/>
-              </a:rPr>
               <a:t>Augment people, never replace</a:t>
             </a:r>
           </a:p>
@@ -3990,13 +3951,13 @@
       </p:sp>
       <p:sp>
         <p:nvSpPr>
-          <p:cNvPr id="23" name="Rectangle 22"/>
+          <p:cNvPr id="22" name="Rectangle 21"/>
           <p:cNvSpPr/>
           <p:nvPr/>
         </p:nvSpPr>
         <p:spPr>
           <a:xfrm>
-            <a:off x="3467100" y="6235700"/>
+            <a:off x="4273550" y="6235700"/>
             <a:ext cx="6350" cy="330200"/>
           </a:xfrm>
           <a:prstGeom prst="rect">
@@ -4034,13 +3995,13 @@
       </p:sp>
       <p:sp>
         <p:nvSpPr>
-          <p:cNvPr id="24" name="Rectangle 23"/>
+          <p:cNvPr id="23" name="Rectangle 22"/>
           <p:cNvSpPr/>
           <p:nvPr/>
         </p:nvSpPr>
         <p:spPr>
           <a:xfrm>
-            <a:off x="6197600" y="6235700"/>
+            <a:off x="7918449" y="6235700"/>
             <a:ext cx="6350" cy="330200"/>
           </a:xfrm>
           <a:prstGeom prst="rect">
@@ -4078,51 +4039,7 @@
       </p:sp>
       <p:sp>
         <p:nvSpPr>
-          <p:cNvPr id="25" name="Rectangle 24"/>
-          <p:cNvSpPr/>
-          <p:nvPr/>
-        </p:nvSpPr>
-        <p:spPr>
-          <a:xfrm>
-            <a:off x="8801100" y="6235700"/>
-            <a:ext cx="6350" cy="330200"/>
-          </a:xfrm>
-          <a:prstGeom prst="rect">
-            <a:avLst/>
-          </a:prstGeom>
-          <a:solidFill>
-            <a:srgbClr val="E5E7EB"/>
-          </a:solidFill>
-          <a:ln>
-            <a:noFill/>
-          </a:ln>
-          <a:effectLst/>
-        </p:spPr>
-        <p:style>
-          <a:lnRef idx="1">
-            <a:schemeClr val="accent1"/>
-          </a:lnRef>
-          <a:fillRef idx="3">
-            <a:schemeClr val="accent1"/>
-          </a:fillRef>
-          <a:effectRef idx="2">
-            <a:schemeClr val="accent1"/>
-          </a:effectRef>
-          <a:fontRef idx="minor">
-            <a:schemeClr val="lt1"/>
-          </a:fontRef>
-        </p:style>
-        <p:txBody>
-          <a:bodyPr rtlCol="0" anchor="ctr"/>
-          <a:lstStyle/>
-          <a:p>
-            <a:pPr algn="ctr"/>
-          </a:p>
-        </p:txBody>
-      </p:sp>
-      <p:sp>
-        <p:nvSpPr>
-          <p:cNvPr id="26" name="TextBox 25"/>
+          <p:cNvPr id="24" name="TextBox 23"/>
           <p:cNvSpPr txBox="1"/>
           <p:nvPr/>
         </p:nvSpPr>
@@ -4149,14 +4066,14 @@
                 </a:solidFill>
                 <a:latin typeface="Inter"/>
               </a:rPr>
-              <a:t>Sona — Care Journey &amp; Product Overview</a:t>
-            </a:r>
-          </a:p>
-        </p:txBody>
-      </p:sp>
-      <p:sp>
-        <p:nvSpPr>
-          <p:cNvPr id="27" name="TextBox 26"/>
+              <a:t>Sona: Care Journey &amp; Product Overview</a:t>
+            </a:r>
+          </a:p>
+        </p:txBody>
+      </p:sp>
+      <p:sp>
+        <p:nvSpPr>
+          <p:cNvPr id="25" name="TextBox 24"/>
           <p:cNvSpPr txBox="1"/>
           <p:nvPr/>
         </p:nvSpPr>
@@ -4363,7 +4280,7 @@
                 </a:solidFill>
                 <a:latin typeface="Inter"/>
               </a:rPr>
-              <a:t>How a new SLT case feels today, and where Sona reduces admin burnout and adds value — across five phases.</a:t>
+              <a:t>How a new SLT case feels today, and where Sona reduces admin burnout and adds value across five phases.</a:t>
             </a:r>
           </a:p>
         </p:txBody>
@@ -5966,7 +5883,7 @@
                 </a:solidFill>
                 <a:latin typeface="Inter"/>
               </a:rPr>
-              <a:t>TODAY'S PAIN — BY PHASE</a:t>
+              <a:t>TODAY'S PAIN · BY PHASE</a:t>
             </a:r>
           </a:p>
         </p:txBody>
@@ -6228,7 +6145,7 @@
                 </a:solidFill>
                 <a:latin typeface="Inter"/>
               </a:rPr>
-              <a:t>Chasing forms — everything is manual</a:t>
+              <a:t>Chasing forms; everything is manual</a:t>
             </a:r>
           </a:p>
         </p:txBody>
@@ -6942,7 +6859,7 @@
                 </a:solidFill>
                 <a:latin typeface="Inter"/>
               </a:rPr>
-              <a:t>Sona — Care Journey &amp; Product Overview</a:t>
+              <a:t>Sona: Care Journey &amp; Product Overview</a:t>
             </a:r>
           </a:p>
         </p:txBody>
@@ -7156,7 +7073,7 @@
                 </a:solidFill>
                 <a:latin typeface="Inter"/>
               </a:rPr>
-              <a:t>The first 30 days as nine stages grouped into five phases — what Sona does, and the surface that delivers it.</a:t>
+              <a:t>The first 30 days as nine stages grouped into five phases: what Sona does, and the surface that delivers it.</a:t>
             </a:r>
           </a:p>
         </p:txBody>
@@ -10243,7 +10160,7 @@
                 </a:solidFill>
                 <a:latin typeface="Inter"/>
               </a:rPr>
-              <a:t>Trust is the moat — clinician signs every draft</a:t>
+              <a:t>Trust is the moat; clinician signs every draft</a:t>
             </a:r>
           </a:p>
         </p:txBody>
@@ -10452,7 +10369,7 @@
                 </a:solidFill>
                 <a:latin typeface="Inter"/>
               </a:rPr>
-              <a:t>Colour groups the nine stages into their five phases.   ·   Generalized across SLTs (Pediatric &amp; Adult).</a:t>
+              <a:t>Colour groups the nine stages into their five phases.   ·   Generalised across SLTs (Paediatric &amp; Adult).</a:t>
             </a:r>
           </a:p>
         </p:txBody>
@@ -10486,7 +10403,7 @@
                 </a:solidFill>
                 <a:latin typeface="Inter"/>
               </a:rPr>
-              <a:t>Sona — Care Journey &amp; Product Overview</a:t>
+              <a:t>Sona: Care Journey &amp; Product Overview</a:t>
             </a:r>
           </a:p>
         </p:txBody>
@@ -10700,7 +10617,7 @@
                 </a:solidFill>
                 <a:latin typeface="Inter"/>
               </a:rPr>
-              <a:t>A swimlane map of the proposed (To-Be) process — the basis for prototypes and screens.</a:t>
+              <a:t>A swimlane map of the proposed (To-Be) process: the basis for prototypes and screens.</a:t>
             </a:r>
           </a:p>
         </p:txBody>
@@ -13421,7 +13338,7 @@
                 </a:solidFill>
                 <a:latin typeface="Inter"/>
               </a:rPr>
-              <a:t>Sona — Care Journey &amp; Product Overview</a:t>
+              <a:t>Sona: Care Journey &amp; Product Overview</a:t>
             </a:r>
           </a:p>
         </p:txBody>

</xml_diff>

<commit_message>
design: punctuation pass (Truss-proof)
Fix a comma splice (AI drafts; clinician decides), semicolons that joined
non-clauses, double spaces, 'ad-hoc' -> 'ad hoc', 'vs' -> 'versus', an arrow in
prose, slash-heavy glossary, and 'artifact' -> 'artefact' (UK). Regenerate
PPTX + PDF; board updated to match.

https://claude.ai/code/session_015v7JWiWTXQN2Qco9pisXZ1
</commit_message>
<xml_diff>
--- a/docs/design/Sona_Care_Journey_Deck.pptx
+++ b/docs/design/Sona_Care_Journey_Deck.pptx
@@ -3247,7 +3247,7 @@
                 </a:solidFill>
                 <a:latin typeface="Inter"/>
               </a:rPr>
-              <a:t>An AI practice partner that reduces admin burnout in UK private Speech &amp; Language Therapy (SLT), giving clinicians more productive time for care across a client's first 30 days.</a:t>
+              <a:t>An AI practice partner that reduces admin burnout in UK private Speech and Language Therapy (SLT), giving clinicians more productive time for care across a client's first 30 days.</a:t>
             </a:r>
           </a:p>
         </p:txBody>
@@ -3371,7 +3371,7 @@
                 </a:solidFill>
                 <a:latin typeface="Inter"/>
               </a:rPr>
-              <a:t>Sona is an AI practice partner for UK private Speech &amp; Language Therapy (SLT).</a:t>
+              <a:t>Sona is an AI practice partner for UK private Speech and Language Therapy (SLT).</a:t>
             </a:r>
           </a:p>
           <a:p>
@@ -3531,7 +3531,7 @@
                 </a:solidFill>
                 <a:latin typeface="Inter"/>
               </a:rPr>
-              <a:t>Three views, read left → right:</a:t>
+              <a:t>Three views, read left to right:</a:t>
             </a:r>
           </a:p>
         </p:txBody>
@@ -3575,7 +3575,7 @@
                 </a:solidFill>
                 <a:latin typeface="Inter"/>
               </a:rPr>
-              <a:t>:  the journey &amp; the value</a:t>
+              <a:t>: the journey and the value</a:t>
             </a:r>
           </a:p>
         </p:txBody>
@@ -3619,7 +3619,7 @@
                 </a:solidFill>
                 <a:latin typeface="Inter"/>
               </a:rPr>
-              <a:t>:  the proposed solution</a:t>
+              <a:t>: the proposed solution</a:t>
             </a:r>
           </a:p>
         </p:txBody>
@@ -3663,7 +3663,7 @@
                 </a:solidFill>
                 <a:latin typeface="Inter"/>
               </a:rPr>
-              <a:t>:  the To-Be swimlane</a:t>
+              <a:t>: the To-Be swimlane</a:t>
             </a:r>
           </a:p>
         </p:txBody>
@@ -3741,8 +3741,8 @@
                 </a:solidFill>
                 <a:latin typeface="Inter"/>
               </a:rPr>
-              <a:t>client / parent / carer: the family or adult client
-clinician / SLT: the therapist    ·    practice: the private clinic</a:t>
+              <a:t>Client, parent or carer: the family or the adult client.
+Clinician (SLT): the therapist. Practice: the private clinic.</a:t>
             </a:r>
           </a:p>
         </p:txBody>
@@ -3866,7 +3866,7 @@
                 </a:solidFill>
                 <a:latin typeface="Inter"/>
               </a:rPr>
-              <a:t>AI drafts, clinician decides</a:t>
+              <a:t>AI drafts; clinician decides</a:t>
             </a:r>
           </a:p>
         </p:txBody>
@@ -3944,7 +3944,7 @@
                 </a:solidFill>
                 <a:latin typeface="Inter"/>
               </a:rPr>
-              <a:t>Augment people, never replace</a:t>
+              <a:t>Augment people, never replace them</a:t>
             </a:r>
           </a:p>
         </p:txBody>
@@ -4790,7 +4790,7 @@
                 </a:solidFill>
                 <a:latin typeface="Inter"/>
               </a:rPr>
-              <a:t>HOW EACH PHASE FEELS  ·  one point per phase, family + clinician</a:t>
+              <a:t>HOW EACH PHASE FEELS · one point per phase, family and clinician</a:t>
             </a:r>
           </a:p>
         </p:txBody>
@@ -5844,7 +5844,7 @@
                 </a:solidFill>
                 <a:latin typeface="Inter"/>
               </a:rPr>
-              <a:t>confident &amp; in control</a:t>
+              <a:t>confident and in control</a:t>
             </a:r>
           </a:p>
         </p:txBody>
@@ -6145,7 +6145,7 @@
                 </a:solidFill>
                 <a:latin typeface="Inter"/>
               </a:rPr>
-              <a:t>Chasing forms; everything is manual</a:t>
+              <a:t>Chasing families to finish the form</a:t>
             </a:r>
           </a:p>
         </p:txBody>
@@ -6407,7 +6407,7 @@
                 </a:solidFill>
                 <a:latin typeface="Inter"/>
               </a:rPr>
-              <a:t>Plans hand-built; reports take ~3 weeks</a:t>
+              <a:t>Plans are hand-built; reports take ~3 weeks</a:t>
             </a:r>
           </a:p>
         </p:txBody>
@@ -6538,7 +6538,7 @@
                 </a:solidFill>
                 <a:latin typeface="Inter"/>
               </a:rPr>
-              <a:t>Carryover is ad-hoc (email / WhatsApp)</a:t>
+              <a:t>Carryover is ad hoc (email or WhatsApp)</a:t>
             </a:r>
           </a:p>
         </p:txBody>
@@ -6662,7 +6662,7 @@
                 </a:solidFill>
                 <a:latin typeface="Inter"/>
               </a:rPr>
-              <a:t>≥ 4 hours / month</a:t>
+              <a:t>≥ 4 hours a month</a:t>
             </a:r>
           </a:p>
         </p:txBody>
@@ -6825,7 +6825,7 @@
                 </a:solidFill>
                 <a:latin typeface="Inter"/>
               </a:rPr>
-              <a:t>client summaries &amp; reports, vs the ~3-week manual baseline</a:t>
+              <a:t>client summaries and reports, versus the ~3-week manual baseline</a:t>
             </a:r>
           </a:p>
         </p:txBody>
@@ -7073,7 +7073,7 @@
                 </a:solidFill>
                 <a:latin typeface="Inter"/>
               </a:rPr>
-              <a:t>The first 30 days as nine stages grouped into five phases: what Sona does, and the surface that delivers it.</a:t>
+              <a:t>The first 30 days as nine stages grouped into five phases: what Sona does and the surface that delivers it.</a:t>
             </a:r>
           </a:p>
         </p:txBody>
@@ -8166,7 +8166,7 @@
                 </a:solidFill>
                 <a:latin typeface="Inter"/>
               </a:rPr>
-              <a:t>Family / client app</a:t>
+              <a:t>Family or client app</a:t>
             </a:r>
           </a:p>
         </p:txBody>
@@ -8846,7 +8846,7 @@
                 </a:solidFill>
                 <a:latin typeface="Inter"/>
               </a:rPr>
-              <a:t>Schedule consult + calendar / video</a:t>
+              <a:t>Schedule consult (calendar, video)</a:t>
             </a:r>
           </a:p>
         </p:txBody>
@@ -10160,7 +10160,7 @@
                 </a:solidFill>
                 <a:latin typeface="Inter"/>
               </a:rPr>
-              <a:t>Trust is the moat; clinician signs every draft</a:t>
+              <a:t>Trust is the moat; the clinician signs every draft</a:t>
             </a:r>
           </a:p>
         </p:txBody>
@@ -10369,7 +10369,7 @@
                 </a:solidFill>
                 <a:latin typeface="Inter"/>
               </a:rPr>
-              <a:t>Colour groups the nine stages into their five phases.   ·   Generalised across SLTs (Paediatric &amp; Adult).</a:t>
+              <a:t>Colour groups the nine stages into their five phases. · Generalised across SLTs (paediatric and adult).</a:t>
             </a:r>
           </a:p>
         </p:txBody>
@@ -10992,7 +10992,7 @@
                 </a:solidFill>
                 <a:latin typeface="Inter"/>
               </a:rPr>
-              <a:t>Sona  (app &amp; AI)</a:t>
+              <a:t>Sona (app &amp; AI)</a:t>
             </a:r>
           </a:p>
         </p:txBody>
@@ -11117,7 +11117,7 @@
                 </a:solidFill>
                 <a:latin typeface="Inter"/>
               </a:rPr>
-              <a:t>External  (calendar · PMS)</a:t>
+              <a:t>External (calendar and PMS)</a:t>
             </a:r>
           </a:p>
         </p:txBody>
@@ -12479,7 +12479,7 @@
                 </a:solidFill>
                 <a:latin typeface="Inter"/>
               </a:rPr>
-              <a:t>Calendar / video link</a:t>
+              <a:t>Calendar and video link</a:t>
             </a:r>
           </a:p>
         </p:txBody>
@@ -13304,7 +13304,7 @@
                 </a:solidFill>
                 <a:latin typeface="Inter"/>
               </a:rPr>
-              <a:t>Shapes:  rounded = task   ·   diamond = decision   ·   pill = start / end.    DRAFT = AI artifact the clinician reviews &amp; signs.</a:t>
+              <a:t>Shapes: rounded = task · diamond = decision · pill = start or end. DRAFT = AI artefact the clinician reviews and signs.</a:t>
             </a:r>
           </a:p>
         </p:txBody>

</xml_diff>